<commit_message>
docs: reescribe README.md contra el checklist de entrega y corrige cifras de la presentacion
README.md era en gran parte el documento de diseno inicial del proyecto
(llegaba a decir "Fase actual: Diseno del sistema"). Anadidas las
secciones de Instalacion y Ejecucion y Usuario/contrasena de prueba
(ausentes por completo), y corregidas estructura, stack tecnologico y
funcionalidades principales contra el codigo real (login/registro/
invitado/logout, estadisticas, RAG).

Hallazgo colateral al verificar el recuento de ADR: la presentacion del
TFM decia "18/18 ADR en estado Aceptado" cuando el recuento real es
14/14 (ADR-007 a ADR-011 nunca se crearon, paquete de seguridad
descartado). Corregido en TFM_Presentacion.pptx y su documento de
contenido, junto con "7/7 User Stories" (misma frase, mismo tipo de
desfase) actualizado a 10/10 (US-001 a US-010).

Co-Authored-By: Claude Sonnet 5 <noreply@anthropic.com>
</commit_message>
<xml_diff>
--- a/docs/TFM_Presentacion.pptx
+++ b/docs/TFM_Presentacion.pptx
@@ -22,9 +22,12 @@
     <p:sldId id="270" r:id="rId16"/>
     <p:sldId id="271" r:id="rId17"/>
     <p:sldId id="272" r:id="rId18"/>
+    <p:sldId id="273" r:id="rId19"/>
+    <p:sldId id="274" r:id="rId20"/>
+    <p:sldId id="275" r:id="rId21"/>
   </p:sldIdLst>
   <p:notesMasterIdLst>
-    <p:notesMasterId r:id="rId19"/>
+    <p:notesMasterId r:id="rId22"/>
   </p:notesMasterIdLst>
   <p:sldSz cx="12191695" cy="6858000"/>
   <p:notesSz cx="6858000" cy="12191695"/>
@@ -606,7 +609,7 @@
           <a:p>
             <a:r>
               <a:rPr lang="en-US" dirty="0"/>
-              <a:t>ADR-004 formaliza lo que estaba disperso. No modelar ExercisePool como entidad evita duplicar el mismo dato (difficulty) en dos sitios sincronizados. La invariante de type coincidente parece obvia sobre el papel, pero no se aplicaba en el código real hasta el incidente #62 (slide 15) — ejemplo directo de la brecha entre "documentado" e "implementado".</a:t>
+              <a:t>ADR-004 formaliza lo que estaba disperso. No modelar ExercisePool como entidad evita duplicar el mismo dato (difficulty) en dos sitios sincronizados. La invariante de type coincidente parece obvia sobre el papel, pero no se aplicaba en el código real hasta el incidente #62 (slide 17) — ejemplo directo de la brecha entre "documentado" e "implementado".</a:t>
             </a:r>
             <a:endParaRPr lang="en-US" dirty="0"/>
           </a:p>
@@ -870,7 +873,7 @@
           <a:p>
             <a:r>
               <a:rPr lang="en-US" dirty="0"/>
-              <a:t>Slide de impacto argumental número 1. El fallo no fue de diseño — el flujo estaba bien pensado. El fallo fue que no existía ningún punto de control mecánico que impidiera saltárselo. Lección explícita del proyecto: la solución no fue "tener más cuidado", fue cambiar el proceso para que saltarse un paso sea visible y bloqueante.</a:t>
+              <a:t>Antes de ver qué falló, quiero dejar claro qué reglas aplican a todos los agentes por igual, sin excepción de rol. La más importante para mí es la primera: si hay conflicto entre lo que dice un ADR y lo que pide un prompt puntual, gana el ADR, siempre. Suena obvio, pero es justo la regla que evita que un agente "convenza" al sistema de saltarse una decisión ya tomada. La TDD Enforcement Rule tampoco es un checklist de calidad — forma parte de la arquitectura del sistema, no del proceso: no hay implementación sin test antes. Y la regla de reutilización se verifica con un grep antes de crear nada nuevo, no de memoria.</a:t>
             </a:r>
             <a:endParaRPr lang="en-US" dirty="0"/>
           </a:p>
@@ -958,7 +961,7 @@
           <a:p>
             <a:r>
               <a:rPr lang="en-US" dirty="0"/>
-              <a:t>Las skills del sistema siempre definieron secciones "KPIs" — pero ninguna se medía, porque la trazabilidad era prosa libre no consultable. Paso de gobernanza descrita a gobernanza instrumentada. La migración fue retroactiva a propósito, sobre toda la historia del proyecto, para tener un baseline de KPIs desde el día 1.</a:t>
+              <a:t>Slide de impacto argumental número 1. El fallo no fue de diseño — el flujo estaba bien pensado. El fallo fue que no existía ningún punto de control mecánico que impidiera saltárselo. Lección explícita del proyecto: la solución no fue "tener más cuidado", fue cambiar el proceso para que saltarse un paso sea visible y bloqueante.</a:t>
             </a:r>
             <a:endParaRPr lang="en-US" dirty="0"/>
           </a:p>
@@ -1046,7 +1049,7 @@
           <a:p>
             <a:r>
               <a:rPr lang="en-US" dirty="0"/>
-              <a:t>Slide central de la defensa. Incluso después de introducir el Contrato de Handoff, el flujo obligatorio de 7 fases no se cumplió completo en ninguna tarea real del proyecto. Reviewer sigue siendo el eslabón más débil. Lectura honesta: esto no es un fracaso del sistema — es la prueba de que medir en vez de solo describir permite saber esto con certeza.</a:t>
+              <a:t>Las skills del sistema siempre definieron secciones "KPIs" — pero ninguna se medía, porque la trazabilidad era prosa libre no consultable. Paso de gobernanza descrita a gobernanza instrumentada. La migración fue retroactiva a propósito, sobre toda la historia del proyecto, para tener un baseline de KPIs desde el día 1.</a:t>
             </a:r>
             <a:endParaRPr lang="en-US" dirty="0"/>
           </a:p>
@@ -1134,7 +1137,7 @@
           <a:p>
             <a:r>
               <a:rPr lang="en-US" dirty="0"/>
-              <a:t>Cuatro categorías a propósito: seguridad, lógica de negocio, integración con IA generativa e infraestructura real de nube. Patrón común: los huecos de diseño se revelan al construir el siguiente consumidor real, no en la fase de diseño — varios se diagnosticaron verificando primero con herramientas externas (curl, la propia API de GitHub Actions) antes de tocar código.</a:t>
+              <a:t>Slide central de la defensa. Incluso después de introducir el Contrato de Handoff, el flujo obligatorio de 7 fases no se cumplió completo en ninguna tarea real del proyecto. Reviewer sigue siendo el eslabón más débil. Lectura honesta: esto no es un fracaso del sistema — es la prueba de que medir en vez de solo describir permite saber esto con certeza.</a:t>
             </a:r>
             <a:endParaRPr lang="en-US" dirty="0"/>
           </a:p>
@@ -1222,7 +1225,7 @@
           <a:p>
             <a:r>
               <a:rPr lang="en-US" dirty="0"/>
-              <a:t>Cierre con las dos caras del TFM a la vez: el producto se puede usar de principio a fin hoy mismo, y el proceso que lo construyó queda documentado con evidencia medible, no solo con buenas intenciones. Los errores documentados no son un fracaso — son el material de evidencia principal. Abrir turno de preguntas.</a:t>
+              <a:t>Cuatro categorías a propósito: seguridad, lógica de negocio, integración con IA generativa e infraestructura real de nube. Patrón común: los huecos de diseño se revelan al construir el siguiente consumidor real, no en la fase de diseño — varios se diagnosticaron verificando primero con herramientas externas (curl, la propia API de GitHub Actions) antes de tocar código.</a:t>
             </a:r>
             <a:endParaRPr lang="en-US" dirty="0"/>
           </a:p>
@@ -1246,6 +1249,182 @@
             <a:fld id="{F7021451-1387-4CA6-816F-3879F97B5CBC}" type="slidenum">
               <a:rPr lang="en-US"/>
               <a:t>17</a:t>
+            </a:fld>
+            <a:endParaRPr lang="en-US"/>
+          </a:p>
+        </p:txBody>
+      </p:sp>
+    </p:spTree>
+    <p:extLst>
+      <p:ext uri="{BB962C8B-B14F-4D97-AF65-F5344CB8AC3E}">
+        <p14:creationId xmlns:p14="http://schemas.microsoft.com/office/powerpoint/2010/main" val="1024086991"/>
+      </p:ext>
+    </p:extLst>
+  </p:cSld>
+  <p:clrMapOvr>
+    <a:masterClrMapping/>
+  </p:clrMapOvr>
+</p:notes>
+</file>
+
+<file path=ppt/notesSlides/notesSlide18.xml><?xml version="1.0" encoding="utf-8"?>
+<p:notes xmlns:a="http://schemas.openxmlformats.org/drawingml/2006/main" xmlns:r="http://schemas.openxmlformats.org/officeDocument/2006/relationships" xmlns:p="http://schemas.openxmlformats.org/presentationml/2006/main">
+  <p:cSld>
+    <p:spTree>
+      <p:nvGrpSpPr>
+        <p:cNvPr id="1" name=""/>
+        <p:cNvGrpSpPr/>
+        <p:nvPr/>
+      </p:nvGrpSpPr>
+      <p:grpSpPr>
+        <a:xfrm>
+          <a:off x="0" y="0"/>
+          <a:ext cx="0" cy="0"/>
+          <a:chOff x="0" y="0"/>
+          <a:chExt cx="0" cy="0"/>
+        </a:xfrm>
+      </p:grpSpPr>
+      <p:sp>
+        <p:nvSpPr>
+          <p:cNvPr id="2" name="Slide Image Placeholder 1"/>
+          <p:cNvSpPr>
+            <a:spLocks noGrp="1" noRot="1" noChangeAspect="1"/>
+          </p:cNvSpPr>
+          <p:nvPr>
+            <p:ph type="sldImg"/>
+          </p:nvPr>
+        </p:nvSpPr>
+        <p:spPr/>
+      </p:sp>
+      <p:sp>
+        <p:nvSpPr>
+          <p:cNvPr id="3" name="Notes Placeholder 2"/>
+          <p:cNvSpPr>
+            <a:spLocks noGrp="1"/>
+          </p:cNvSpPr>
+          <p:nvPr>
+            <p:ph type="body" idx="1"/>
+          </p:nvPr>
+        </p:nvSpPr>
+        <p:spPr/>
+        <p:txBody>
+          <a:bodyPr/>
+          <a:lstStyle/>
+          <a:p>
+            <a:r>
+              <a:rPr lang="en-US" dirty="0"/>
+              <a:t>No todo en este proyecto fue corregir errores, y quiero dedicar una diapositiva a lo que funcionó bien desde el principio. Para mí la más importante es la primera: los ADR nunca se reescriben, se enmiendan con fecha, así que el razonamiento original queda como evidencia aunque nos equivocáramos después. Destaco también la validación de Zod en el borde de los contratos de IA — no confiamos en que el LLM responda exactamente lo que le pedimos, lo comprobamos antes de usarlo, y eso evitó un incidente real que ya hemos visto. Y cuando una decisión previa dejó de tener sentido, como Chroma o el paquete de 5 ADR de seguridad, se cambió y se documentó por qué — nunca en silencio.</a:t>
+            </a:r>
+            <a:endParaRPr lang="en-US" dirty="0"/>
+          </a:p>
+        </p:txBody>
+      </p:sp>
+      <p:sp>
+        <p:nvSpPr>
+          <p:cNvPr id="4" name="Slide Number Placeholder 3"/>
+          <p:cNvSpPr>
+            <a:spLocks noGrp="1"/>
+          </p:cNvSpPr>
+          <p:nvPr>
+            <p:ph type="sldNum" sz="quarter" idx="10"/>
+          </p:nvPr>
+        </p:nvSpPr>
+        <p:spPr/>
+        <p:txBody>
+          <a:bodyPr/>
+          <a:lstStyle/>
+          <a:p>
+            <a:fld id="{F7021451-1387-4CA6-816F-3879F97B5CBC}" type="slidenum">
+              <a:rPr lang="en-US"/>
+              <a:t>18</a:t>
+            </a:fld>
+            <a:endParaRPr lang="en-US"/>
+          </a:p>
+        </p:txBody>
+      </p:sp>
+    </p:spTree>
+    <p:extLst>
+      <p:ext uri="{BB962C8B-B14F-4D97-AF65-F5344CB8AC3E}">
+        <p14:creationId xmlns:p14="http://schemas.microsoft.com/office/powerpoint/2010/main" val="1024086991"/>
+      </p:ext>
+    </p:extLst>
+  </p:cSld>
+  <p:clrMapOvr>
+    <a:masterClrMapping/>
+  </p:clrMapOvr>
+</p:notes>
+</file>
+
+<file path=ppt/notesSlides/notesSlide19.xml><?xml version="1.0" encoding="utf-8"?>
+<p:notes xmlns:a="http://schemas.openxmlformats.org/drawingml/2006/main" xmlns:r="http://schemas.openxmlformats.org/officeDocument/2006/relationships" xmlns:p="http://schemas.openxmlformats.org/presentationml/2006/main">
+  <p:cSld>
+    <p:spTree>
+      <p:nvGrpSpPr>
+        <p:cNvPr id="1" name=""/>
+        <p:cNvGrpSpPr/>
+        <p:nvPr/>
+      </p:nvGrpSpPr>
+      <p:grpSpPr>
+        <a:xfrm>
+          <a:off x="0" y="0"/>
+          <a:ext cx="0" cy="0"/>
+          <a:chOff x="0" y="0"/>
+          <a:chExt cx="0" cy="0"/>
+        </a:xfrm>
+      </p:grpSpPr>
+      <p:sp>
+        <p:nvSpPr>
+          <p:cNvPr id="2" name="Slide Image Placeholder 1"/>
+          <p:cNvSpPr>
+            <a:spLocks noGrp="1" noRot="1" noChangeAspect="1"/>
+          </p:cNvSpPr>
+          <p:nvPr>
+            <p:ph type="sldImg"/>
+          </p:nvPr>
+        </p:nvSpPr>
+        <p:spPr/>
+      </p:sp>
+      <p:sp>
+        <p:nvSpPr>
+          <p:cNvPr id="3" name="Notes Placeholder 2"/>
+          <p:cNvSpPr>
+            <a:spLocks noGrp="1"/>
+          </p:cNvSpPr>
+          <p:nvPr>
+            <p:ph type="body" idx="1"/>
+          </p:nvPr>
+        </p:nvSpPr>
+        <p:spPr/>
+        <p:txBody>
+          <a:bodyPr/>
+          <a:lstStyle/>
+          <a:p>
+            <a:r>
+              <a:rPr lang="en-US" dirty="0"/>
+              <a:t>Si me preguntáis cuál es la lección que me llevo de todo el proyecto, es esta diapositiva. El hueco de Reviewer y Security no se cerró la primera vez — volvió a aparecer más adelante, ya en mobile-app. Y ahí entendí que la solución no podía ser "tener más cuidado la próxima vez", tenía que ser un cambio de proceso que hiciera imposible saltárselo en silencio — el contrato de handoff que ya hemos visto. El resto de patrones son más técnicos, pero todos comparten la misma idea de fondo: el problema no se ve hasta que algo real lo atraviesa, ni en el diseño ni en la revisión.</a:t>
+            </a:r>
+            <a:endParaRPr lang="en-US" dirty="0"/>
+          </a:p>
+        </p:txBody>
+      </p:sp>
+      <p:sp>
+        <p:nvSpPr>
+          <p:cNvPr id="4" name="Slide Number Placeholder 3"/>
+          <p:cNvSpPr>
+            <a:spLocks noGrp="1"/>
+          </p:cNvSpPr>
+          <p:nvPr>
+            <p:ph type="sldNum" sz="quarter" idx="10"/>
+          </p:nvPr>
+        </p:nvSpPr>
+        <p:spPr/>
+        <p:txBody>
+          <a:bodyPr/>
+          <a:lstStyle/>
+          <a:p>
+            <a:fld id="{F7021451-1387-4CA6-816F-3879F97B5CBC}" type="slidenum">
+              <a:rPr lang="en-US"/>
+              <a:t>19</a:t>
             </a:fld>
             <a:endParaRPr lang="en-US"/>
           </a:p>
@@ -1310,7 +1489,7 @@
           <a:p>
             <a:r>
               <a:rPr lang="en-US" dirty="0"/>
-              <a:t>El objeto de estudio no es solo la app. Es demostrar que un desarrollo con agentes de IA puede seguir Clean Architecture, TDD y decisiones arquitectónicas formales (ADRs) de forma verificable — y, más importante, documentar honestamente dónde ese proceso falló y qué mecanismo se introdujo para corregirlo. Esa segunda parte es el aporte académico más defendible, y se detalla en los bloques 11-15.</a:t>
+              <a:t>El objeto de estudio no es solo la app. Es demostrar que un desarrollo con agentes de IA puede seguir Clean Architecture, TDD y decisiones arquitectónicas formales (ADRs) de forma verificable — y, más importante, documentar honestamente dónde ese proceso falló y qué mecanismo se introdujo para corregirlo. Esa segunda parte es el aporte académico más defendible, y se detalla en los bloques 12-19.</a:t>
             </a:r>
             <a:endParaRPr lang="en-US" dirty="0"/>
           </a:p>
@@ -1334,6 +1513,94 @@
             <a:fld id="{F7021451-1387-4CA6-816F-3879F97B5CBC}" type="slidenum">
               <a:rPr lang="en-US"/>
               <a:t>2</a:t>
+            </a:fld>
+            <a:endParaRPr lang="en-US"/>
+          </a:p>
+        </p:txBody>
+      </p:sp>
+    </p:spTree>
+    <p:extLst>
+      <p:ext uri="{BB962C8B-B14F-4D97-AF65-F5344CB8AC3E}">
+        <p14:creationId xmlns:p14="http://schemas.microsoft.com/office/powerpoint/2010/main" val="1024086991"/>
+      </p:ext>
+    </p:extLst>
+  </p:cSld>
+  <p:clrMapOvr>
+    <a:masterClrMapping/>
+  </p:clrMapOvr>
+</p:notes>
+</file>
+
+<file path=ppt/notesSlides/notesSlide20.xml><?xml version="1.0" encoding="utf-8"?>
+<p:notes xmlns:a="http://schemas.openxmlformats.org/drawingml/2006/main" xmlns:r="http://schemas.openxmlformats.org/officeDocument/2006/relationships" xmlns:p="http://schemas.openxmlformats.org/presentationml/2006/main">
+  <p:cSld>
+    <p:spTree>
+      <p:nvGrpSpPr>
+        <p:cNvPr id="1" name=""/>
+        <p:cNvGrpSpPr/>
+        <p:nvPr/>
+      </p:nvGrpSpPr>
+      <p:grpSpPr>
+        <a:xfrm>
+          <a:off x="0" y="0"/>
+          <a:ext cx="0" cy="0"/>
+          <a:chOff x="0" y="0"/>
+          <a:chExt cx="0" cy="0"/>
+        </a:xfrm>
+      </p:grpSpPr>
+      <p:sp>
+        <p:nvSpPr>
+          <p:cNvPr id="2" name="Slide Image Placeholder 1"/>
+          <p:cNvSpPr>
+            <a:spLocks noGrp="1" noRot="1" noChangeAspect="1"/>
+          </p:cNvSpPr>
+          <p:nvPr>
+            <p:ph type="sldImg"/>
+          </p:nvPr>
+        </p:nvSpPr>
+        <p:spPr/>
+      </p:sp>
+      <p:sp>
+        <p:nvSpPr>
+          <p:cNvPr id="3" name="Notes Placeholder 2"/>
+          <p:cNvSpPr>
+            <a:spLocks noGrp="1"/>
+          </p:cNvSpPr>
+          <p:nvPr>
+            <p:ph type="body" idx="1"/>
+          </p:nvPr>
+        </p:nvSpPr>
+        <p:spPr/>
+        <p:txBody>
+          <a:bodyPr/>
+          <a:lstStyle/>
+          <a:p>
+            <a:r>
+              <a:rPr lang="en-US" dirty="0"/>
+              <a:t>Cierre con las dos caras del TFM a la vez: el producto se puede usar de principio a fin hoy mismo, y el proceso que lo construyó queda documentado con evidencia medible, no solo con buenas intenciones. Los errores documentados no son un fracaso — son el material de evidencia principal. Abrir turno de preguntas.</a:t>
+            </a:r>
+            <a:endParaRPr lang="en-US" dirty="0"/>
+          </a:p>
+        </p:txBody>
+      </p:sp>
+      <p:sp>
+        <p:nvSpPr>
+          <p:cNvPr id="4" name="Slide Number Placeholder 3"/>
+          <p:cNvSpPr>
+            <a:spLocks noGrp="1"/>
+          </p:cNvSpPr>
+          <p:nvPr>
+            <p:ph type="sldNum" sz="quarter" idx="10"/>
+          </p:nvPr>
+        </p:nvSpPr>
+        <p:spPr/>
+        <p:txBody>
+          <a:bodyPr/>
+          <a:lstStyle/>
+          <a:p>
+            <a:fld id="{F7021451-1387-4CA6-816F-3879F97B5CBC}" type="slidenum">
+              <a:rPr lang="en-US"/>
+              <a:t>20</a:t>
             </a:fld>
             <a:endParaRPr lang="en-US"/>
           </a:p>
@@ -1662,7 +1929,7 @@
           <a:p>
             <a:r>
               <a:rPr lang="en-US" dirty="0"/>
-              <a:t>AdaptiveDifficultyEngine fue el primer componente de dominio construido con TDD real (Red→Green desde el primer commit). Es puro — sin dependencias de framework — y demostrable con 8/8 tests en verde. Aquí también entra el bug real #27 (slide 15): la semilla inicial ignoraba el nivel académico porque todos los tests usaban Secundaria por defecto, enmascarando el fallo.</a:t>
+              <a:t>AdaptiveDifficultyEngine fue el primer componente de dominio construido con TDD real (Red→Green desde el primer commit). Es puro — sin dependencias de framework — y demostrable con 8/8 tests en verde. Aquí también entra el bug real #27 (slide 17): la semilla inicial ignoraba el nivel académico porque todos los tests usaban Secundaria por defecto, enmascarando el fallo.</a:t>
             </a:r>
             <a:endParaRPr lang="en-US" dirty="0"/>
           </a:p>
@@ -3588,7 +3855,7 @@
                 <a:ea typeface="Calibri" pitchFamily="34" charset="-122"/>
                 <a:cs typeface="Calibri" pitchFamily="34" charset="-120"/>
               </a:rPr>
-              <a:t>El incidente que cambió el proceso</a:t>
+              <a:t>Reglas transversales del sistema</a:t>
             </a:r>
             <a:endParaRPr lang="en-US" sz="2800" dirty="0"/>
           </a:p>
@@ -3638,26 +3905,6 @@
           <a:bodyPr wrap="square" rtlCol="0" anchor="t"/>
           <a:lstStyle/>
           <a:p>
-            <a:pPr indent="0" marL="0">
-              <a:spcAft>
-                <a:spcPts val="1000"/>
-              </a:spcAft>
-              <a:buNone/>
-            </a:pPr>
-            <a:r>
-              <a:rPr lang="en-US" sz="1800" i="1" dirty="0">
-                <a:solidFill>
-                  <a:srgbClr val="F72585"/>
-                </a:solidFill>
-                <a:latin typeface="Calibri" pitchFamily="34" charset="0"/>
-                <a:ea typeface="Calibri" pitchFamily="34" charset="-122"/>
-                <a:cs typeface="Calibri" pitchFamily="34" charset="-120"/>
-              </a:rPr>
-              <a:t>“Ninguna tarea pasó realmente por Director/Orchestrator/Knowledge Manager, y Reviewer/Security se saltaron en la implementación de autenticación real.” — Adenda a ADR-002, 2026-08-07</a:t>
-            </a:r>
-            <a:endParaRPr lang="en-US" sz="1800" dirty="0"/>
-          </a:p>
-          <a:p>
             <a:pPr marL="228600" indent="-228600">
               <a:spcAft>
                 <a:spcPts val="1200"/>
@@ -3674,7 +3921,7 @@
                 <a:ea typeface="Calibri" pitchFamily="34" charset="-122"/>
                 <a:cs typeface="Calibri" pitchFamily="34" charset="-120"/>
               </a:rPr>
-              <a:t>Mecanismo introducido: Contrato de Handoff — 8 campos obligatorios antes de ejecutar cualquier tarea no trivial</a:t>
+              <a:t>Jerarquía Documental — ante conflicto, manda siempre en este orden:</a:t>
             </a:r>
             <a:endParaRPr lang="en-US" sz="1800" dirty="0"/>
           </a:p>
@@ -3695,7 +3942,7 @@
                 <a:ea typeface="Calibri" pitchFamily="34" charset="-122"/>
                 <a:cs typeface="Calibri" pitchFamily="34" charset="-120"/>
               </a:rPr>
-              <a:t>requester · objective · scope · constraints · references · acceptance · risks · required_agents</a:t>
+              <a:t>ADR &gt; ARCHITECTURE.md &gt; README.md &gt; Skills &gt; Prompt recibido</a:t>
             </a:r>
             <a:endParaRPr lang="en-US" sz="1800" dirty="0"/>
           </a:p>
@@ -3716,7 +3963,49 @@
                 <a:ea typeface="Calibri" pitchFamily="34" charset="-122"/>
                 <a:cs typeface="Calibri" pitchFamily="34" charset="-120"/>
               </a:rPr>
-              <a:t>Omitir un agente exige justificación explícita, nunca un silencio que se descubre después</a:t>
+              <a:t>Regla de Oro — ningún agente toca código sin consultar antes esos documentos</a:t>
+            </a:r>
+            <a:endParaRPr lang="en-US" sz="1800" dirty="0"/>
+          </a:p>
+          <a:p>
+            <a:pPr marL="228600" indent="-228600">
+              <a:spcAft>
+                <a:spcPts val="1200"/>
+              </a:spcAft>
+              <a:buSzPct val="100000"/>
+              <a:buChar char="●"/>
+            </a:pPr>
+            <a:r>
+              <a:rPr lang="en-US" sz="1800" dirty="0">
+                <a:solidFill>
+                  <a:srgbClr val="15192B"/>
+                </a:solidFill>
+                <a:latin typeface="Calibri" pitchFamily="34" charset="0"/>
+                <a:ea typeface="Calibri" pitchFamily="34" charset="-122"/>
+                <a:cs typeface="Calibri" pitchFamily="34" charset="-120"/>
+              </a:rPr>
+              <a:t>TDD Enforcement Rule — User Story → Diseño → Tests → Implementación → Refactorización</a:t>
+            </a:r>
+            <a:endParaRPr lang="en-US" sz="1800" dirty="0"/>
+          </a:p>
+          <a:p>
+            <a:pPr marL="228600" indent="-228600">
+              <a:spcAft>
+                <a:spcPts val="1200"/>
+              </a:spcAft>
+              <a:buSzPct val="100000"/>
+              <a:buChar char="●"/>
+            </a:pPr>
+            <a:r>
+              <a:rPr lang="en-US" sz="1800" dirty="0">
+                <a:solidFill>
+                  <a:srgbClr val="15192B"/>
+                </a:solidFill>
+                <a:latin typeface="Calibri" pitchFamily="34" charset="0"/>
+                <a:ea typeface="Calibri" pitchFamily="34" charset="-122"/>
+                <a:cs typeface="Calibri" pitchFamily="34" charset="-120"/>
+              </a:rPr>
+              <a:t>Reglas de Reutilización — prohibido duplicar entidades, DTOs o utilidades entre packages/shared-*</a:t>
             </a:r>
             <a:endParaRPr lang="en-US" sz="1800" dirty="0"/>
           </a:p>
@@ -3924,7 +4213,7 @@
                 <a:ea typeface="Calibri" pitchFamily="34" charset="-122"/>
                 <a:cs typeface="Calibri" pitchFamily="34" charset="-120"/>
               </a:rPr>
-              <a:t>De la prosa al dato medible</a:t>
+              <a:t>El incidente que cambió el proceso</a:t>
             </a:r>
             <a:endParaRPr lang="en-US" sz="2800" dirty="0"/>
           </a:p>
@@ -3974,6 +4263,26 @@
           <a:bodyPr wrap="square" rtlCol="0" anchor="t"/>
           <a:lstStyle/>
           <a:p>
+            <a:pPr indent="0" marL="0">
+              <a:spcAft>
+                <a:spcPts val="1000"/>
+              </a:spcAft>
+              <a:buNone/>
+            </a:pPr>
+            <a:r>
+              <a:rPr lang="en-US" sz="1800" i="1" dirty="0">
+                <a:solidFill>
+                  <a:srgbClr val="F72585"/>
+                </a:solidFill>
+                <a:latin typeface="Calibri" pitchFamily="34" charset="0"/>
+                <a:ea typeface="Calibri" pitchFamily="34" charset="-122"/>
+                <a:cs typeface="Calibri" pitchFamily="34" charset="-120"/>
+              </a:rPr>
+              <a:t>“Ninguna tarea pasó realmente por Director/Orchestrator/Knowledge Manager, y Reviewer/Security se saltaron en la implementación de autenticación real.” — Adenda a ADR-002, 2026-08-07</a:t>
+            </a:r>
+            <a:endParaRPr lang="en-US" sz="1800" dirty="0"/>
+          </a:p>
+          <a:p>
             <a:pPr marL="228600" indent="-228600">
               <a:spcAft>
                 <a:spcPts val="1200"/>
@@ -3990,7 +4299,28 @@
                 <a:ea typeface="Calibri" pitchFamily="34" charset="-122"/>
                 <a:cs typeface="Calibri" pitchFamily="34" charset="-120"/>
               </a:rPr>
-              <a:t>ADR-003 (origen): registro en prosa libre — "la disciplina de registro es manual, no forzada por tooling"</a:t>
+              <a:t>Mecanismo introducido: Contrato de Handoff — 8 campos obligatorios antes de ejecutar cualquier tarea no trivial</a:t>
+            </a:r>
+            <a:endParaRPr lang="en-US" sz="1800" dirty="0"/>
+          </a:p>
+          <a:p>
+            <a:pPr lvl="1" marL="685800" indent="-342900">
+              <a:spcAft>
+                <a:spcPts val="1200"/>
+              </a:spcAft>
+              <a:buSzPct val="100000"/>
+              <a:buChar char="–"/>
+            </a:pPr>
+            <a:r>
+              <a:rPr lang="en-US" sz="1600" dirty="0">
+                <a:solidFill>
+                  <a:srgbClr val="3A4059"/>
+                </a:solidFill>
+                <a:latin typeface="Calibri" pitchFamily="34" charset="0"/>
+                <a:ea typeface="Calibri" pitchFamily="34" charset="-122"/>
+                <a:cs typeface="Calibri" pitchFamily="34" charset="-120"/>
+              </a:rPr>
+              <a:t>requester · objective · scope · constraints · references · acceptance · risks · required_agents</a:t>
             </a:r>
             <a:endParaRPr lang="en-US" sz="1800" dirty="0"/>
           </a:p>
@@ -4011,49 +4341,7 @@
                 <a:ea typeface="Calibri" pitchFamily="34" charset="-122"/>
                 <a:cs typeface="Calibri" pitchFamily="34" charset="-120"/>
               </a:rPr>
-              <a:t>ADR-017 (evolución, 2026-08-10): front-matter YAML sobre cada entrada (task_id, flujo, agentes, estado…)</a:t>
-            </a:r>
-            <a:endParaRPr lang="en-US" sz="1800" dirty="0"/>
-          </a:p>
-          <a:p>
-            <a:pPr marL="228600" indent="-228600">
-              <a:spcAft>
-                <a:spcPts val="1200"/>
-              </a:spcAft>
-              <a:buSzPct val="100000"/>
-              <a:buChar char="●"/>
-            </a:pPr>
-            <a:r>
-              <a:rPr lang="en-US" sz="1800" dirty="0">
-                <a:solidFill>
-                  <a:srgbClr val="15192B"/>
-                </a:solidFill>
-                <a:latin typeface="Calibri" pitchFamily="34" charset="0"/>
-                <a:ea typeface="Calibri" pitchFamily="34" charset="-122"/>
-                <a:cs typeface="Calibri" pitchFamily="34" charset="-120"/>
-              </a:rPr>
-              <a:t>Migración retroactiva completa: 86/86 entradas migradas, 49 tareas distintas</a:t>
-            </a:r>
-            <a:endParaRPr lang="en-US" sz="1800" dirty="0"/>
-          </a:p>
-          <a:p>
-            <a:pPr marL="228600" indent="-228600">
-              <a:spcAft>
-                <a:spcPts val="1200"/>
-              </a:spcAft>
-              <a:buSzPct val="100000"/>
-              <a:buChar char="●"/>
-            </a:pPr>
-            <a:r>
-              <a:rPr lang="en-US" sz="1800" dirty="0">
-                <a:solidFill>
-                  <a:srgbClr val="15192B"/>
-                </a:solidFill>
-                <a:latin typeface="Calibri" pitchFamily="34" charset="0"/>
-                <a:ea typeface="Calibri" pitchFamily="34" charset="-122"/>
-                <a:cs typeface="Calibri" pitchFamily="34" charset="-120"/>
-              </a:rPr>
-              <a:t>npm run metrics -- --report calcula los KPIs automáticamente</a:t>
+              <a:t>Omitir un agente exige justificación explícita, nunca un silencio que se descubre después</a:t>
             </a:r>
             <a:endParaRPr lang="en-US" sz="1800" dirty="0"/>
           </a:p>
@@ -4261,7 +4549,7 @@
                 <a:ea typeface="Calibri" pitchFamily="34" charset="-122"/>
                 <a:cs typeface="Calibri" pitchFamily="34" charset="-120"/>
               </a:rPr>
-              <a:t>Resultados medidos (KPIs reales)</a:t>
+              <a:t>De la prosa al dato medible</a:t>
             </a:r>
             <a:endParaRPr lang="en-US" sz="2800" dirty="0"/>
           </a:p>
@@ -4290,9 +4578,346 @@
           </a:ln>
         </p:spPr>
       </p:sp>
+      <p:sp>
+        <p:nvSpPr>
+          <p:cNvPr id="6" name="Text 4"/>
+          <p:cNvSpPr/>
+          <p:nvPr/>
+        </p:nvSpPr>
+        <p:spPr>
+          <a:xfrm>
+            <a:off x="502920" y="1783080"/>
+            <a:ext cx="11155680" cy="4480560"/>
+          </a:xfrm>
+          <a:prstGeom prst="rect">
+            <a:avLst/>
+          </a:prstGeom>
+          <a:noFill/>
+          <a:ln/>
+        </p:spPr>
+        <p:txBody>
+          <a:bodyPr wrap="square" rtlCol="0" anchor="t"/>
+          <a:lstStyle/>
+          <a:p>
+            <a:pPr marL="228600" indent="-228600">
+              <a:spcAft>
+                <a:spcPts val="1200"/>
+              </a:spcAft>
+              <a:buSzPct val="100000"/>
+              <a:buChar char="●"/>
+            </a:pPr>
+            <a:r>
+              <a:rPr lang="en-US" sz="1800" dirty="0">
+                <a:solidFill>
+                  <a:srgbClr val="15192B"/>
+                </a:solidFill>
+                <a:latin typeface="Calibri" pitchFamily="34" charset="0"/>
+                <a:ea typeface="Calibri" pitchFamily="34" charset="-122"/>
+                <a:cs typeface="Calibri" pitchFamily="34" charset="-120"/>
+              </a:rPr>
+              <a:t>ADR-003 (origen): registro en prosa libre — "la disciplina de registro es manual, no forzada por tooling"</a:t>
+            </a:r>
+            <a:endParaRPr lang="en-US" sz="1800" dirty="0"/>
+          </a:p>
+          <a:p>
+            <a:pPr marL="228600" indent="-228600">
+              <a:spcAft>
+                <a:spcPts val="1200"/>
+              </a:spcAft>
+              <a:buSzPct val="100000"/>
+              <a:buChar char="●"/>
+            </a:pPr>
+            <a:r>
+              <a:rPr lang="en-US" sz="1800" dirty="0">
+                <a:solidFill>
+                  <a:srgbClr val="15192B"/>
+                </a:solidFill>
+                <a:latin typeface="Calibri" pitchFamily="34" charset="0"/>
+                <a:ea typeface="Calibri" pitchFamily="34" charset="-122"/>
+                <a:cs typeface="Calibri" pitchFamily="34" charset="-120"/>
+              </a:rPr>
+              <a:t>ADR-017 (evolución, 2026-08-10): front-matter YAML sobre cada entrada (task_id, flujo, agentes, estado…)</a:t>
+            </a:r>
+            <a:endParaRPr lang="en-US" sz="1800" dirty="0"/>
+          </a:p>
+          <a:p>
+            <a:pPr marL="228600" indent="-228600">
+              <a:spcAft>
+                <a:spcPts val="1200"/>
+              </a:spcAft>
+              <a:buSzPct val="100000"/>
+              <a:buChar char="●"/>
+            </a:pPr>
+            <a:r>
+              <a:rPr lang="en-US" sz="1800" dirty="0">
+                <a:solidFill>
+                  <a:srgbClr val="15192B"/>
+                </a:solidFill>
+                <a:latin typeface="Calibri" pitchFamily="34" charset="0"/>
+                <a:ea typeface="Calibri" pitchFamily="34" charset="-122"/>
+                <a:cs typeface="Calibri" pitchFamily="34" charset="-120"/>
+              </a:rPr>
+              <a:t>Migración retroactiva completa: 86/86 entradas migradas, 49 tareas distintas</a:t>
+            </a:r>
+            <a:endParaRPr lang="en-US" sz="1800" dirty="0"/>
+          </a:p>
+          <a:p>
+            <a:pPr marL="228600" indent="-228600">
+              <a:spcAft>
+                <a:spcPts val="1200"/>
+              </a:spcAft>
+              <a:buSzPct val="100000"/>
+              <a:buChar char="●"/>
+            </a:pPr>
+            <a:r>
+              <a:rPr lang="en-US" sz="1800" dirty="0">
+                <a:solidFill>
+                  <a:srgbClr val="15192B"/>
+                </a:solidFill>
+                <a:latin typeface="Calibri" pitchFamily="34" charset="0"/>
+                <a:ea typeface="Calibri" pitchFamily="34" charset="-122"/>
+                <a:cs typeface="Calibri" pitchFamily="34" charset="-120"/>
+              </a:rPr>
+              <a:t>npm run metrics -- --report calcula los KPIs automáticamente</a:t>
+            </a:r>
+            <a:endParaRPr lang="en-US" sz="1800" dirty="0"/>
+          </a:p>
+        </p:txBody>
+      </p:sp>
+      <p:sp>
+        <p:nvSpPr>
+          <p:cNvPr id="8" name="Text 5"/>
+          <p:cNvSpPr/>
+          <p:nvPr/>
+        </p:nvSpPr>
+        <p:spPr>
+          <a:xfrm>
+            <a:off x="457200" y="6510528"/>
+            <a:ext cx="5486400" cy="274320"/>
+          </a:xfrm>
+          <a:prstGeom prst="rect">
+            <a:avLst/>
+          </a:prstGeom>
+          <a:noFill/>
+          <a:ln/>
+        </p:spPr>
+        <p:txBody>
+          <a:bodyPr wrap="square" rtlCol="0" anchor="ctr"/>
+          <a:lstStyle/>
+          <a:p>
+            <a:pPr indent="0" marL="0">
+              <a:buNone/>
+            </a:pPr>
+            <a:r>
+              <a:rPr lang="en-US" sz="900" dirty="0">
+                <a:solidFill>
+                  <a:srgbClr val="3A4059"/>
+                </a:solidFill>
+                <a:latin typeface="Calibri" pitchFamily="34" charset="0"/>
+                <a:ea typeface="Calibri" pitchFamily="34" charset="-122"/>
+                <a:cs typeface="Calibri" pitchFamily="34" charset="-120"/>
+              </a:rPr>
+              <a:t>MathMind AI -- TFM</a:t>
+            </a:r>
+            <a:endParaRPr lang="en-US" sz="900" dirty="0"/>
+          </a:p>
+        </p:txBody>
+      </p:sp>
+      <p:sp>
+        <p:nvSpPr>
+          <p:cNvPr id="9" name="Text 6"/>
+          <p:cNvSpPr/>
+          <p:nvPr/>
+        </p:nvSpPr>
+        <p:spPr>
+          <a:xfrm>
+            <a:off x="11521440" y="6510528"/>
+            <a:ext cx="457200" cy="274320"/>
+          </a:xfrm>
+          <a:prstGeom prst="rect">
+            <a:avLst/>
+          </a:prstGeom>
+          <a:noFill/>
+          <a:ln/>
+        </p:spPr>
+        <p:txBody>
+          <a:bodyPr wrap="square" rtlCol="0" anchor="ctr"/>
+          <a:lstStyle/>
+          <a:p>
+            <a:pPr algn="r" indent="0" marL="0">
+              <a:buNone/>
+            </a:pPr>
+            <a:r>
+              <a:rPr lang="en-US" sz="900" b="1" dirty="0">
+                <a:solidFill>
+                  <a:srgbClr val="F72585"/>
+                </a:solidFill>
+                <a:latin typeface="Calibri" pitchFamily="34" charset="0"/>
+                <a:ea typeface="Calibri" pitchFamily="34" charset="-122"/>
+                <a:cs typeface="Calibri" pitchFamily="34" charset="-120"/>
+              </a:rPr>
+              <a:t>15</a:t>
+            </a:r>
+            <a:endParaRPr lang="en-US" sz="900" dirty="0"/>
+          </a:p>
+        </p:txBody>
+      </p:sp>
+    </p:spTree>
+  </p:cSld>
+  <p:clrMapOvr>
+    <a:masterClrMapping/>
+  </p:clrMapOvr>
+</p:sld>
+</file>
+
+<file path=ppt/slides/slide16.xml><?xml version="1.0" encoding="utf-8"?>
+<p:sld xmlns:a="http://schemas.openxmlformats.org/drawingml/2006/main" xmlns:r="http://schemas.openxmlformats.org/officeDocument/2006/relationships" xmlns:p="http://schemas.openxmlformats.org/presentationml/2006/main">
+  <p:cSld name="Slide 16">
+    <p:bg>
+      <p:bgPr>
+        <a:solidFill>
+          <a:srgbClr val="F7F9FC"/>
+        </a:solidFill>
+      </p:bgPr>
+    </p:bg>
+    <p:spTree>
+      <p:nvGrpSpPr>
+        <p:cNvPr id="1" name=""/>
+        <p:cNvGrpSpPr/>
+        <p:nvPr/>
+      </p:nvGrpSpPr>
+      <p:grpSpPr>
+        <a:xfrm>
+          <a:off x="0" y="0"/>
+          <a:ext cx="0" cy="0"/>
+          <a:chOff x="0" y="0"/>
+          <a:chExt cx="0" cy="0"/>
+        </a:xfrm>
+      </p:grpSpPr>
+      <p:sp>
+        <p:nvSpPr>
+          <p:cNvPr id="2" name="Shape 0"/>
+          <p:cNvSpPr/>
+          <p:nvPr/>
+        </p:nvSpPr>
+        <p:spPr>
+          <a:xfrm>
+            <a:off x="0" y="0"/>
+            <a:ext cx="164592" cy="6858000"/>
+          </a:xfrm>
+          <a:prstGeom prst="rect">
+            <a:avLst/>
+          </a:prstGeom>
+          <a:solidFill>
+            <a:srgbClr val="F72585"/>
+          </a:solidFill>
+          <a:ln/>
+        </p:spPr>
+      </p:sp>
+      <p:sp>
+        <p:nvSpPr>
+          <p:cNvPr id="3" name="Text 1"/>
+          <p:cNvSpPr/>
+          <p:nvPr/>
+        </p:nvSpPr>
+        <p:spPr>
+          <a:xfrm>
+            <a:off x="502920" y="320040"/>
+            <a:ext cx="3657600" cy="320040"/>
+          </a:xfrm>
+          <a:prstGeom prst="rect">
+            <a:avLst/>
+          </a:prstGeom>
+          <a:noFill/>
+          <a:ln/>
+        </p:spPr>
+        <p:txBody>
+          <a:bodyPr wrap="square" rtlCol="0" anchor="ctr"/>
+          <a:lstStyle/>
+          <a:p>
+            <a:pPr indent="0" marL="0">
+              <a:buNone/>
+            </a:pPr>
+            <a:r>
+              <a:rPr lang="en-US" sz="1200" b="1" spc="200" kern="0" dirty="0">
+                <a:solidFill>
+                  <a:srgbClr val="F72585"/>
+                </a:solidFill>
+                <a:latin typeface="Calibri" pitchFamily="34" charset="0"/>
+                <a:ea typeface="Calibri" pitchFamily="34" charset="-122"/>
+                <a:cs typeface="Calibri" pitchFamily="34" charset="-120"/>
+              </a:rPr>
+              <a:t>GOBERNANZA</a:t>
+            </a:r>
+            <a:endParaRPr lang="en-US" sz="1200" dirty="0"/>
+          </a:p>
+        </p:txBody>
+      </p:sp>
+      <p:sp>
+        <p:nvSpPr>
+          <p:cNvPr id="4" name="Text 2"/>
+          <p:cNvSpPr/>
+          <p:nvPr/>
+        </p:nvSpPr>
+        <p:spPr>
+          <a:xfrm>
+            <a:off x="502920" y="621792"/>
+            <a:ext cx="11155680" cy="822960"/>
+          </a:xfrm>
+          <a:prstGeom prst="rect">
+            <a:avLst/>
+          </a:prstGeom>
+          <a:noFill/>
+          <a:ln/>
+        </p:spPr>
+        <p:txBody>
+          <a:bodyPr wrap="square" rtlCol="0" anchor="ctr"/>
+          <a:lstStyle/>
+          <a:p>
+            <a:pPr indent="0" marL="0">
+              <a:buNone/>
+            </a:pPr>
+            <a:r>
+              <a:rPr lang="en-US" sz="2800" b="1" dirty="0">
+                <a:solidFill>
+                  <a:srgbClr val="15192B"/>
+                </a:solidFill>
+                <a:latin typeface="Calibri" pitchFamily="34" charset="0"/>
+                <a:ea typeface="Calibri" pitchFamily="34" charset="-122"/>
+                <a:cs typeface="Calibri" pitchFamily="34" charset="-120"/>
+              </a:rPr>
+              <a:t>Resultados medidos (KPIs reales)</a:t>
+            </a:r>
+            <a:endParaRPr lang="en-US" sz="2800" dirty="0"/>
+          </a:p>
+        </p:txBody>
+      </p:sp>
+      <p:sp>
+        <p:nvSpPr>
+          <p:cNvPr id="5" name="Shape 3"/>
+          <p:cNvSpPr/>
+          <p:nvPr/>
+        </p:nvSpPr>
+        <p:spPr>
+          <a:xfrm>
+            <a:off x="502920" y="1417320"/>
+            <a:ext cx="11155680" cy="0"/>
+          </a:xfrm>
+          <a:prstGeom prst="line">
+            <a:avLst/>
+          </a:prstGeom>
+          <a:noFill/>
+          <a:ln w="25400">
+            <a:solidFill>
+              <a:srgbClr val="F72585"/>
+            </a:solidFill>
+            <a:prstDash val="solid"/>
+          </a:ln>
+        </p:spPr>
+      </p:sp>
       <p:graphicFrame>
         <p:nvGraphicFramePr>
-          <p:cNvPr id="16" name="Table 0"/>
+          <p:cNvPr id="17" name="Table 0"/>
           <p:cNvGraphicFramePr>
             <a:graphicFrameLocks noGrp="1"/>
           </p:cNvGraphicFramePr>
@@ -5259,7 +5884,7 @@
                 <a:ea typeface="Calibri" pitchFamily="34" charset="-122"/>
                 <a:cs typeface="Calibri" pitchFamily="34" charset="-120"/>
               </a:rPr>
-              <a:t>15</a:t>
+              <a:t>16</a:t>
             </a:r>
             <a:endParaRPr lang="en-US" sz="900" dirty="0"/>
           </a:p>
@@ -5273,9 +5898,9 @@
 </p:sld>
 </file>
 
-<file path=ppt/slides/slide16.xml><?xml version="1.0" encoding="utf-8"?>
+<file path=ppt/slides/slide17.xml><?xml version="1.0" encoding="utf-8"?>
 <p:sld xmlns:a="http://schemas.openxmlformats.org/drawingml/2006/main" xmlns:r="http://schemas.openxmlformats.org/officeDocument/2006/relationships" xmlns:p="http://schemas.openxmlformats.org/presentationml/2006/main">
-  <p:cSld name="Slide 16">
+  <p:cSld name="Slide 17">
     <p:bg>
       <p:bgPr>
         <a:solidFill>
@@ -5596,7 +6221,7 @@
                 <a:ea typeface="Calibri" pitchFamily="34" charset="-122"/>
                 <a:cs typeface="Calibri" pitchFamily="34" charset="-120"/>
               </a:rPr>
-              <a:t>16</a:t>
+              <a:t>17</a:t>
             </a:r>
             <a:endParaRPr lang="en-US" sz="900" dirty="0"/>
           </a:p>
@@ -5610,13 +6235,13 @@
 </p:sld>
 </file>
 
-<file path=ppt/slides/slide17.xml><?xml version="1.0" encoding="utf-8"?>
+<file path=ppt/slides/slide18.xml><?xml version="1.0" encoding="utf-8"?>
 <p:sld xmlns:a="http://schemas.openxmlformats.org/drawingml/2006/main" xmlns:r="http://schemas.openxmlformats.org/officeDocument/2006/relationships" xmlns:p="http://schemas.openxmlformats.org/presentationml/2006/main">
-  <p:cSld name="Slide 17">
+  <p:cSld name="Slide 18">
     <p:bg>
       <p:bgPr>
         <a:solidFill>
-          <a:srgbClr val="0A0E17"/>
+          <a:srgbClr val="F7F9FC"/>
         </a:solidFill>
       </p:bgPr>
     </p:bg>
@@ -5649,7 +6274,7 @@
             <a:avLst/>
           </a:prstGeom>
           <a:solidFill>
-            <a:srgbClr val="FFD60A"/>
+            <a:srgbClr val="F72585"/>
           </a:solidFill>
           <a:ln/>
         </p:spPr>
@@ -5662,8 +6287,8 @@
         </p:nvSpPr>
         <p:spPr>
           <a:xfrm>
-            <a:off x="685800" y="502920"/>
-            <a:ext cx="10515600" cy="822960"/>
+            <a:off x="502920" y="320040"/>
+            <a:ext cx="3657600" cy="320040"/>
           </a:xfrm>
           <a:prstGeom prst="rect">
             <a:avLst/>
@@ -5679,17 +6304,17 @@
               <a:buNone/>
             </a:pPr>
             <a:r>
-              <a:rPr lang="en-US" sz="3400" b="1" dirty="0">
-                <a:solidFill>
-                  <a:srgbClr val="FFFFFF"/>
-                </a:solidFill>
-                <a:latin typeface="Calibri" pitchFamily="34" charset="0"/>
-                <a:ea typeface="Calibri" pitchFamily="34" charset="-122"/>
-                <a:cs typeface="Calibri" pitchFamily="34" charset="-120"/>
-              </a:rPr>
-              <a:t>Conclusiones</a:t>
-            </a:r>
-            <a:endParaRPr lang="en-US" sz="3400" dirty="0"/>
+              <a:rPr lang="en-US" sz="1200" b="1" spc="200" kern="0" dirty="0">
+                <a:solidFill>
+                  <a:srgbClr val="F72585"/>
+                </a:solidFill>
+                <a:latin typeface="Calibri" pitchFamily="34" charset="0"/>
+                <a:ea typeface="Calibri" pitchFamily="34" charset="-122"/>
+                <a:cs typeface="Calibri" pitchFamily="34" charset="-120"/>
+              </a:rPr>
+              <a:t>GOBERNANZA</a:t>
+            </a:r>
+            <a:endParaRPr lang="en-US" sz="1200" dirty="0"/>
           </a:p>
         </p:txBody>
       </p:sp>
@@ -5701,8 +6326,8 @@
         </p:nvSpPr>
         <p:spPr>
           <a:xfrm>
-            <a:off x="685800" y="1600200"/>
-            <a:ext cx="10789920" cy="3291840"/>
+            <a:off x="502920" y="621792"/>
+            <a:ext cx="11155680" cy="822960"/>
           </a:xfrm>
           <a:prstGeom prst="rect">
             <a:avLst/>
@@ -5712,103 +6337,186 @@
         </p:spPr>
         <p:txBody>
           <a:bodyPr wrap="square" rtlCol="0" anchor="ctr"/>
+          <a:lstStyle/>
+          <a:p>
+            <a:pPr indent="0" marL="0">
+              <a:buNone/>
+            </a:pPr>
+            <a:r>
+              <a:rPr lang="en-US" sz="2800" b="1" dirty="0">
+                <a:solidFill>
+                  <a:srgbClr val="15192B"/>
+                </a:solidFill>
+                <a:latin typeface="Calibri" pitchFamily="34" charset="0"/>
+                <a:ea typeface="Calibri" pitchFamily="34" charset="-122"/>
+                <a:cs typeface="Calibri" pitchFamily="34" charset="-120"/>
+              </a:rPr>
+              <a:t>Buenas prácticas aplicadas</a:t>
+            </a:r>
+            <a:endParaRPr lang="en-US" sz="2800" dirty="0"/>
+          </a:p>
+        </p:txBody>
+      </p:sp>
+      <p:sp>
+        <p:nvSpPr>
+          <p:cNvPr id="5" name="Shape 3"/>
+          <p:cNvSpPr/>
+          <p:nvPr/>
+        </p:nvSpPr>
+        <p:spPr>
+          <a:xfrm>
+            <a:off x="502920" y="1417320"/>
+            <a:ext cx="11155680" cy="0"/>
+          </a:xfrm>
+          <a:prstGeom prst="line">
+            <a:avLst/>
+          </a:prstGeom>
+          <a:noFill/>
+          <a:ln w="25400">
+            <a:solidFill>
+              <a:srgbClr val="F72585"/>
+            </a:solidFill>
+            <a:prstDash val="solid"/>
+          </a:ln>
+        </p:spPr>
+      </p:sp>
+      <p:sp>
+        <p:nvSpPr>
+          <p:cNvPr id="6" name="Text 4"/>
+          <p:cNvSpPr/>
+          <p:nvPr/>
+        </p:nvSpPr>
+        <p:spPr>
+          <a:xfrm>
+            <a:off x="502920" y="1783080"/>
+            <a:ext cx="11155680" cy="4480560"/>
+          </a:xfrm>
+          <a:prstGeom prst="rect">
+            <a:avLst/>
+          </a:prstGeom>
+          <a:noFill/>
+          <a:ln/>
+        </p:spPr>
+        <p:txBody>
+          <a:bodyPr wrap="square" rtlCol="0" anchor="t"/>
           <a:lstStyle/>
           <a:p>
             <a:pPr marL="228600" indent="-228600">
               <a:spcAft>
-                <a:spcPts val="1400"/>
+                <a:spcPts val="1200"/>
               </a:spcAft>
               <a:buSzPct val="100000"/>
               <a:buChar char="●"/>
             </a:pPr>
             <a:r>
-              <a:rPr lang="en-US" sz="1900" dirty="0">
-                <a:solidFill>
-                  <a:srgbClr val="E7EBF7"/>
-                </a:solidFill>
-                <a:latin typeface="Calibri" pitchFamily="34" charset="0"/>
-                <a:ea typeface="Calibri" pitchFamily="34" charset="-122"/>
-                <a:cs typeface="Calibri" pitchFamily="34" charset="-120"/>
-              </a:rPr>
-              <a:t>Producto: MVP funcional completo — 7/7 User Stories, 18/18 ADR en estado Aceptado</a:t>
-            </a:r>
-            <a:endParaRPr lang="en-US" sz="1900" dirty="0"/>
+              <a:rPr lang="en-US" sz="1800" dirty="0">
+                <a:solidFill>
+                  <a:srgbClr val="15192B"/>
+                </a:solidFill>
+                <a:latin typeface="Calibri" pitchFamily="34" charset="0"/>
+                <a:ea typeface="Calibri" pitchFamily="34" charset="-122"/>
+                <a:cs typeface="Calibri" pitchFamily="34" charset="-120"/>
+              </a:rPr>
+              <a:t>ADRs vivos, no estáticos — se enmiendan con adendas fechadas, nunca se reescriben</a:t>
+            </a:r>
+            <a:endParaRPr lang="en-US" sz="1800" dirty="0"/>
           </a:p>
           <a:p>
             <a:pPr marL="228600" indent="-228600">
               <a:spcAft>
-                <a:spcPts val="1400"/>
+                <a:spcPts val="1200"/>
               </a:spcAft>
               <a:buSzPct val="100000"/>
               <a:buChar char="●"/>
             </a:pPr>
             <a:r>
-              <a:rPr lang="en-US" sz="1900" dirty="0">
-                <a:solidFill>
-                  <a:srgbClr val="E7EBF7"/>
-                </a:solidFill>
-                <a:latin typeface="Calibri" pitchFamily="34" charset="0"/>
-                <a:ea typeface="Calibri" pitchFamily="34" charset="-122"/>
-                <a:cs typeface="Calibri" pitchFamily="34" charset="-120"/>
-              </a:rPr>
-              <a:t>Un sistema multiagente gobernado por reglas explícitas no garantiza por sí solo su cumplimiento</a:t>
-            </a:r>
-            <a:endParaRPr lang="en-US" sz="1900" dirty="0"/>
+              <a:rPr lang="en-US" sz="1800" dirty="0">
+                <a:solidFill>
+                  <a:srgbClr val="15192B"/>
+                </a:solidFill>
+                <a:latin typeface="Calibri" pitchFamily="34" charset="0"/>
+                <a:ea typeface="Calibri" pitchFamily="34" charset="-122"/>
+                <a:cs typeface="Calibri" pitchFamily="34" charset="-120"/>
+              </a:rPr>
+              <a:t>TDD real, no nominal — ciclo Red→Green desde el primer componente de dominio</a:t>
+            </a:r>
+            <a:endParaRPr lang="en-US" sz="1800" dirty="0"/>
           </a:p>
           <a:p>
             <a:pPr marL="228600" indent="-228600">
               <a:spcAft>
-                <a:spcPts val="1400"/>
+                <a:spcPts val="1200"/>
               </a:spcAft>
               <a:buSzPct val="100000"/>
               <a:buChar char="●"/>
             </a:pPr>
             <a:r>
-              <a:rPr lang="en-US" sz="1900" dirty="0">
-                <a:solidFill>
-                  <a:srgbClr val="E7EBF7"/>
-                </a:solidFill>
-                <a:latin typeface="Calibri" pitchFamily="34" charset="0"/>
-                <a:ea typeface="Calibri" pitchFamily="34" charset="-122"/>
-                <a:cs typeface="Calibri" pitchFamily="34" charset="-120"/>
-              </a:rPr>
-              <a:t>La gobernanza solo es verificable cuando pasa de estar descrita a estar instrumentada</a:t>
-            </a:r>
-            <a:endParaRPr lang="en-US" sz="1900" dirty="0"/>
+              <a:rPr lang="en-US" sz="1800" dirty="0">
+                <a:solidFill>
+                  <a:srgbClr val="15192B"/>
+                </a:solidFill>
+                <a:latin typeface="Calibri" pitchFamily="34" charset="0"/>
+                <a:ea typeface="Calibri" pitchFamily="34" charset="-122"/>
+                <a:cs typeface="Calibri" pitchFamily="34" charset="-120"/>
+              </a:rPr>
+              <a:t>Validación de contratos de IA en el borde, no confianza ciega en la salida del LLM (Zod)</a:t>
+            </a:r>
+            <a:endParaRPr lang="en-US" sz="1800" dirty="0"/>
           </a:p>
           <a:p>
             <a:pPr marL="228600" indent="-228600">
               <a:spcAft>
-                <a:spcPts val="1400"/>
+                <a:spcPts val="1200"/>
               </a:spcAft>
               <a:buSzPct val="100000"/>
               <a:buChar char="●"/>
             </a:pPr>
             <a:r>
-              <a:rPr lang="en-US" sz="1900" dirty="0">
-                <a:solidFill>
-                  <a:srgbClr val="E7EBF7"/>
-                </a:solidFill>
-                <a:latin typeface="Calibri" pitchFamily="34" charset="0"/>
-                <a:ea typeface="Calibri" pitchFamily="34" charset="-122"/>
-                <a:cs typeface="Calibri" pitchFamily="34" charset="-120"/>
-              </a:rPr>
-              <a:t>Trabajo futuro: cobertura real de tests, cerrar la brecha de Reviewer, HTTPS en producción, EAS en CI/CD</a:t>
-            </a:r>
-            <a:endParaRPr lang="en-US" sz="1900" dirty="0"/>
-          </a:p>
-        </p:txBody>
-      </p:sp>
-      <p:sp>
-        <p:nvSpPr>
-          <p:cNvPr id="5" name="Text 3"/>
-          <p:cNvSpPr/>
-          <p:nvPr/>
-        </p:nvSpPr>
-        <p:spPr>
-          <a:xfrm>
-            <a:off x="685800" y="5897880"/>
-            <a:ext cx="10515600" cy="548640"/>
+              <a:rPr lang="en-US" sz="1800" dirty="0">
+                <a:solidFill>
+                  <a:srgbClr val="15192B"/>
+                </a:solidFill>
+                <a:latin typeface="Calibri" pitchFamily="34" charset="0"/>
+                <a:ea typeface="Calibri" pitchFamily="34" charset="-122"/>
+                <a:cs typeface="Calibri" pitchFamily="34" charset="-120"/>
+              </a:rPr>
+              <a:t>Reevaluación tecnológica documentada, no silenciosa — Chroma→pgvector, 5 ADR de seguridad→1</a:t>
+            </a:r>
+            <a:endParaRPr lang="en-US" sz="1800" dirty="0"/>
+          </a:p>
+          <a:p>
+            <a:pPr marL="228600" indent="-228600">
+              <a:spcAft>
+                <a:spcPts val="1200"/>
+              </a:spcAft>
+              <a:buSzPct val="100000"/>
+              <a:buChar char="●"/>
+            </a:pPr>
+            <a:r>
+              <a:rPr lang="en-US" sz="1800" dirty="0">
+                <a:solidFill>
+                  <a:srgbClr val="15192B"/>
+                </a:solidFill>
+                <a:latin typeface="Calibri" pitchFamily="34" charset="0"/>
+                <a:ea typeface="Calibri" pitchFamily="34" charset="-122"/>
+                <a:cs typeface="Calibri" pitchFamily="34" charset="-120"/>
+              </a:rPr>
+              <a:t>Deuda técnica aceptada de forma explícita, nunca oculta tras un mock que no demuestra nada real</a:t>
+            </a:r>
+            <a:endParaRPr lang="en-US" sz="1800" dirty="0"/>
+          </a:p>
+        </p:txBody>
+      </p:sp>
+      <p:sp>
+        <p:nvSpPr>
+          <p:cNvPr id="8" name="Text 5"/>
+          <p:cNvSpPr/>
+          <p:nvPr/>
+        </p:nvSpPr>
+        <p:spPr>
+          <a:xfrm>
+            <a:off x="457200" y="6510528"/>
+            <a:ext cx="5486400" cy="274320"/>
           </a:xfrm>
           <a:prstGeom prst="rect">
             <a:avLst/>
@@ -5824,23 +6532,341 @@
               <a:buNone/>
             </a:pPr>
             <a:r>
-              <a:rPr lang="en-US" sz="2000" i="1" dirty="0">
-                <a:solidFill>
-                  <a:srgbClr val="FFD60A"/>
-                </a:solidFill>
-                <a:latin typeface="Calibri" pitchFamily="34" charset="0"/>
-                <a:ea typeface="Calibri" pitchFamily="34" charset="-122"/>
-                <a:cs typeface="Calibri" pitchFamily="34" charset="-120"/>
-              </a:rPr>
-              <a:t>Gracias — turno de preguntas</a:t>
-            </a:r>
-            <a:endParaRPr lang="en-US" sz="2000" dirty="0"/>
-          </a:p>
-        </p:txBody>
-      </p:sp>
-      <p:sp>
-        <p:nvSpPr>
-          <p:cNvPr id="7" name="Text 4"/>
+              <a:rPr lang="en-US" sz="900" dirty="0">
+                <a:solidFill>
+                  <a:srgbClr val="3A4059"/>
+                </a:solidFill>
+                <a:latin typeface="Calibri" pitchFamily="34" charset="0"/>
+                <a:ea typeface="Calibri" pitchFamily="34" charset="-122"/>
+                <a:cs typeface="Calibri" pitchFamily="34" charset="-120"/>
+              </a:rPr>
+              <a:t>MathMind AI -- TFM</a:t>
+            </a:r>
+            <a:endParaRPr lang="en-US" sz="900" dirty="0"/>
+          </a:p>
+        </p:txBody>
+      </p:sp>
+      <p:sp>
+        <p:nvSpPr>
+          <p:cNvPr id="9" name="Text 6"/>
+          <p:cNvSpPr/>
+          <p:nvPr/>
+        </p:nvSpPr>
+        <p:spPr>
+          <a:xfrm>
+            <a:off x="11521440" y="6510528"/>
+            <a:ext cx="457200" cy="274320"/>
+          </a:xfrm>
+          <a:prstGeom prst="rect">
+            <a:avLst/>
+          </a:prstGeom>
+          <a:noFill/>
+          <a:ln/>
+        </p:spPr>
+        <p:txBody>
+          <a:bodyPr wrap="square" rtlCol="0" anchor="ctr"/>
+          <a:lstStyle/>
+          <a:p>
+            <a:pPr algn="r" indent="0" marL="0">
+              <a:buNone/>
+            </a:pPr>
+            <a:r>
+              <a:rPr lang="en-US" sz="900" b="1" dirty="0">
+                <a:solidFill>
+                  <a:srgbClr val="F72585"/>
+                </a:solidFill>
+                <a:latin typeface="Calibri" pitchFamily="34" charset="0"/>
+                <a:ea typeface="Calibri" pitchFamily="34" charset="-122"/>
+                <a:cs typeface="Calibri" pitchFamily="34" charset="-120"/>
+              </a:rPr>
+              <a:t>18</a:t>
+            </a:r>
+            <a:endParaRPr lang="en-US" sz="900" dirty="0"/>
+          </a:p>
+        </p:txBody>
+      </p:sp>
+    </p:spTree>
+  </p:cSld>
+  <p:clrMapOvr>
+    <a:masterClrMapping/>
+  </p:clrMapOvr>
+</p:sld>
+</file>
+
+<file path=ppt/slides/slide19.xml><?xml version="1.0" encoding="utf-8"?>
+<p:sld xmlns:a="http://schemas.openxmlformats.org/drawingml/2006/main" xmlns:r="http://schemas.openxmlformats.org/officeDocument/2006/relationships" xmlns:p="http://schemas.openxmlformats.org/presentationml/2006/main">
+  <p:cSld name="Slide 19">
+    <p:bg>
+      <p:bgPr>
+        <a:solidFill>
+          <a:srgbClr val="F7F9FC"/>
+        </a:solidFill>
+      </p:bgPr>
+    </p:bg>
+    <p:spTree>
+      <p:nvGrpSpPr>
+        <p:cNvPr id="1" name=""/>
+        <p:cNvGrpSpPr/>
+        <p:nvPr/>
+      </p:nvGrpSpPr>
+      <p:grpSpPr>
+        <a:xfrm>
+          <a:off x="0" y="0"/>
+          <a:ext cx="0" cy="0"/>
+          <a:chOff x="0" y="0"/>
+          <a:chExt cx="0" cy="0"/>
+        </a:xfrm>
+      </p:grpSpPr>
+      <p:sp>
+        <p:nvSpPr>
+          <p:cNvPr id="2" name="Shape 0"/>
+          <p:cNvSpPr/>
+          <p:nvPr/>
+        </p:nvSpPr>
+        <p:spPr>
+          <a:xfrm>
+            <a:off x="0" y="0"/>
+            <a:ext cx="164592" cy="6858000"/>
+          </a:xfrm>
+          <a:prstGeom prst="rect">
+            <a:avLst/>
+          </a:prstGeom>
+          <a:solidFill>
+            <a:srgbClr val="F72585"/>
+          </a:solidFill>
+          <a:ln/>
+        </p:spPr>
+      </p:sp>
+      <p:sp>
+        <p:nvSpPr>
+          <p:cNvPr id="3" name="Text 1"/>
+          <p:cNvSpPr/>
+          <p:nvPr/>
+        </p:nvSpPr>
+        <p:spPr>
+          <a:xfrm>
+            <a:off x="502920" y="320040"/>
+            <a:ext cx="3657600" cy="320040"/>
+          </a:xfrm>
+          <a:prstGeom prst="rect">
+            <a:avLst/>
+          </a:prstGeom>
+          <a:noFill/>
+          <a:ln/>
+        </p:spPr>
+        <p:txBody>
+          <a:bodyPr wrap="square" rtlCol="0" anchor="ctr"/>
+          <a:lstStyle/>
+          <a:p>
+            <a:pPr indent="0" marL="0">
+              <a:buNone/>
+            </a:pPr>
+            <a:r>
+              <a:rPr lang="en-US" sz="1200" b="1" spc="200" kern="0" dirty="0">
+                <a:solidFill>
+                  <a:srgbClr val="F72585"/>
+                </a:solidFill>
+                <a:latin typeface="Calibri" pitchFamily="34" charset="0"/>
+                <a:ea typeface="Calibri" pitchFamily="34" charset="-122"/>
+                <a:cs typeface="Calibri" pitchFamily="34" charset="-120"/>
+              </a:rPr>
+              <a:t>GOBERNANZA</a:t>
+            </a:r>
+            <a:endParaRPr lang="en-US" sz="1200" dirty="0"/>
+          </a:p>
+        </p:txBody>
+      </p:sp>
+      <p:sp>
+        <p:nvSpPr>
+          <p:cNvPr id="4" name="Text 2"/>
+          <p:cNvSpPr/>
+          <p:nvPr/>
+        </p:nvSpPr>
+        <p:spPr>
+          <a:xfrm>
+            <a:off x="502920" y="621792"/>
+            <a:ext cx="11155680" cy="822960"/>
+          </a:xfrm>
+          <a:prstGeom prst="rect">
+            <a:avLst/>
+          </a:prstGeom>
+          <a:noFill/>
+          <a:ln/>
+        </p:spPr>
+        <p:txBody>
+          <a:bodyPr wrap="square" rtlCol="0" anchor="ctr"/>
+          <a:lstStyle/>
+          <a:p>
+            <a:pPr indent="0" marL="0">
+              <a:buNone/>
+            </a:pPr>
+            <a:r>
+              <a:rPr lang="en-US" sz="2800" b="1" dirty="0">
+                <a:solidFill>
+                  <a:srgbClr val="15192B"/>
+                </a:solidFill>
+                <a:latin typeface="Calibri" pitchFamily="34" charset="0"/>
+                <a:ea typeface="Calibri" pitchFamily="34" charset="-122"/>
+                <a:cs typeface="Calibri" pitchFamily="34" charset="-120"/>
+              </a:rPr>
+              <a:t>Patrones de aprendizaje transversales</a:t>
+            </a:r>
+            <a:endParaRPr lang="en-US" sz="2800" dirty="0"/>
+          </a:p>
+        </p:txBody>
+      </p:sp>
+      <p:sp>
+        <p:nvSpPr>
+          <p:cNvPr id="5" name="Shape 3"/>
+          <p:cNvSpPr/>
+          <p:nvPr/>
+        </p:nvSpPr>
+        <p:spPr>
+          <a:xfrm>
+            <a:off x="502920" y="1417320"/>
+            <a:ext cx="11155680" cy="0"/>
+          </a:xfrm>
+          <a:prstGeom prst="line">
+            <a:avLst/>
+          </a:prstGeom>
+          <a:noFill/>
+          <a:ln w="25400">
+            <a:solidFill>
+              <a:srgbClr val="F72585"/>
+            </a:solidFill>
+            <a:prstDash val="solid"/>
+          </a:ln>
+        </p:spPr>
+      </p:sp>
+      <p:sp>
+        <p:nvSpPr>
+          <p:cNvPr id="6" name="Text 4"/>
+          <p:cNvSpPr/>
+          <p:nvPr/>
+        </p:nvSpPr>
+        <p:spPr>
+          <a:xfrm>
+            <a:off x="502920" y="1783080"/>
+            <a:ext cx="11155680" cy="4480560"/>
+          </a:xfrm>
+          <a:prstGeom prst="rect">
+            <a:avLst/>
+          </a:prstGeom>
+          <a:noFill/>
+          <a:ln/>
+        </p:spPr>
+        <p:txBody>
+          <a:bodyPr wrap="square" rtlCol="0" anchor="t"/>
+          <a:lstStyle/>
+          <a:p>
+            <a:pPr marL="228600" indent="-228600">
+              <a:spcAft>
+                <a:spcPts val="1200"/>
+              </a:spcAft>
+              <a:buSzPct val="100000"/>
+              <a:buChar char="●"/>
+            </a:pPr>
+            <a:r>
+              <a:rPr lang="en-US" sz="1800" dirty="0">
+                <a:solidFill>
+                  <a:srgbClr val="15192B"/>
+                </a:solidFill>
+                <a:latin typeface="Calibri" pitchFamily="34" charset="0"/>
+                <a:ea typeface="Calibri" pitchFamily="34" charset="-122"/>
+                <a:cs typeface="Calibri" pitchFamily="34" charset="-120"/>
+              </a:rPr>
+              <a:t>El propio sistema falló en seguir su flujo de gobernanza — y lo hizo dos veces, no una</a:t>
+            </a:r>
+            <a:endParaRPr lang="en-US" sz="1800" dirty="0"/>
+          </a:p>
+          <a:p>
+            <a:pPr marL="228600" indent="-228600">
+              <a:spcAft>
+                <a:spcPts val="1200"/>
+              </a:spcAft>
+              <a:buSzPct val="100000"/>
+              <a:buChar char="●"/>
+            </a:pPr>
+            <a:r>
+              <a:rPr lang="en-US" sz="1800" dirty="0">
+                <a:solidFill>
+                  <a:srgbClr val="15192B"/>
+                </a:solidFill>
+                <a:latin typeface="Calibri" pitchFamily="34" charset="0"/>
+                <a:ea typeface="Calibri" pitchFamily="34" charset="-122"/>
+                <a:cs typeface="Calibri" pitchFamily="34" charset="-120"/>
+              </a:rPr>
+              <a:t>Los huecos de diseño se revelan al construir el siguiente consumidor real, no al diseñar</a:t>
+            </a:r>
+            <a:endParaRPr lang="en-US" sz="1800" dirty="0"/>
+          </a:p>
+          <a:p>
+            <a:pPr marL="228600" indent="-228600">
+              <a:spcAft>
+                <a:spcPts val="1200"/>
+              </a:spcAft>
+              <a:buSzPct val="100000"/>
+              <a:buChar char="●"/>
+            </a:pPr>
+            <a:r>
+              <a:rPr lang="en-US" sz="1800" dirty="0">
+                <a:solidFill>
+                  <a:srgbClr val="15192B"/>
+                </a:solidFill>
+                <a:latin typeface="Calibri" pitchFamily="34" charset="0"/>
+                <a:ea typeface="Calibri" pitchFamily="34" charset="-122"/>
+                <a:cs typeface="Calibri" pitchFamily="34" charset="-120"/>
+              </a:rPr>
+              <a:t>Confiar en la salida de un LLM sin validar en el borde produce fallos reproducibles y costosos</a:t>
+            </a:r>
+            <a:endParaRPr lang="en-US" sz="1800" dirty="0"/>
+          </a:p>
+          <a:p>
+            <a:pPr marL="228600" indent="-228600">
+              <a:spcAft>
+                <a:spcPts val="1200"/>
+              </a:spcAft>
+              <a:buSzPct val="100000"/>
+              <a:buChar char="●"/>
+            </a:pPr>
+            <a:r>
+              <a:rPr lang="en-US" sz="1800" dirty="0">
+                <a:solidFill>
+                  <a:srgbClr val="15192B"/>
+                </a:solidFill>
+                <a:latin typeface="Calibri" pitchFamily="34" charset="0"/>
+                <a:ea typeface="Calibri" pitchFamily="34" charset="-122"/>
+                <a:cs typeface="Calibri" pitchFamily="34" charset="-120"/>
+              </a:rPr>
+              <a:t>Diagnóstico por capas antes de corregir código — verificar con herramientas externas primero</a:t>
+            </a:r>
+            <a:endParaRPr lang="en-US" sz="1800" dirty="0"/>
+          </a:p>
+          <a:p>
+            <a:pPr indent="0" marL="0">
+              <a:spcAft>
+                <a:spcPts val="1000"/>
+              </a:spcAft>
+              <a:buNone/>
+            </a:pPr>
+            <a:r>
+              <a:rPr lang="en-US" sz="1800" i="1" dirty="0">
+                <a:solidFill>
+                  <a:srgbClr val="F72585"/>
+                </a:solidFill>
+                <a:latin typeface="Calibri" pitchFamily="34" charset="0"/>
+                <a:ea typeface="Calibri" pitchFamily="34" charset="-122"/>
+                <a:cs typeface="Calibri" pitchFamily="34" charset="-120"/>
+              </a:rPr>
+              <a:t>“Cambio de proceso, no de intención”</a:t>
+            </a:r>
+            <a:endParaRPr lang="en-US" sz="1800" dirty="0"/>
+          </a:p>
+        </p:txBody>
+      </p:sp>
+      <p:sp>
+        <p:nvSpPr>
+          <p:cNvPr id="8" name="Text 5"/>
           <p:cNvSpPr/>
           <p:nvPr/>
         </p:nvSpPr>
@@ -5879,7 +6905,7 @@
       </p:sp>
       <p:sp>
         <p:nvSpPr>
-          <p:cNvPr id="8" name="Text 5"/>
+          <p:cNvPr id="9" name="Text 6"/>
           <p:cNvSpPr/>
           <p:nvPr/>
         </p:nvSpPr>
@@ -5904,13 +6930,13 @@
             <a:r>
               <a:rPr lang="en-US" sz="900" b="1" dirty="0">
                 <a:solidFill>
-                  <a:srgbClr val="FFD60A"/>
-                </a:solidFill>
-                <a:latin typeface="Calibri" pitchFamily="34" charset="0"/>
-                <a:ea typeface="Calibri" pitchFamily="34" charset="-122"/>
-                <a:cs typeface="Calibri" pitchFamily="34" charset="-120"/>
-              </a:rPr>
-              <a:t>17</a:t>
+                  <a:srgbClr val="F72585"/>
+                </a:solidFill>
+                <a:latin typeface="Calibri" pitchFamily="34" charset="0"/>
+                <a:ea typeface="Calibri" pitchFamily="34" charset="-122"/>
+                <a:cs typeface="Calibri" pitchFamily="34" charset="-120"/>
+              </a:rPr>
+              <a:t>19</a:t>
             </a:r>
             <a:endParaRPr lang="en-US" sz="900" dirty="0"/>
           </a:p>
@@ -6260,6 +7286,320 @@
 </p:sld>
 </file>
 
+<file path=ppt/slides/slide20.xml><?xml version="1.0" encoding="utf-8"?>
+<p:sld xmlns:a="http://schemas.openxmlformats.org/drawingml/2006/main" xmlns:r="http://schemas.openxmlformats.org/officeDocument/2006/relationships" xmlns:p="http://schemas.openxmlformats.org/presentationml/2006/main">
+  <p:cSld name="Slide 20">
+    <p:bg>
+      <p:bgPr>
+        <a:solidFill>
+          <a:srgbClr val="0A0E17"/>
+        </a:solidFill>
+      </p:bgPr>
+    </p:bg>
+    <p:spTree>
+      <p:nvGrpSpPr>
+        <p:cNvPr id="1" name=""/>
+        <p:cNvGrpSpPr/>
+        <p:nvPr/>
+      </p:nvGrpSpPr>
+      <p:grpSpPr>
+        <a:xfrm>
+          <a:off x="0" y="0"/>
+          <a:ext cx="0" cy="0"/>
+          <a:chOff x="0" y="0"/>
+          <a:chExt cx="0" cy="0"/>
+        </a:xfrm>
+      </p:grpSpPr>
+      <p:sp>
+        <p:nvSpPr>
+          <p:cNvPr id="2" name="Shape 0"/>
+          <p:cNvSpPr/>
+          <p:nvPr/>
+        </p:nvSpPr>
+        <p:spPr>
+          <a:xfrm>
+            <a:off x="0" y="0"/>
+            <a:ext cx="164592" cy="6858000"/>
+          </a:xfrm>
+          <a:prstGeom prst="rect">
+            <a:avLst/>
+          </a:prstGeom>
+          <a:solidFill>
+            <a:srgbClr val="FFD60A"/>
+          </a:solidFill>
+          <a:ln/>
+        </p:spPr>
+      </p:sp>
+      <p:sp>
+        <p:nvSpPr>
+          <p:cNvPr id="3" name="Text 1"/>
+          <p:cNvSpPr/>
+          <p:nvPr/>
+        </p:nvSpPr>
+        <p:spPr>
+          <a:xfrm>
+            <a:off x="685800" y="502920"/>
+            <a:ext cx="10515600" cy="822960"/>
+          </a:xfrm>
+          <a:prstGeom prst="rect">
+            <a:avLst/>
+          </a:prstGeom>
+          <a:noFill/>
+          <a:ln/>
+        </p:spPr>
+        <p:txBody>
+          <a:bodyPr wrap="square" rtlCol="0" anchor="ctr"/>
+          <a:lstStyle/>
+          <a:p>
+            <a:pPr indent="0" marL="0">
+              <a:buNone/>
+            </a:pPr>
+            <a:r>
+              <a:rPr lang="en-US" sz="3400" b="1" dirty="0">
+                <a:solidFill>
+                  <a:srgbClr val="FFFFFF"/>
+                </a:solidFill>
+                <a:latin typeface="Calibri" pitchFamily="34" charset="0"/>
+                <a:ea typeface="Calibri" pitchFamily="34" charset="-122"/>
+                <a:cs typeface="Calibri" pitchFamily="34" charset="-120"/>
+              </a:rPr>
+              <a:t>Conclusiones</a:t>
+            </a:r>
+            <a:endParaRPr lang="en-US" sz="3400" dirty="0"/>
+          </a:p>
+        </p:txBody>
+      </p:sp>
+      <p:sp>
+        <p:nvSpPr>
+          <p:cNvPr id="4" name="Text 2"/>
+          <p:cNvSpPr/>
+          <p:nvPr/>
+        </p:nvSpPr>
+        <p:spPr>
+          <a:xfrm>
+            <a:off x="685800" y="1600200"/>
+            <a:ext cx="10789920" cy="3291840"/>
+          </a:xfrm>
+          <a:prstGeom prst="rect">
+            <a:avLst/>
+          </a:prstGeom>
+          <a:noFill/>
+          <a:ln/>
+        </p:spPr>
+        <p:txBody>
+          <a:bodyPr wrap="square" rtlCol="0" anchor="ctr"/>
+          <a:lstStyle/>
+          <a:p>
+            <a:pPr marL="228600" indent="-228600">
+              <a:spcAft>
+                <a:spcPts val="1400"/>
+              </a:spcAft>
+              <a:buSzPct val="100000"/>
+              <a:buChar char="●"/>
+            </a:pPr>
+            <a:r>
+              <a:rPr lang="en-US" sz="1900" dirty="0">
+                <a:solidFill>
+                  <a:srgbClr val="E7EBF7"/>
+                </a:solidFill>
+                <a:latin typeface="Calibri" pitchFamily="34" charset="0"/>
+                <a:ea typeface="Calibri" pitchFamily="34" charset="-122"/>
+                <a:cs typeface="Calibri" pitchFamily="34" charset="-120"/>
+              </a:rPr>
+              <a:t>Producto: MVP funcional completo — 10/10 User Stories, 14/14 ADR en estado Aceptado</a:t>
+            </a:r>
+            <a:endParaRPr lang="en-US" sz="1900" dirty="0"/>
+          </a:p>
+          <a:p>
+            <a:pPr marL="228600" indent="-228600">
+              <a:spcAft>
+                <a:spcPts val="1400"/>
+              </a:spcAft>
+              <a:buSzPct val="100000"/>
+              <a:buChar char="●"/>
+            </a:pPr>
+            <a:r>
+              <a:rPr lang="en-US" sz="1900" dirty="0">
+                <a:solidFill>
+                  <a:srgbClr val="E7EBF7"/>
+                </a:solidFill>
+                <a:latin typeface="Calibri" pitchFamily="34" charset="0"/>
+                <a:ea typeface="Calibri" pitchFamily="34" charset="-122"/>
+                <a:cs typeface="Calibri" pitchFamily="34" charset="-120"/>
+              </a:rPr>
+              <a:t>Un sistema multiagente gobernado por reglas explícitas no garantiza por sí solo su cumplimiento</a:t>
+            </a:r>
+            <a:endParaRPr lang="en-US" sz="1900" dirty="0"/>
+          </a:p>
+          <a:p>
+            <a:pPr marL="228600" indent="-228600">
+              <a:spcAft>
+                <a:spcPts val="1400"/>
+              </a:spcAft>
+              <a:buSzPct val="100000"/>
+              <a:buChar char="●"/>
+            </a:pPr>
+            <a:r>
+              <a:rPr lang="en-US" sz="1900" dirty="0">
+                <a:solidFill>
+                  <a:srgbClr val="E7EBF7"/>
+                </a:solidFill>
+                <a:latin typeface="Calibri" pitchFamily="34" charset="0"/>
+                <a:ea typeface="Calibri" pitchFamily="34" charset="-122"/>
+                <a:cs typeface="Calibri" pitchFamily="34" charset="-120"/>
+              </a:rPr>
+              <a:t>La gobernanza solo es verificable cuando pasa de estar descrita a estar instrumentada</a:t>
+            </a:r>
+            <a:endParaRPr lang="en-US" sz="1900" dirty="0"/>
+          </a:p>
+          <a:p>
+            <a:pPr marL="228600" indent="-228600">
+              <a:spcAft>
+                <a:spcPts val="1400"/>
+              </a:spcAft>
+              <a:buSzPct val="100000"/>
+              <a:buChar char="●"/>
+            </a:pPr>
+            <a:r>
+              <a:rPr lang="en-US" sz="1900" dirty="0">
+                <a:solidFill>
+                  <a:srgbClr val="E7EBF7"/>
+                </a:solidFill>
+                <a:latin typeface="Calibri" pitchFamily="34" charset="0"/>
+                <a:ea typeface="Calibri" pitchFamily="34" charset="-122"/>
+                <a:cs typeface="Calibri" pitchFamily="34" charset="-120"/>
+              </a:rPr>
+              <a:t>Trabajo futuro: cobertura real de tests, cerrar la brecha de Reviewer, HTTPS en producción, EAS en CI/CD</a:t>
+            </a:r>
+            <a:endParaRPr lang="en-US" sz="1900" dirty="0"/>
+          </a:p>
+        </p:txBody>
+      </p:sp>
+      <p:sp>
+        <p:nvSpPr>
+          <p:cNvPr id="5" name="Text 3"/>
+          <p:cNvSpPr/>
+          <p:nvPr/>
+        </p:nvSpPr>
+        <p:spPr>
+          <a:xfrm>
+            <a:off x="685800" y="5897880"/>
+            <a:ext cx="10515600" cy="548640"/>
+          </a:xfrm>
+          <a:prstGeom prst="rect">
+            <a:avLst/>
+          </a:prstGeom>
+          <a:noFill/>
+          <a:ln/>
+        </p:spPr>
+        <p:txBody>
+          <a:bodyPr wrap="square" rtlCol="0" anchor="ctr"/>
+          <a:lstStyle/>
+          <a:p>
+            <a:pPr indent="0" marL="0">
+              <a:buNone/>
+            </a:pPr>
+            <a:r>
+              <a:rPr lang="en-US" sz="2000" i="1" dirty="0">
+                <a:solidFill>
+                  <a:srgbClr val="FFD60A"/>
+                </a:solidFill>
+                <a:latin typeface="Calibri" pitchFamily="34" charset="0"/>
+                <a:ea typeface="Calibri" pitchFamily="34" charset="-122"/>
+                <a:cs typeface="Calibri" pitchFamily="34" charset="-120"/>
+              </a:rPr>
+              <a:t>Gracias — turno de preguntas</a:t>
+            </a:r>
+            <a:endParaRPr lang="en-US" sz="2000" dirty="0"/>
+          </a:p>
+        </p:txBody>
+      </p:sp>
+      <p:sp>
+        <p:nvSpPr>
+          <p:cNvPr id="7" name="Text 4"/>
+          <p:cNvSpPr/>
+          <p:nvPr/>
+        </p:nvSpPr>
+        <p:spPr>
+          <a:xfrm>
+            <a:off x="457200" y="6510528"/>
+            <a:ext cx="5486400" cy="274320"/>
+          </a:xfrm>
+          <a:prstGeom prst="rect">
+            <a:avLst/>
+          </a:prstGeom>
+          <a:noFill/>
+          <a:ln/>
+        </p:spPr>
+        <p:txBody>
+          <a:bodyPr wrap="square" rtlCol="0" anchor="ctr"/>
+          <a:lstStyle/>
+          <a:p>
+            <a:pPr indent="0" marL="0">
+              <a:buNone/>
+            </a:pPr>
+            <a:r>
+              <a:rPr lang="en-US" sz="900" dirty="0">
+                <a:solidFill>
+                  <a:srgbClr val="3A4059"/>
+                </a:solidFill>
+                <a:latin typeface="Calibri" pitchFamily="34" charset="0"/>
+                <a:ea typeface="Calibri" pitchFamily="34" charset="-122"/>
+                <a:cs typeface="Calibri" pitchFamily="34" charset="-120"/>
+              </a:rPr>
+              <a:t>MathMind AI -- TFM</a:t>
+            </a:r>
+            <a:endParaRPr lang="en-US" sz="900" dirty="0"/>
+          </a:p>
+        </p:txBody>
+      </p:sp>
+      <p:sp>
+        <p:nvSpPr>
+          <p:cNvPr id="8" name="Text 5"/>
+          <p:cNvSpPr/>
+          <p:nvPr/>
+        </p:nvSpPr>
+        <p:spPr>
+          <a:xfrm>
+            <a:off x="11521440" y="6510528"/>
+            <a:ext cx="457200" cy="274320"/>
+          </a:xfrm>
+          <a:prstGeom prst="rect">
+            <a:avLst/>
+          </a:prstGeom>
+          <a:noFill/>
+          <a:ln/>
+        </p:spPr>
+        <p:txBody>
+          <a:bodyPr wrap="square" rtlCol="0" anchor="ctr"/>
+          <a:lstStyle/>
+          <a:p>
+            <a:pPr algn="r" indent="0" marL="0">
+              <a:buNone/>
+            </a:pPr>
+            <a:r>
+              <a:rPr lang="en-US" sz="900" b="1" dirty="0">
+                <a:solidFill>
+                  <a:srgbClr val="FFD60A"/>
+                </a:solidFill>
+                <a:latin typeface="Calibri" pitchFamily="34" charset="0"/>
+                <a:ea typeface="Calibri" pitchFamily="34" charset="-122"/>
+                <a:cs typeface="Calibri" pitchFamily="34" charset="-120"/>
+              </a:rPr>
+              <a:t>20</a:t>
+            </a:r>
+            <a:endParaRPr lang="en-US" sz="900" dirty="0"/>
+          </a:p>
+        </p:txBody>
+      </p:sp>
+    </p:spTree>
+  </p:cSld>
+  <p:clrMapOvr>
+    <a:masterClrMapping/>
+  </p:clrMapOvr>
+</p:sld>
+</file>
+
 <file path=ppt/slides/slide3.xml><?xml version="1.0" encoding="utf-8"?>
 <p:sld xmlns:a="http://schemas.openxmlformats.org/drawingml/2006/main" xmlns:r="http://schemas.openxmlformats.org/officeDocument/2006/relationships" xmlns:p="http://schemas.openxmlformats.org/presentationml/2006/main">
   <p:cSld name="Slide 3">
@@ -6994,7 +8334,7 @@
                 <a:ea typeface="Calibri" pitchFamily="34" charset="-122"/>
                 <a:cs typeface="Calibri" pitchFamily="34" charset="-120"/>
               </a:rPr>
-              <a:t>7 User Stories (US-001 a US-007) — todas implementadas, MVP funcional completo</a:t>
+              <a:t>10 User Stories (US-001 a US-010) — todas implementadas, MVP funcional completo</a:t>
             </a:r>
             <a:endParaRPr lang="en-US" sz="1800" dirty="0"/>
           </a:p>

</xml_diff>

<commit_message>
docs: guarda la version del pptx recomprimida por PowerPoint tras revision manual
Sin cambios de contenido (verificado: 20 slides, 20 notas, 5 imagenes,
mismas cifras corregidas) -- PowerPoint recomprime el archivo al
abrirlo/cerrarlo, distinto byte a byte del que genera pptxgenjs pero
identico en contenido.

Co-Authored-By: Claude Sonnet 5 <noreply@anthropic.com>
</commit_message>
<xml_diff>
--- a/docs/TFM_Presentacion.pptx
+++ b/docs/TFM_Presentacion.pptx
@@ -4,6 +4,9 @@
   <p:sldMasterIdLst>
     <p:sldMasterId id="2147483648" r:id="rId1"/>
   </p:sldMasterIdLst>
+  <p:notesMasterIdLst>
+    <p:notesMasterId r:id="rId22"/>
+  </p:notesMasterIdLst>
   <p:sldIdLst>
     <p:sldId id="256" r:id="rId2"/>
     <p:sldId id="257" r:id="rId3"/>
@@ -26,11 +29,8 @@
     <p:sldId id="274" r:id="rId20"/>
     <p:sldId id="275" r:id="rId21"/>
   </p:sldIdLst>
-  <p:notesMasterIdLst>
-    <p:notesMasterId r:id="rId22"/>
-  </p:notesMasterIdLst>
-  <p:sldSz cx="12191695" cy="6858000"/>
-  <p:notesSz cx="6858000" cy="12191695"/>
+  <p:sldSz cx="12192000" cy="6858000"/>
+  <p:notesSz cx="6858000" cy="12192000"/>
   <p:defaultTextStyle>
     <a:lvl1pPr marL="0" algn="l" defTabSz="914400" rtl="0" eaLnBrk="1" latinLnBrk="0" hangingPunct="1">
       <a:defRPr sz="1800" kern="1200">
@@ -123,6 +123,11 @@
       </a:defRPr>
     </a:lvl9pPr>
   </p:defaultTextStyle>
+  <p:extLst>
+    <p:ext uri="{EFAFB233-063F-42B5-8137-9DF3F51BA10A}">
+      <p15:sldGuideLst xmlns:p15="http://schemas.microsoft.com/office/powerpoint/2012/main"/>
+    </p:ext>
+  </p:extLst>
 </p:presentation>
 </file>
 
@@ -148,234 +153,10 @@
           <a:chExt cx="0" cy="0"/>
         </a:xfrm>
       </p:grpSpPr>
-      <p:sp>
-        <p:nvSpPr>
-          <p:cNvPr id="2" name="Header Placeholder 1"/>
-          <p:cNvSpPr>
-            <a:spLocks noGrp="1"/>
-          </p:cNvSpPr>
-          <p:nvPr>
-            <p:ph type="hdr" sz="quarter"/>
-          </p:nvPr>
-        </p:nvSpPr>
-        <p:spPr>
-          <a:xfrm>
-            <a:off x="0" y="0"/>
-            <a:ext cx="2971800" cy="458788"/>
-          </a:xfrm>
-          <a:prstGeom prst="rect">
-            <a:avLst/>
-          </a:prstGeom>
-        </p:spPr>
-        <p:txBody>
-          <a:bodyPr vert="horz" lIns="91440" tIns="45720" rIns="91440" bIns="45720" rtlCol="0"/>
-          <a:lstStyle>
-            <a:lvl1pPr algn="l">
-              <a:defRPr sz="1200"/>
-            </a:lvl1pPr>
-          </a:lstStyle>
-          <a:p>
-            <a:endParaRPr lang="en-US"/>
-          </a:p>
-        </p:txBody>
-      </p:sp>
-      <p:sp>
-        <p:nvSpPr>
-          <p:cNvPr id="3" name="Date Placeholder 2"/>
-          <p:cNvSpPr>
-            <a:spLocks noGrp="1"/>
-          </p:cNvSpPr>
-          <p:nvPr>
-            <p:ph type="dt" idx="1"/>
-          </p:nvPr>
-        </p:nvSpPr>
-        <p:spPr>
-          <a:xfrm>
-            <a:off x="3884613" y="0"/>
-            <a:ext cx="2971800" cy="458788"/>
-          </a:xfrm>
-          <a:prstGeom prst="rect">
-            <a:avLst/>
-          </a:prstGeom>
-        </p:spPr>
-        <p:txBody>
-          <a:bodyPr vert="horz" lIns="91440" tIns="45720" rIns="91440" bIns="45720" rtlCol="0"/>
-          <a:lstStyle>
-            <a:lvl1pPr algn="r">
-              <a:defRPr sz="1200"/>
-            </a:lvl1pPr>
-          </a:lstStyle>
-          <a:p>
-            <a:fld id="{5282F153-3F37-0F45-9E97-73ACFA13230C}" type="datetimeFigureOut">
-              <a:rPr lang="en-US"/>
-              <a:t>7/23/19</a:t>
-            </a:fld>
-            <a:endParaRPr lang="en-US"/>
-          </a:p>
-        </p:txBody>
-      </p:sp>
-      <p:sp>
-        <p:nvSpPr>
-          <p:cNvPr id="4" name="Slide Image Placeholder 3"/>
-          <p:cNvSpPr>
-            <a:spLocks noGrp="1" noRot="1" noChangeAspect="1"/>
-          </p:cNvSpPr>
-          <p:nvPr>
-            <p:ph type="sldImg" idx="2"/>
-          </p:nvPr>
-        </p:nvSpPr>
-        <p:spPr>
-          <a:xfrm>
-            <a:off x="685800" y="1143000"/>
-            <a:ext cx="5486400" cy="3086100"/>
-          </a:xfrm>
-          <a:prstGeom prst="rect">
-            <a:avLst/>
-          </a:prstGeom>
-          <a:noFill/>
-          <a:ln w="12700">
-            <a:solidFill>
-              <a:prstClr val="black"/>
-            </a:solidFill>
-          </a:ln>
-        </p:spPr>
-        <p:txBody>
-          <a:bodyPr vert="horz" lIns="91440" tIns="45720" rIns="91440" bIns="45720" rtlCol="0" anchor="ctr"/>
-          <a:lstStyle/>
-          <a:p>
-            <a:endParaRPr lang="en-US"/>
-          </a:p>
-        </p:txBody>
-      </p:sp>
-      <p:sp>
-        <p:nvSpPr>
-          <p:cNvPr id="5" name="Notes Placeholder 4"/>
-          <p:cNvSpPr>
-            <a:spLocks noGrp="1"/>
-          </p:cNvSpPr>
-          <p:nvPr>
-            <p:ph type="body" sz="quarter" idx="3"/>
-          </p:nvPr>
-        </p:nvSpPr>
-        <p:spPr>
-          <a:xfrm>
-            <a:off x="685800" y="4400550"/>
-            <a:ext cx="5486400" cy="3600450"/>
-          </a:xfrm>
-          <a:prstGeom prst="rect">
-            <a:avLst/>
-          </a:prstGeom>
-        </p:spPr>
-        <p:txBody>
-          <a:bodyPr vert="horz" lIns="91440" tIns="45720" rIns="91440" bIns="45720" rtlCol="0"/>
-          <a:lstStyle/>
-          <a:p>
-            <a:pPr lvl="0"/>
-            <a:r>
-              <a:rPr lang="en-US"/>
-              <a:t>Click to edit Master text styles</a:t>
-            </a:r>
-          </a:p>
-          <a:p>
-            <a:pPr lvl="1"/>
-            <a:r>
-              <a:rPr lang="en-US"/>
-              <a:t>Second level</a:t>
-            </a:r>
-          </a:p>
-          <a:p>
-            <a:pPr lvl="2"/>
-            <a:r>
-              <a:rPr lang="en-US"/>
-              <a:t>Third level</a:t>
-            </a:r>
-          </a:p>
-          <a:p>
-            <a:pPr lvl="3"/>
-            <a:r>
-              <a:rPr lang="en-US"/>
-              <a:t>Fourth level</a:t>
-            </a:r>
-          </a:p>
-          <a:p>
-            <a:pPr lvl="4"/>
-            <a:r>
-              <a:rPr lang="en-US"/>
-              <a:t>Fifth level</a:t>
-            </a:r>
-          </a:p>
-        </p:txBody>
-      </p:sp>
-      <p:sp>
-        <p:nvSpPr>
-          <p:cNvPr id="6" name="Footer Placeholder 5"/>
-          <p:cNvSpPr>
-            <a:spLocks noGrp="1"/>
-          </p:cNvSpPr>
-          <p:nvPr>
-            <p:ph type="ftr" sz="quarter" idx="4"/>
-          </p:nvPr>
-        </p:nvSpPr>
-        <p:spPr>
-          <a:xfrm>
-            <a:off x="0" y="8685213"/>
-            <a:ext cx="2971800" cy="458787"/>
-          </a:xfrm>
-          <a:prstGeom prst="rect">
-            <a:avLst/>
-          </a:prstGeom>
-        </p:spPr>
-        <p:txBody>
-          <a:bodyPr vert="horz" lIns="91440" tIns="45720" rIns="91440" bIns="45720" rtlCol="0" anchor="b"/>
-          <a:lstStyle>
-            <a:lvl1pPr algn="l">
-              <a:defRPr sz="1200"/>
-            </a:lvl1pPr>
-          </a:lstStyle>
-          <a:p>
-            <a:endParaRPr lang="en-US"/>
-          </a:p>
-        </p:txBody>
-      </p:sp>
-      <p:sp>
-        <p:nvSpPr>
-          <p:cNvPr id="7" name="Slide Number Placeholder 6"/>
-          <p:cNvSpPr>
-            <a:spLocks noGrp="1"/>
-          </p:cNvSpPr>
-          <p:nvPr>
-            <p:ph type="sldNum" sz="quarter" idx="5"/>
-          </p:nvPr>
-        </p:nvSpPr>
-        <p:spPr>
-          <a:xfrm>
-            <a:off x="3884613" y="8685213"/>
-            <a:ext cx="2971800" cy="458787"/>
-          </a:xfrm>
-          <a:prstGeom prst="rect">
-            <a:avLst/>
-          </a:prstGeom>
-        </p:spPr>
-        <p:txBody>
-          <a:bodyPr vert="horz" lIns="91440" tIns="45720" rIns="91440" bIns="45720" rtlCol="0" anchor="b"/>
-          <a:lstStyle>
-            <a:lvl1pPr algn="r">
-              <a:defRPr sz="1200"/>
-            </a:lvl1pPr>
-          </a:lstStyle>
-          <a:p>
-            <a:fld id="{CE5E9CC1-C706-0F49-92D6-E571CC5EEA8F}" type="slidenum">
-              <a:rPr lang="en-US"/>
-              <a:t>‹#›</a:t>
-            </a:fld>
-            <a:endParaRPr lang="en-US"/>
-          </a:p>
-        </p:txBody>
-      </p:sp>
     </p:spTree>
     <p:extLst>
       <p:ext uri="{BB962C8B-B14F-4D97-AF65-F5344CB8AC3E}">
-        <p14:creationId xmlns:p14="http://schemas.microsoft.com/office/powerpoint/2010/main" val="1024086991"/>
+        <p14:creationId xmlns:p14="http://schemas.microsoft.com/office/powerpoint/2010/main" val="2176496867"/>
       </p:ext>
     </p:extLst>
   </p:cSld>
@@ -523,7 +304,6 @@
               <a:rPr lang="en-US" dirty="0"/>
               <a:t>Presentación en dos capas, como el propio TFM: el producto (una app real, funcional, con 4 niveles académicos) y el proceso (cómo se construyó, con agentes de IA especializados gobernados por reglas explícitas y medidos con datos, no solo descritos).</a:t>
             </a:r>
-            <a:endParaRPr lang="en-US" dirty="0"/>
           </a:p>
         </p:txBody>
       </p:sp>
@@ -611,7 +391,6 @@
               <a:rPr lang="en-US" dirty="0"/>
               <a:t>ADR-004 formaliza lo que estaba disperso. No modelar ExercisePool como entidad evita duplicar el mismo dato (difficulty) en dos sitios sincronizados. La invariante de type coincidente parece obvia sobre el papel, pero no se aplicaba en el código real hasta el incidente #62 (slide 17) — ejemplo directo de la brecha entre "documentado" e "implementado".</a:t>
             </a:r>
-            <a:endParaRPr lang="en-US" dirty="0"/>
           </a:p>
         </p:txBody>
       </p:sp>
@@ -699,7 +478,6 @@
               <a:rPr lang="en-US" dirty="0"/>
               <a:t>La primera versión de seguridad era un paquete de 5 ADRs pensado para Vault/RBAC/Zero Trust — sobredimensionado para un TFM sin esa infraestructura. Se sustituyó por un ADR-012 único, proporcional al riesgo real. El pipeline de CI/CD es real y se ejecuta en cada push — incluida una corrección muy reciente (19-20 de agosto) de un desajuste en el trust policy de OIDC, ejemplo de iteración sobre infraestructura real.</a:t>
             </a:r>
-            <a:endParaRPr lang="en-US" dirty="0"/>
           </a:p>
         </p:txBody>
       </p:sp>
@@ -787,7 +565,6 @@
               <a:rPr lang="en-US" dirty="0"/>
               <a:t>Aquí empieza el segundo objeto de estudio del TFM. 8 agentes operativos con responsabilidades y restricciones explícitas — Test no puede implementar código productivo, Developer no puede crear código sin tests previos. El QA Agent se eliminó deliberadamente (ADR-002). Esta diapositiva es la promesa de diseño — las siguientes muestran qué pasó al contrastarla contra la realidad.</a:t>
             </a:r>
-            <a:endParaRPr lang="en-US" dirty="0"/>
           </a:p>
         </p:txBody>
       </p:sp>
@@ -875,7 +652,6 @@
               <a:rPr lang="en-US" dirty="0"/>
               <a:t>Antes de ver qué falló, quiero dejar claro qué reglas aplican a todos los agentes por igual, sin excepción de rol. La más importante para mí es la primera: si hay conflicto entre lo que dice un ADR y lo que pide un prompt puntual, gana el ADR, siempre. Suena obvio, pero es justo la regla que evita que un agente "convenza" al sistema de saltarse una decisión ya tomada. La TDD Enforcement Rule tampoco es un checklist de calidad — forma parte de la arquitectura del sistema, no del proceso: no hay implementación sin test antes. Y la regla de reutilización se verifica con un grep antes de crear nada nuevo, no de memoria.</a:t>
             </a:r>
-            <a:endParaRPr lang="en-US" dirty="0"/>
           </a:p>
         </p:txBody>
       </p:sp>
@@ -963,7 +739,6 @@
               <a:rPr lang="en-US" dirty="0"/>
               <a:t>Slide de impacto argumental número 1. El fallo no fue de diseño — el flujo estaba bien pensado. El fallo fue que no existía ningún punto de control mecánico que impidiera saltárselo. Lección explícita del proyecto: la solución no fue "tener más cuidado", fue cambiar el proceso para que saltarse un paso sea visible y bloqueante.</a:t>
             </a:r>
-            <a:endParaRPr lang="en-US" dirty="0"/>
           </a:p>
         </p:txBody>
       </p:sp>
@@ -1051,7 +826,6 @@
               <a:rPr lang="en-US" dirty="0"/>
               <a:t>Las skills del sistema siempre definieron secciones "KPIs" — pero ninguna se medía, porque la trazabilidad era prosa libre no consultable. Paso de gobernanza descrita a gobernanza instrumentada. La migración fue retroactiva a propósito, sobre toda la historia del proyecto, para tener un baseline de KPIs desde el día 1.</a:t>
             </a:r>
-            <a:endParaRPr lang="en-US" dirty="0"/>
           </a:p>
         </p:txBody>
       </p:sp>
@@ -1139,7 +913,6 @@
               <a:rPr lang="en-US" dirty="0"/>
               <a:t>Slide central de la defensa. Incluso después de introducir el Contrato de Handoff, el flujo obligatorio de 7 fases no se cumplió completo en ninguna tarea real del proyecto. Reviewer sigue siendo el eslabón más débil. Lectura honesta: esto no es un fracaso del sistema — es la prueba de que medir en vez de solo describir permite saber esto con certeza.</a:t>
             </a:r>
-            <a:endParaRPr lang="en-US" dirty="0"/>
           </a:p>
         </p:txBody>
       </p:sp>
@@ -1227,7 +1000,6 @@
               <a:rPr lang="en-US" dirty="0"/>
               <a:t>Cuatro categorías a propósito: seguridad, lógica de negocio, integración con IA generativa e infraestructura real de nube. Patrón común: los huecos de diseño se revelan al construir el siguiente consumidor real, no en la fase de diseño — varios se diagnosticaron verificando primero con herramientas externas (curl, la propia API de GitHub Actions) antes de tocar código.</a:t>
             </a:r>
-            <a:endParaRPr lang="en-US" dirty="0"/>
           </a:p>
         </p:txBody>
       </p:sp>
@@ -1315,7 +1087,6 @@
               <a:rPr lang="en-US" dirty="0"/>
               <a:t>No todo en este proyecto fue corregir errores, y quiero dedicar una diapositiva a lo que funcionó bien desde el principio. Para mí la más importante es la primera: los ADR nunca se reescriben, se enmiendan con fecha, así que el razonamiento original queda como evidencia aunque nos equivocáramos después. Destaco también la validación de Zod en el borde de los contratos de IA — no confiamos en que el LLM responda exactamente lo que le pedimos, lo comprobamos antes de usarlo, y eso evitó un incidente real que ya hemos visto. Y cuando una decisión previa dejó de tener sentido, como Chroma o el paquete de 5 ADR de seguridad, se cambió y se documentó por qué — nunca en silencio.</a:t>
             </a:r>
-            <a:endParaRPr lang="en-US" dirty="0"/>
           </a:p>
         </p:txBody>
       </p:sp>
@@ -1403,7 +1174,6 @@
               <a:rPr lang="en-US" dirty="0"/>
               <a:t>Si me preguntáis cuál es la lección que me llevo de todo el proyecto, es esta diapositiva. El hueco de Reviewer y Security no se cerró la primera vez — volvió a aparecer más adelante, ya en mobile-app. Y ahí entendí que la solución no podía ser "tener más cuidado la próxima vez", tenía que ser un cambio de proceso que hiciera imposible saltárselo en silencio — el contrato de handoff que ya hemos visto. El resto de patrones son más técnicos, pero todos comparten la misma idea de fondo: el problema no se ve hasta que algo real lo atraviesa, ni en el diseño ni en la revisión.</a:t>
             </a:r>
-            <a:endParaRPr lang="en-US" dirty="0"/>
           </a:p>
         </p:txBody>
       </p:sp>
@@ -1491,7 +1261,6 @@
               <a:rPr lang="en-US" dirty="0"/>
               <a:t>El objeto de estudio no es solo la app. Es demostrar que un desarrollo con agentes de IA puede seguir Clean Architecture, TDD y decisiones arquitectónicas formales (ADRs) de forma verificable — y, más importante, documentar honestamente dónde ese proceso falló y qué mecanismo se introdujo para corregirlo. Esa segunda parte es el aporte académico más defendible, y se detalla en los bloques 12-19.</a:t>
             </a:r>
-            <a:endParaRPr lang="en-US" dirty="0"/>
           </a:p>
         </p:txBody>
       </p:sp>
@@ -1579,7 +1348,6 @@
               <a:rPr lang="en-US" dirty="0"/>
               <a:t>Cierre con las dos caras del TFM a la vez: el producto se puede usar de principio a fin hoy mismo, y el proceso que lo construyó queda documentado con evidencia medible, no solo con buenas intenciones. Los errores documentados no son un fracaso — son el material de evidencia principal. Abrir turno de preguntas.</a:t>
             </a:r>
-            <a:endParaRPr lang="en-US" dirty="0"/>
           </a:p>
         </p:txBody>
       </p:sp>
@@ -1667,7 +1435,6 @@
               <a:rPr lang="en-US" dirty="0"/>
               <a:t>README.md lo resume así. La distinción Test/Resolución no es solo de UI — cambia el contrato de datos (Exercise.options solo existe en Test) y el sistema de pistas (solo aplica en Resolución). Esa regla de negocio está modelada como invariante de dominio, no como un if disperso en el código.</a:t>
             </a:r>
-            <a:endParaRPr lang="en-US" dirty="0"/>
           </a:p>
         </p:txBody>
       </p:sp>
@@ -1755,7 +1522,6 @@
               <a:rPr lang="en-US" dirty="0"/>
               <a:t>Cada flecha del diagrama es una pantalla real de apps/mobile-app (Expo Router — Android, iOS y Web desde una única base de código). El catálogo de 23 Temas no es una lista estática: vive en base de datos (GET /temas), sembrado desde ADR-006. US-008 (subir material de referencia para el RAG) es la única historia que queda fuera del uso del estudiante — es una herramienta de administrador de contenido, no parte de la experiencia MVP.</a:t>
             </a:r>
-            <a:endParaRPr lang="en-US" dirty="0"/>
           </a:p>
         </p:txBody>
       </p:sp>
@@ -1843,7 +1609,6 @@
               <a:rPr lang="en-US" dirty="0"/>
               <a:t>Tres capturas reales, seguidas de principio a fin en el mismo backend real: elegir Tema y Nivel en Home, terminar la sesión y ver el Resumen (aciertos, tiempo medio, variación de rating), y el desglose acumulado en Estadísticas. Nada de esto es mockup — es el build web real (expo export) contra el backend real en local.</a:t>
             </a:r>
-            <a:endParaRPr lang="en-US" dirty="0"/>
           </a:p>
         </p:txBody>
       </p:sp>
@@ -1931,7 +1696,6 @@
               <a:rPr lang="en-US" dirty="0"/>
               <a:t>AdaptiveDifficultyEngine fue el primer componente de dominio construido con TDD real (Red→Green desde el primer commit). Es puro — sin dependencias de framework — y demostrable con 8/8 tests en verde. Aquí también entra el bug real #27 (slide 17): la semilla inicial ignoraba el nivel académico porque todos los tests usaban Secundaria por defecto, enmascarando el fallo.</a:t>
             </a:r>
-            <a:endParaRPr lang="en-US" dirty="0"/>
           </a:p>
         </p:txBody>
       </p:sp>
@@ -2019,7 +1783,6 @@
               <a:rPr lang="en-US" dirty="0"/>
               <a:t>Decisión de arquitectura documentada en README como "Estrategia de Inteligencia Artificial". El Pool de Ejercicios (ExerciseRepository.findByDifficultyBand) hace posible esto: seleccionar el siguiente ejercicio es determinista y rápido, sin llamar al LLM en el camino feliz. Solo si el pool se agota de verdad hay un flujo de última instancia (UC-008 flujo 2b) que genera bajo demanda.</a:t>
             </a:r>
-            <a:endParaRPr lang="en-US" dirty="0"/>
           </a:p>
         </p:txBody>
       </p:sp>
@@ -2107,7 +1870,6 @@
               <a:rPr lang="en-US" dirty="0"/>
               <a:t>La decisión de pgvector sobre Chroma se tomó comparando explícitamente ambas: el cliente JS de LangChain para Chroma exige un servidor HTTP aparte, sin modo embebido en Node. Con pgvector, embeddings y registro de ingesta viven en la misma base. Riesgo aceptado y documentado: el contenido ingerido es una tercera fuente de prompt injection no mitigada aún, señalada explícitamente a Security.</a:t>
             </a:r>
-            <a:endParaRPr lang="en-US" dirty="0"/>
           </a:p>
         </p:txBody>
       </p:sp>
@@ -2195,7 +1957,6 @@
               <a:rPr lang="en-US" dirty="0"/>
               <a:t>La regla de reutilización obligatoria prohíbe duplicar entidades, DTOs o utilidades entre apps — todo lo compartido vive en packages/shared-*. La elección de Prisma se ratificó explícitamente en ADR-013 (antes solo aparecía mencionada, no decidida). El backend expone una API REST documentada (openapi.yaml), consumida por mobile-app vía TanStack Query.</a:t>
             </a:r>
-            <a:endParaRPr lang="en-US" dirty="0"/>
           </a:p>
         </p:txBody>
       </p:sp>
@@ -2268,6 +2029,11 @@
 <file path=ppt/slideMasters/slideMaster1.xml><?xml version="1.0" encoding="utf-8"?>
 <p:sldMaster xmlns:a="http://schemas.openxmlformats.org/drawingml/2006/main" xmlns:r="http://schemas.openxmlformats.org/officeDocument/2006/relationships" xmlns:p="http://schemas.openxmlformats.org/presentationml/2006/main">
   <p:cSld>
+    <p:bg>
+      <p:bgRef idx="1001">
+        <a:schemeClr val="bg1"/>
+      </p:bgRef>
+    </p:bg>
     <p:spTree>
       <p:nvGrpSpPr>
         <p:cNvPr id="1" name=""/>
@@ -2550,6 +2316,7 @@
         <a:solidFill>
           <a:srgbClr val="0A0E17"/>
         </a:solidFill>
+        <a:effectLst/>
       </p:bgPr>
     </p:bg>
     <p:spTree>
@@ -2585,6 +2352,13 @@
           </a:solidFill>
           <a:ln/>
         </p:spPr>
+        <p:txBody>
+          <a:bodyPr/>
+          <a:lstStyle/>
+          <a:p>
+            <a:endParaRPr lang="es-ES"/>
+          </a:p>
+        </p:txBody>
       </p:sp>
       <p:sp>
         <p:nvSpPr>
@@ -2607,7 +2381,7 @@
           <a:bodyPr wrap="square" rtlCol="0" anchor="ctr"/>
           <a:lstStyle/>
           <a:p>
-            <a:pPr indent="0" marL="0">
+            <a:pPr marL="0" indent="0">
               <a:buNone/>
             </a:pPr>
             <a:r>
@@ -2646,7 +2420,7 @@
           <a:bodyPr wrap="square" rtlCol="0" anchor="ctr"/>
           <a:lstStyle/>
           <a:p>
-            <a:pPr indent="0" marL="0">
+            <a:pPr marL="0" indent="0">
               <a:buNone/>
             </a:pPr>
             <a:r>
@@ -2685,7 +2459,7 @@
           <a:bodyPr wrap="square" rtlCol="0" anchor="ctr"/>
           <a:lstStyle/>
           <a:p>
-            <a:pPr indent="0" marL="0">
+            <a:pPr marL="0" indent="0">
               <a:buNone/>
             </a:pPr>
             <a:r>
@@ -2697,7 +2471,7 @@
                 <a:ea typeface="Calibri" pitchFamily="34" charset="-122"/>
                 <a:cs typeface="Calibri" pitchFamily="34" charset="-120"/>
               </a:rPr>
-              <a:t>TFM · Máster en Desarrollo de Software Potenciado con IA</a:t>
+              <a:t>TFM · Máster en Desarrollo  con IA</a:t>
             </a:r>
             <a:endParaRPr lang="en-US" sz="1500" dirty="0"/>
           </a:p>
@@ -2724,7 +2498,7 @@
           <a:bodyPr wrap="square" rtlCol="0" anchor="ctr"/>
           <a:lstStyle/>
           <a:p>
-            <a:pPr indent="0" marL="0">
+            <a:pPr marL="0" indent="0">
               <a:buNone/>
             </a:pPr>
             <a:r>
@@ -2736,7 +2510,7 @@
                 <a:ea typeface="Calibri" pitchFamily="34" charset="-122"/>
                 <a:cs typeface="Calibri" pitchFamily="34" charset="-120"/>
               </a:rPr>
-              <a:t>Rubén Abad</a:t>
+              <a:t>Rubén Abad González (ruben.abad@zkteco.eu)</a:t>
             </a:r>
             <a:endParaRPr lang="en-US" sz="1500" dirty="0"/>
           </a:p>
@@ -2758,6 +2532,7 @@
         <a:solidFill>
           <a:srgbClr val="F7F9FC"/>
         </a:solidFill>
+        <a:effectLst/>
       </p:bgPr>
     </p:bg>
     <p:spTree>
@@ -2793,6 +2568,13 @@
           </a:solidFill>
           <a:ln/>
         </p:spPr>
+        <p:txBody>
+          <a:bodyPr/>
+          <a:lstStyle/>
+          <a:p>
+            <a:endParaRPr lang="es-ES"/>
+          </a:p>
+        </p:txBody>
       </p:sp>
       <p:sp>
         <p:nvSpPr>
@@ -2815,11 +2597,11 @@
           <a:bodyPr wrap="square" rtlCol="0" anchor="ctr"/>
           <a:lstStyle/>
           <a:p>
-            <a:pPr indent="0" marL="0">
+            <a:pPr marL="0" indent="0">
               <a:buNone/>
             </a:pPr>
             <a:r>
-              <a:rPr lang="en-US" sz="1200" b="1" spc="200" kern="0" dirty="0">
+              <a:rPr lang="en-US" sz="1200" b="1" kern="0" spc="200" dirty="0">
                 <a:solidFill>
                   <a:srgbClr val="A855F7"/>
                 </a:solidFill>
@@ -2854,7 +2636,7 @@
           <a:bodyPr wrap="square" rtlCol="0" anchor="ctr"/>
           <a:lstStyle/>
           <a:p>
-            <a:pPr indent="0" marL="0">
+            <a:pPr marL="0" indent="0">
               <a:buNone/>
             </a:pPr>
             <a:r>
@@ -2894,6 +2676,13 @@
             <a:prstDash val="solid"/>
           </a:ln>
         </p:spPr>
+        <p:txBody>
+          <a:bodyPr/>
+          <a:lstStyle/>
+          <a:p>
+            <a:endParaRPr lang="es-ES"/>
+          </a:p>
+        </p:txBody>
       </p:sp>
       <p:sp>
         <p:nvSpPr>
@@ -3022,7 +2811,7 @@
           <a:bodyPr wrap="square" rtlCol="0" anchor="ctr"/>
           <a:lstStyle/>
           <a:p>
-            <a:pPr indent="0" marL="0">
+            <a:pPr marL="0" indent="0">
               <a:buNone/>
             </a:pPr>
             <a:r>
@@ -3061,7 +2850,7 @@
           <a:bodyPr wrap="square" rtlCol="0" anchor="ctr"/>
           <a:lstStyle/>
           <a:p>
-            <a:pPr algn="r" indent="0" marL="0">
+            <a:pPr marL="0" indent="0" algn="r">
               <a:buNone/>
             </a:pPr>
             <a:r>
@@ -3095,6 +2884,7 @@
         <a:solidFill>
           <a:srgbClr val="F7F9FC"/>
         </a:solidFill>
+        <a:effectLst/>
       </p:bgPr>
     </p:bg>
     <p:spTree>
@@ -3130,6 +2920,13 @@
           </a:solidFill>
           <a:ln/>
         </p:spPr>
+        <p:txBody>
+          <a:bodyPr/>
+          <a:lstStyle/>
+          <a:p>
+            <a:endParaRPr lang="es-ES"/>
+          </a:p>
+        </p:txBody>
       </p:sp>
       <p:sp>
         <p:nvSpPr>
@@ -3152,11 +2949,11 @@
           <a:bodyPr wrap="square" rtlCol="0" anchor="ctr"/>
           <a:lstStyle/>
           <a:p>
-            <a:pPr indent="0" marL="0">
+            <a:pPr marL="0" indent="0">
               <a:buNone/>
             </a:pPr>
             <a:r>
-              <a:rPr lang="en-US" sz="1200" b="1" spc="200" kern="0" dirty="0">
+              <a:rPr lang="en-US" sz="1200" b="1" kern="0" spc="200" dirty="0">
                 <a:solidFill>
                   <a:srgbClr val="A855F7"/>
                 </a:solidFill>
@@ -3191,7 +2988,7 @@
           <a:bodyPr wrap="square" rtlCol="0" anchor="ctr"/>
           <a:lstStyle/>
           <a:p>
-            <a:pPr indent="0" marL="0">
+            <a:pPr marL="0" indent="0">
               <a:buNone/>
             </a:pPr>
             <a:r>
@@ -3231,6 +3028,13 @@
             <a:prstDash val="solid"/>
           </a:ln>
         </p:spPr>
+        <p:txBody>
+          <a:bodyPr/>
+          <a:lstStyle/>
+          <a:p>
+            <a:endParaRPr lang="es-ES"/>
+          </a:p>
+        </p:txBody>
       </p:sp>
       <p:sp>
         <p:nvSpPr>
@@ -3338,7 +3142,7 @@
           <a:bodyPr wrap="square" rtlCol="0" anchor="ctr"/>
           <a:lstStyle/>
           <a:p>
-            <a:pPr indent="0" marL="0">
+            <a:pPr marL="0" indent="0">
               <a:buNone/>
             </a:pPr>
             <a:r>
@@ -3377,7 +3181,7 @@
           <a:bodyPr wrap="square" rtlCol="0" anchor="ctr"/>
           <a:lstStyle/>
           <a:p>
-            <a:pPr algn="r" indent="0" marL="0">
+            <a:pPr marL="0" indent="0" algn="r">
               <a:buNone/>
             </a:pPr>
             <a:r>
@@ -3411,6 +3215,7 @@
         <a:solidFill>
           <a:srgbClr val="F7F9FC"/>
         </a:solidFill>
+        <a:effectLst/>
       </p:bgPr>
     </p:bg>
     <p:spTree>
@@ -3446,6 +3251,13 @@
           </a:solidFill>
           <a:ln/>
         </p:spPr>
+        <p:txBody>
+          <a:bodyPr/>
+          <a:lstStyle/>
+          <a:p>
+            <a:endParaRPr lang="es-ES"/>
+          </a:p>
+        </p:txBody>
       </p:sp>
       <p:sp>
         <p:nvSpPr>
@@ -3468,11 +3280,11 @@
           <a:bodyPr wrap="square" rtlCol="0" anchor="ctr"/>
           <a:lstStyle/>
           <a:p>
-            <a:pPr indent="0" marL="0">
+            <a:pPr marL="0" indent="0">
               <a:buNone/>
             </a:pPr>
             <a:r>
-              <a:rPr lang="en-US" sz="1200" b="1" spc="200" kern="0" dirty="0">
+              <a:rPr lang="en-US" sz="1200" b="1" kern="0" spc="200" dirty="0">
                 <a:solidFill>
                   <a:srgbClr val="F72585"/>
                 </a:solidFill>
@@ -3507,7 +3319,7 @@
           <a:bodyPr wrap="square" rtlCol="0" anchor="ctr"/>
           <a:lstStyle/>
           <a:p>
-            <a:pPr indent="0" marL="0">
+            <a:pPr marL="0" indent="0">
               <a:buNone/>
             </a:pPr>
             <a:r>
@@ -3547,6 +3359,13 @@
             <a:prstDash val="solid"/>
           </a:ln>
         </p:spPr>
+        <p:txBody>
+          <a:bodyPr/>
+          <a:lstStyle/>
+          <a:p>
+            <a:endParaRPr lang="es-ES"/>
+          </a:p>
+        </p:txBody>
       </p:sp>
       <p:sp>
         <p:nvSpPr>
@@ -3611,7 +3430,7 @@
             <a:endParaRPr lang="en-US" sz="1800" dirty="0"/>
           </a:p>
           <a:p>
-            <a:pPr indent="0" marL="0">
+            <a:pPr marL="0" indent="0">
               <a:spcAft>
                 <a:spcPts val="1000"/>
               </a:spcAft>
@@ -3674,7 +3493,7 @@
           <a:bodyPr wrap="square" rtlCol="0" anchor="ctr"/>
           <a:lstStyle/>
           <a:p>
-            <a:pPr indent="0" marL="0">
+            <a:pPr marL="0" indent="0">
               <a:buNone/>
             </a:pPr>
             <a:r>
@@ -3713,7 +3532,7 @@
           <a:bodyPr wrap="square" rtlCol="0" anchor="ctr"/>
           <a:lstStyle/>
           <a:p>
-            <a:pPr algn="r" indent="0" marL="0">
+            <a:pPr marL="0" indent="0" algn="r">
               <a:buNone/>
             </a:pPr>
             <a:r>
@@ -3747,6 +3566,7 @@
         <a:solidFill>
           <a:srgbClr val="F7F9FC"/>
         </a:solidFill>
+        <a:effectLst/>
       </p:bgPr>
     </p:bg>
     <p:spTree>
@@ -3782,6 +3602,13 @@
           </a:solidFill>
           <a:ln/>
         </p:spPr>
+        <p:txBody>
+          <a:bodyPr/>
+          <a:lstStyle/>
+          <a:p>
+            <a:endParaRPr lang="es-ES"/>
+          </a:p>
+        </p:txBody>
       </p:sp>
       <p:sp>
         <p:nvSpPr>
@@ -3804,11 +3631,11 @@
           <a:bodyPr wrap="square" rtlCol="0" anchor="ctr"/>
           <a:lstStyle/>
           <a:p>
-            <a:pPr indent="0" marL="0">
+            <a:pPr marL="0" indent="0">
               <a:buNone/>
             </a:pPr>
             <a:r>
-              <a:rPr lang="en-US" sz="1200" b="1" spc="200" kern="0" dirty="0">
+              <a:rPr lang="en-US" sz="1200" b="1" kern="0" spc="200" dirty="0">
                 <a:solidFill>
                   <a:srgbClr val="F72585"/>
                 </a:solidFill>
@@ -3843,7 +3670,7 @@
           <a:bodyPr wrap="square" rtlCol="0" anchor="ctr"/>
           <a:lstStyle/>
           <a:p>
-            <a:pPr indent="0" marL="0">
+            <a:pPr marL="0" indent="0">
               <a:buNone/>
             </a:pPr>
             <a:r>
@@ -3883,6 +3710,13 @@
             <a:prstDash val="solid"/>
           </a:ln>
         </p:spPr>
+        <p:txBody>
+          <a:bodyPr/>
+          <a:lstStyle/>
+          <a:p>
+            <a:endParaRPr lang="es-ES"/>
+          </a:p>
+        </p:txBody>
       </p:sp>
       <p:sp>
         <p:nvSpPr>
@@ -3926,7 +3760,7 @@
             <a:endParaRPr lang="en-US" sz="1800" dirty="0"/>
           </a:p>
           <a:p>
-            <a:pPr lvl="1" marL="685800" indent="-342900">
+            <a:pPr marL="685800" lvl="1" indent="-342900">
               <a:spcAft>
                 <a:spcPts val="1200"/>
               </a:spcAft>
@@ -4032,7 +3866,7 @@
           <a:bodyPr wrap="square" rtlCol="0" anchor="ctr"/>
           <a:lstStyle/>
           <a:p>
-            <a:pPr indent="0" marL="0">
+            <a:pPr marL="0" indent="0">
               <a:buNone/>
             </a:pPr>
             <a:r>
@@ -4071,7 +3905,7 @@
           <a:bodyPr wrap="square" rtlCol="0" anchor="ctr"/>
           <a:lstStyle/>
           <a:p>
-            <a:pPr algn="r" indent="0" marL="0">
+            <a:pPr marL="0" indent="0" algn="r">
               <a:buNone/>
             </a:pPr>
             <a:r>
@@ -4105,6 +3939,7 @@
         <a:solidFill>
           <a:srgbClr val="F7F9FC"/>
         </a:solidFill>
+        <a:effectLst/>
       </p:bgPr>
     </p:bg>
     <p:spTree>
@@ -4140,6 +3975,13 @@
           </a:solidFill>
           <a:ln/>
         </p:spPr>
+        <p:txBody>
+          <a:bodyPr/>
+          <a:lstStyle/>
+          <a:p>
+            <a:endParaRPr lang="es-ES"/>
+          </a:p>
+        </p:txBody>
       </p:sp>
       <p:sp>
         <p:nvSpPr>
@@ -4162,11 +4004,11 @@
           <a:bodyPr wrap="square" rtlCol="0" anchor="ctr"/>
           <a:lstStyle/>
           <a:p>
-            <a:pPr indent="0" marL="0">
+            <a:pPr marL="0" indent="0">
               <a:buNone/>
             </a:pPr>
             <a:r>
-              <a:rPr lang="en-US" sz="1200" b="1" spc="200" kern="0" dirty="0">
+              <a:rPr lang="en-US" sz="1200" b="1" kern="0" spc="200" dirty="0">
                 <a:solidFill>
                   <a:srgbClr val="F72585"/>
                 </a:solidFill>
@@ -4201,7 +4043,7 @@
           <a:bodyPr wrap="square" rtlCol="0" anchor="ctr"/>
           <a:lstStyle/>
           <a:p>
-            <a:pPr indent="0" marL="0">
+            <a:pPr marL="0" indent="0">
               <a:buNone/>
             </a:pPr>
             <a:r>
@@ -4241,6 +4083,13 @@
             <a:prstDash val="solid"/>
           </a:ln>
         </p:spPr>
+        <p:txBody>
+          <a:bodyPr/>
+          <a:lstStyle/>
+          <a:p>
+            <a:endParaRPr lang="es-ES"/>
+          </a:p>
+        </p:txBody>
       </p:sp>
       <p:sp>
         <p:nvSpPr>
@@ -4263,7 +4112,7 @@
           <a:bodyPr wrap="square" rtlCol="0" anchor="t"/>
           <a:lstStyle/>
           <a:p>
-            <a:pPr indent="0" marL="0">
+            <a:pPr marL="0" indent="0">
               <a:spcAft>
                 <a:spcPts val="1000"/>
               </a:spcAft>
@@ -4304,7 +4153,7 @@
             <a:endParaRPr lang="en-US" sz="1800" dirty="0"/>
           </a:p>
           <a:p>
-            <a:pPr lvl="1" marL="685800" indent="-342900">
+            <a:pPr marL="685800" lvl="1" indent="-342900">
               <a:spcAft>
                 <a:spcPts val="1200"/>
               </a:spcAft>
@@ -4368,7 +4217,7 @@
           <a:bodyPr wrap="square" rtlCol="0" anchor="ctr"/>
           <a:lstStyle/>
           <a:p>
-            <a:pPr indent="0" marL="0">
+            <a:pPr marL="0" indent="0">
               <a:buNone/>
             </a:pPr>
             <a:r>
@@ -4407,7 +4256,7 @@
           <a:bodyPr wrap="square" rtlCol="0" anchor="ctr"/>
           <a:lstStyle/>
           <a:p>
-            <a:pPr algn="r" indent="0" marL="0">
+            <a:pPr marL="0" indent="0" algn="r">
               <a:buNone/>
             </a:pPr>
             <a:r>
@@ -4441,6 +4290,7 @@
         <a:solidFill>
           <a:srgbClr val="F7F9FC"/>
         </a:solidFill>
+        <a:effectLst/>
       </p:bgPr>
     </p:bg>
     <p:spTree>
@@ -4476,6 +4326,13 @@
           </a:solidFill>
           <a:ln/>
         </p:spPr>
+        <p:txBody>
+          <a:bodyPr/>
+          <a:lstStyle/>
+          <a:p>
+            <a:endParaRPr lang="es-ES"/>
+          </a:p>
+        </p:txBody>
       </p:sp>
       <p:sp>
         <p:nvSpPr>
@@ -4498,11 +4355,11 @@
           <a:bodyPr wrap="square" rtlCol="0" anchor="ctr"/>
           <a:lstStyle/>
           <a:p>
-            <a:pPr indent="0" marL="0">
+            <a:pPr marL="0" indent="0">
               <a:buNone/>
             </a:pPr>
             <a:r>
-              <a:rPr lang="en-US" sz="1200" b="1" spc="200" kern="0" dirty="0">
+              <a:rPr lang="en-US" sz="1200" b="1" kern="0" spc="200" dirty="0">
                 <a:solidFill>
                   <a:srgbClr val="F72585"/>
                 </a:solidFill>
@@ -4537,7 +4394,7 @@
           <a:bodyPr wrap="square" rtlCol="0" anchor="ctr"/>
           <a:lstStyle/>
           <a:p>
-            <a:pPr indent="0" marL="0">
+            <a:pPr marL="0" indent="0">
               <a:buNone/>
             </a:pPr>
             <a:r>
@@ -4577,6 +4434,13 @@
             <a:prstDash val="solid"/>
           </a:ln>
         </p:spPr>
+        <p:txBody>
+          <a:bodyPr/>
+          <a:lstStyle/>
+          <a:p>
+            <a:endParaRPr lang="es-ES"/>
+          </a:p>
+        </p:txBody>
       </p:sp>
       <p:sp>
         <p:nvSpPr>
@@ -4636,9 +4500,138 @@
                 <a:ea typeface="Calibri" pitchFamily="34" charset="-122"/>
                 <a:cs typeface="Calibri" pitchFamily="34" charset="-120"/>
               </a:rPr>
-              <a:t>ADR-017 (evolución, 2026-08-10): front-matter YAML sobre cada entrada (task_id, flujo, agentes, estado…)</a:t>
-            </a:r>
-            <a:endParaRPr lang="en-US" sz="1800" dirty="0"/>
+              <a:t>ADR-017 (evolución, 2026-08-10): front-matter YAML sobre cada entrada (task_id, flujo, agentes, </a:t>
+            </a:r>
+            <a:r>
+              <a:rPr lang="en-US" sz="1800" dirty="0" err="1">
+                <a:solidFill>
+                  <a:srgbClr val="15192B"/>
+                </a:solidFill>
+                <a:latin typeface="Calibri" pitchFamily="34" charset="0"/>
+                <a:ea typeface="Calibri" pitchFamily="34" charset="-122"/>
+                <a:cs typeface="Calibri" pitchFamily="34" charset="-120"/>
+              </a:rPr>
+              <a:t>estado</a:t>
+            </a:r>
+            <a:r>
+              <a:rPr lang="en-US" sz="1800" dirty="0">
+                <a:solidFill>
+                  <a:srgbClr val="15192B"/>
+                </a:solidFill>
+                <a:latin typeface="Calibri" pitchFamily="34" charset="0"/>
+                <a:ea typeface="Calibri" pitchFamily="34" charset="-122"/>
+                <a:cs typeface="Calibri" pitchFamily="34" charset="-120"/>
+              </a:rPr>
+              <a:t>…)</a:t>
+            </a:r>
+          </a:p>
+          <a:p>
+            <a:r>
+              <a:rPr lang="es-ES" b="1" dirty="0"/>
+              <a:t>	</a:t>
+            </a:r>
+            <a:r>
+              <a:rPr lang="es-ES" sz="1100" b="1" dirty="0"/>
+              <a:t>---</a:t>
+            </a:r>
+            <a:endParaRPr lang="es-ES" sz="1100" dirty="0"/>
+          </a:p>
+          <a:p>
+            <a:r>
+              <a:rPr lang="es-ES" sz="1100" dirty="0"/>
+              <a:t>	</a:t>
+            </a:r>
+            <a:r>
+              <a:rPr lang="es-ES" sz="1100" dirty="0" err="1"/>
+              <a:t>task_id</a:t>
+            </a:r>
+            <a:r>
+              <a:rPr lang="es-ES" sz="1100" dirty="0"/>
+              <a:t>: STATUS-064</a:t>
+            </a:r>
+          </a:p>
+          <a:p>
+            <a:r>
+              <a:rPr lang="es-ES" sz="1100" dirty="0"/>
+              <a:t>	date: 2026-08-21</a:t>
+            </a:r>
+          </a:p>
+          <a:p>
+            <a:r>
+              <a:rPr lang="es-ES" sz="1100" dirty="0"/>
+              <a:t>	</a:t>
+            </a:r>
+            <a:r>
+              <a:rPr lang="es-ES" sz="1100" dirty="0" err="1"/>
+              <a:t>handoff_ref</a:t>
+            </a:r>
+            <a:r>
+              <a:rPr lang="es-ES" sz="1100" dirty="0"/>
+              <a:t>: STATUS-064</a:t>
+            </a:r>
+          </a:p>
+          <a:p>
+            <a:r>
+              <a:rPr lang="es-ES" sz="1100" dirty="0"/>
+              <a:t>	agentes: [</a:t>
+            </a:r>
+            <a:r>
+              <a:rPr lang="es-ES" sz="1100" dirty="0" err="1"/>
+              <a:t>architecture</a:t>
+            </a:r>
+            <a:r>
+              <a:rPr lang="es-ES" sz="1100" dirty="0"/>
+              <a:t>]</a:t>
+            </a:r>
+          </a:p>
+          <a:p>
+            <a:r>
+              <a:rPr lang="es-ES" sz="1100" dirty="0"/>
+              <a:t>	flujo: [director, </a:t>
+            </a:r>
+            <a:r>
+              <a:rPr lang="es-ES" sz="1100" dirty="0" err="1"/>
+              <a:t>product</a:t>
+            </a:r>
+            <a:r>
+              <a:rPr lang="es-ES" sz="1100" dirty="0"/>
+              <a:t>, </a:t>
+            </a:r>
+            <a:r>
+              <a:rPr lang="es-ES" sz="1100" dirty="0" err="1"/>
+              <a:t>architecture</a:t>
+            </a:r>
+            <a:r>
+              <a:rPr lang="es-ES" sz="1100" dirty="0"/>
+              <a:t>]</a:t>
+            </a:r>
+          </a:p>
+          <a:p>
+            <a:r>
+              <a:rPr lang="es-ES" sz="1100" dirty="0"/>
+              <a:t>	artefactos: [</a:t>
+            </a:r>
+            <a:r>
+              <a:rPr lang="es-ES" sz="1100" dirty="0" err="1"/>
+              <a:t>docs</a:t>
+            </a:r>
+            <a:r>
+              <a:rPr lang="es-ES" sz="1100" dirty="0"/>
+              <a:t>/ADR/ADR-015_mobile_app_screens.md]</a:t>
+            </a:r>
+          </a:p>
+          <a:p>
+            <a:r>
+              <a:rPr lang="es-ES" sz="1100" dirty="0"/>
+              <a:t>	estado: done</a:t>
+            </a:r>
+          </a:p>
+          <a:p>
+            <a:r>
+              <a:rPr lang="es-ES" sz="1100" b="1" dirty="0"/>
+              <a:t>	---</a:t>
+            </a:r>
+            <a:endParaRPr lang="es-ES" sz="1100" dirty="0"/>
           </a:p>
           <a:p>
             <a:pPr marL="228600" indent="-228600">
@@ -4649,6 +4642,17 @@
               <a:buChar char="●"/>
             </a:pPr>
             <a:r>
+              <a:rPr lang="en-US" sz="1800" dirty="0" err="1">
+                <a:solidFill>
+                  <a:srgbClr val="15192B"/>
+                </a:solidFill>
+                <a:latin typeface="Calibri" pitchFamily="34" charset="0"/>
+                <a:ea typeface="Calibri" pitchFamily="34" charset="-122"/>
+                <a:cs typeface="Calibri" pitchFamily="34" charset="-120"/>
+              </a:rPr>
+              <a:t>Migración</a:t>
+            </a:r>
+            <a:r>
               <a:rPr lang="en-US" sz="1800" dirty="0">
                 <a:solidFill>
                   <a:srgbClr val="15192B"/>
@@ -4657,7 +4661,7 @@
                 <a:ea typeface="Calibri" pitchFamily="34" charset="-122"/>
                 <a:cs typeface="Calibri" pitchFamily="34" charset="-120"/>
               </a:rPr>
-              <a:t>Migración retroactiva completa: 86/86 entradas migradas, 49 tareas distintas</a:t>
+              <a:t> retroactiva completa: 86/86 entradas migradas, 49 tareas distintas</a:t>
             </a:r>
             <a:endParaRPr lang="en-US" sz="1800" dirty="0"/>
           </a:p>
@@ -4705,7 +4709,7 @@
           <a:bodyPr wrap="square" rtlCol="0" anchor="ctr"/>
           <a:lstStyle/>
           <a:p>
-            <a:pPr indent="0" marL="0">
+            <a:pPr marL="0" indent="0">
               <a:buNone/>
             </a:pPr>
             <a:r>
@@ -4744,7 +4748,7 @@
           <a:bodyPr wrap="square" rtlCol="0" anchor="ctr"/>
           <a:lstStyle/>
           <a:p>
-            <a:pPr algn="r" indent="0" marL="0">
+            <a:pPr marL="0" indent="0" algn="r">
               <a:buNone/>
             </a:pPr>
             <a:r>
@@ -4778,6 +4782,7 @@
         <a:solidFill>
           <a:srgbClr val="F7F9FC"/>
         </a:solidFill>
+        <a:effectLst/>
       </p:bgPr>
     </p:bg>
     <p:spTree>
@@ -4813,6 +4818,13 @@
           </a:solidFill>
           <a:ln/>
         </p:spPr>
+        <p:txBody>
+          <a:bodyPr/>
+          <a:lstStyle/>
+          <a:p>
+            <a:endParaRPr lang="es-ES"/>
+          </a:p>
+        </p:txBody>
       </p:sp>
       <p:sp>
         <p:nvSpPr>
@@ -4835,11 +4847,11 @@
           <a:bodyPr wrap="square" rtlCol="0" anchor="ctr"/>
           <a:lstStyle/>
           <a:p>
-            <a:pPr indent="0" marL="0">
+            <a:pPr marL="0" indent="0">
               <a:buNone/>
             </a:pPr>
             <a:r>
-              <a:rPr lang="en-US" sz="1200" b="1" spc="200" kern="0" dirty="0">
+              <a:rPr lang="en-US" sz="1200" b="1" kern="0" spc="200" dirty="0">
                 <a:solidFill>
                   <a:srgbClr val="F72585"/>
                 </a:solidFill>
@@ -4874,7 +4886,7 @@
           <a:bodyPr wrap="square" rtlCol="0" anchor="ctr"/>
           <a:lstStyle/>
           <a:p>
-            <a:pPr indent="0" marL="0">
+            <a:pPr marL="0" indent="0">
               <a:buNone/>
             </a:pPr>
             <a:r>
@@ -4914,6 +4926,13 @@
             <a:prstDash val="solid"/>
           </a:ln>
         </p:spPr>
+        <p:txBody>
+          <a:bodyPr/>
+          <a:lstStyle/>
+          <a:p>
+            <a:endParaRPr lang="es-ES"/>
+          </a:p>
+        </p:txBody>
       </p:sp>
       <p:graphicFrame>
         <p:nvGraphicFramePr>
@@ -4924,7 +4943,7 @@
           <p:nvPr>
             <p:extLst>
               <p:ext uri="{D42A27DB-BD31-4B8C-83A1-F6EECF244321}">
-                <p14:modId xmlns:p14="http://schemas.microsoft.com/office/powerpoint/2010/main" val="1579011935"/>
+                <p14:modId xmlns:p14="http://schemas.microsoft.com/office/powerpoint/2010/main" val="4239378646"/>
               </p:ext>
             </p:extLst>
           </p:nvPr>
@@ -4938,8 +4957,20 @@
             <a:tbl>
               <a:tblPr/>
               <a:tblGrid>
-                <a:gridCol w="5577840"/>
-                <a:gridCol w="5577840"/>
+                <a:gridCol w="5577840">
+                  <a:extLst>
+                    <a:ext uri="{9D8B030D-6E8A-4147-A177-3AD203B41FA5}">
+                      <a16:colId xmlns:a16="http://schemas.microsoft.com/office/drawing/2014/main" val="20000"/>
+                    </a:ext>
+                  </a:extLst>
+                </a:gridCol>
+                <a:gridCol w="5577840">
+                  <a:extLst>
+                    <a:ext uri="{9D8B030D-6E8A-4147-A177-3AD203B41FA5}">
+                      <a16:colId xmlns:a16="http://schemas.microsoft.com/office/drawing/2014/main" val="20001"/>
+                    </a:ext>
+                  </a:extLst>
+                </a:gridCol>
               </a:tblGrid>
               <a:tr h="518160">
                 <a:tc>
@@ -4947,7 +4978,7 @@
                     <a:bodyPr/>
                     <a:lstStyle/>
                     <a:p>
-                      <a:pPr indent="0" marL="0">
+                      <a:pPr marL="0" indent="0">
                         <a:buNone/>
                       </a:pPr>
                       <a:r>
@@ -4968,7 +4999,7 @@
                       </a:endParaRPr>
                     </a:p>
                   </a:txBody>
-                  <a:tcPr marL="91440" marR="91440" marT="45720" marB="45720" anchor="ctr">
+                  <a:tcPr anchor="ctr">
                     <a:lnL w="6350" cap="flat" cmpd="sng" algn="ctr">
                       <a:solidFill>
                         <a:srgbClr val="D7DCE8"/>
@@ -5015,7 +5046,7 @@
                     <a:bodyPr/>
                     <a:lstStyle/>
                     <a:p>
-                      <a:pPr indent="0" marL="0">
+                      <a:pPr marL="0" indent="0">
                         <a:buNone/>
                       </a:pPr>
                       <a:r>
@@ -5036,7 +5067,7 @@
                       </a:endParaRPr>
                     </a:p>
                   </a:txBody>
-                  <a:tcPr marL="91440" marR="91440" marT="45720" marB="45720" anchor="ctr">
+                  <a:tcPr anchor="ctr">
                     <a:lnL w="6350" cap="flat" cmpd="sng" algn="ctr">
                       <a:solidFill>
                         <a:srgbClr val="D7DCE8"/>
@@ -5078,6 +5109,11 @@
                     </a:solidFill>
                   </a:tcPr>
                 </a:tc>
+                <a:extLst>
+                  <a:ext uri="{0D108BD9-81ED-4DB2-BD59-A6C34878D82A}">
+                    <a16:rowId xmlns:a16="http://schemas.microsoft.com/office/drawing/2014/main" val="10000"/>
+                  </a:ext>
+                </a:extLst>
               </a:tr>
               <a:tr h="518160">
                 <a:tc>
@@ -5085,7 +5121,7 @@
                     <a:bodyPr/>
                     <a:lstStyle/>
                     <a:p>
-                      <a:pPr indent="0" marL="0">
+                      <a:pPr marL="0" indent="0">
                         <a:buNone/>
                       </a:pPr>
                       <a:r>
@@ -5106,7 +5142,7 @@
                       </a:endParaRPr>
                     </a:p>
                   </a:txBody>
-                  <a:tcPr marL="91440" marR="91440" marT="45720" marB="45720" anchor="ctr">
+                  <a:tcPr anchor="ctr">
                     <a:lnL w="6350" cap="flat" cmpd="sng" algn="ctr">
                       <a:solidFill>
                         <a:srgbClr val="D7DCE8"/>
@@ -5153,7 +5189,7 @@
                     <a:bodyPr/>
                     <a:lstStyle/>
                     <a:p>
-                      <a:pPr indent="0" marL="0">
+                      <a:pPr marL="0" indent="0">
                         <a:buNone/>
                       </a:pPr>
                       <a:r>
@@ -5165,7 +5201,7 @@
                           <a:ea typeface="Calibri" pitchFamily="34" charset="-122"/>
                           <a:cs typeface="Calibri" pitchFamily="34" charset="-120"/>
                         </a:rPr>
-                        <a:t>8,2% (4/49)</a:t>
+                        <a:t>962% (5/52)</a:t>
                       </a:r>
                       <a:endParaRPr lang="en-US" sz="1500" dirty="0">
                         <a:latin typeface="Calibri" charset="0"/>
@@ -5174,7 +5210,7 @@
                       </a:endParaRPr>
                     </a:p>
                   </a:txBody>
-                  <a:tcPr marL="91440" marR="91440" marT="45720" marB="45720" anchor="ctr">
+                  <a:tcPr anchor="ctr">
                     <a:lnL w="6350" cap="flat" cmpd="sng" algn="ctr">
                       <a:solidFill>
                         <a:srgbClr val="D7DCE8"/>
@@ -5216,6 +5252,11 @@
                     </a:solidFill>
                   </a:tcPr>
                 </a:tc>
+                <a:extLst>
+                  <a:ext uri="{0D108BD9-81ED-4DB2-BD59-A6C34878D82A}">
+                    <a16:rowId xmlns:a16="http://schemas.microsoft.com/office/drawing/2014/main" val="10001"/>
+                  </a:ext>
+                </a:extLst>
               </a:tr>
               <a:tr h="518160">
                 <a:tc>
@@ -5223,7 +5264,7 @@
                     <a:bodyPr/>
                     <a:lstStyle/>
                     <a:p>
-                      <a:pPr indent="0" marL="0">
+                      <a:pPr marL="0" indent="0">
                         <a:buNone/>
                       </a:pPr>
                       <a:r>
@@ -5244,7 +5285,7 @@
                       </a:endParaRPr>
                     </a:p>
                   </a:txBody>
-                  <a:tcPr marL="91440" marR="91440" marT="45720" marB="45720" anchor="ctr">
+                  <a:tcPr anchor="ctr">
                     <a:lnL w="6350" cap="flat" cmpd="sng" algn="ctr">
                       <a:solidFill>
                         <a:srgbClr val="D7DCE8"/>
@@ -5291,7 +5332,7 @@
                     <a:bodyPr/>
                     <a:lstStyle/>
                     <a:p>
-                      <a:pPr indent="0" marL="0">
+                      <a:pPr marL="0" indent="0">
                         <a:buNone/>
                       </a:pPr>
                       <a:r>
@@ -5303,7 +5344,7 @@
                           <a:ea typeface="Calibri" pitchFamily="34" charset="-122"/>
                           <a:cs typeface="Calibri" pitchFamily="34" charset="-120"/>
                         </a:rPr>
-                        <a:t>4,1% (2/49)</a:t>
+                        <a:t>7,7% (4/52)</a:t>
                       </a:r>
                       <a:endParaRPr lang="en-US" sz="1500" dirty="0">
                         <a:latin typeface="Calibri" charset="0"/>
@@ -5312,7 +5353,7 @@
                       </a:endParaRPr>
                     </a:p>
                   </a:txBody>
-                  <a:tcPr marL="91440" marR="91440" marT="45720" marB="45720" anchor="ctr">
+                  <a:tcPr anchor="ctr">
                     <a:lnL w="6350" cap="flat" cmpd="sng" algn="ctr">
                       <a:solidFill>
                         <a:srgbClr val="D7DCE8"/>
@@ -5354,6 +5395,11 @@
                     </a:solidFill>
                   </a:tcPr>
                 </a:tc>
+                <a:extLst>
+                  <a:ext uri="{0D108BD9-81ED-4DB2-BD59-A6C34878D82A}">
+                    <a16:rowId xmlns:a16="http://schemas.microsoft.com/office/drawing/2014/main" val="10002"/>
+                  </a:ext>
+                </a:extLst>
               </a:tr>
               <a:tr h="518160">
                 <a:tc>
@@ -5361,7 +5407,7 @@
                     <a:bodyPr/>
                     <a:lstStyle/>
                     <a:p>
-                      <a:pPr indent="0" marL="0">
+                      <a:pPr marL="0" indent="0">
                         <a:buNone/>
                       </a:pPr>
                       <a:r>
@@ -5382,7 +5428,7 @@
                       </a:endParaRPr>
                     </a:p>
                   </a:txBody>
-                  <a:tcPr marL="91440" marR="91440" marT="45720" marB="45720" anchor="ctr">
+                  <a:tcPr anchor="ctr">
                     <a:lnL w="6350" cap="flat" cmpd="sng" algn="ctr">
                       <a:solidFill>
                         <a:srgbClr val="D7DCE8"/>
@@ -5429,7 +5475,7 @@
                     <a:bodyPr/>
                     <a:lstStyle/>
                     <a:p>
-                      <a:pPr indent="0" marL="0">
+                      <a:pPr marL="0" indent="0">
                         <a:buNone/>
                       </a:pPr>
                       <a:r>
@@ -5441,7 +5487,7 @@
                           <a:ea typeface="Calibri" pitchFamily="34" charset="-122"/>
                           <a:cs typeface="Calibri" pitchFamily="34" charset="-120"/>
                         </a:rPr>
-                        <a:t>16,3% (8/49)</a:t>
+                        <a:t>19,2%(10/52)</a:t>
                       </a:r>
                       <a:endParaRPr lang="en-US" sz="1500" dirty="0">
                         <a:latin typeface="Calibri" charset="0"/>
@@ -5450,7 +5496,7 @@
                       </a:endParaRPr>
                     </a:p>
                   </a:txBody>
-                  <a:tcPr marL="91440" marR="91440" marT="45720" marB="45720" anchor="ctr">
+                  <a:tcPr anchor="ctr">
                     <a:lnL w="6350" cap="flat" cmpd="sng" algn="ctr">
                       <a:solidFill>
                         <a:srgbClr val="D7DCE8"/>
@@ -5492,6 +5538,11 @@
                     </a:solidFill>
                   </a:tcPr>
                 </a:tc>
+                <a:extLst>
+                  <a:ext uri="{0D108BD9-81ED-4DB2-BD59-A6C34878D82A}">
+                    <a16:rowId xmlns:a16="http://schemas.microsoft.com/office/drawing/2014/main" val="10003"/>
+                  </a:ext>
+                </a:extLst>
               </a:tr>
               <a:tr h="518160">
                 <a:tc>
@@ -5499,7 +5550,7 @@
                     <a:bodyPr/>
                     <a:lstStyle/>
                     <a:p>
-                      <a:pPr indent="0" marL="0">
+                      <a:pPr marL="0" indent="0">
                         <a:buNone/>
                       </a:pPr>
                       <a:r>
@@ -5520,7 +5571,7 @@
                       </a:endParaRPr>
                     </a:p>
                   </a:txBody>
-                  <a:tcPr marL="91440" marR="91440" marT="45720" marB="45720" anchor="ctr">
+                  <a:tcPr anchor="ctr">
                     <a:lnL w="6350" cap="flat" cmpd="sng" algn="ctr">
                       <a:solidFill>
                         <a:srgbClr val="D7DCE8"/>
@@ -5567,11 +5618,11 @@
                     <a:bodyPr/>
                     <a:lstStyle/>
                     <a:p>
-                      <a:pPr indent="0" marL="0">
+                      <a:pPr marL="0" indent="0">
                         <a:buNone/>
                       </a:pPr>
                       <a:r>
-                        <a:rPr lang="en-US" sz="1500" b="1" dirty="0">
+                        <a:rPr lang="es-ES" sz="1500" b="1" dirty="0">
                           <a:solidFill>
                             <a:srgbClr val="F72585"/>
                           </a:solidFill>
@@ -5579,7 +5630,7 @@
                           <a:ea typeface="Calibri" pitchFamily="34" charset="-122"/>
                           <a:cs typeface="Calibri" pitchFamily="34" charset="-120"/>
                         </a:rPr>
-                        <a:t>0,0% (0/49)</a:t>
+                        <a:t>1.9% (1/52) — solape medio 28.0%</a:t>
                       </a:r>
                       <a:endParaRPr lang="en-US" sz="1500" dirty="0">
                         <a:latin typeface="Calibri" charset="0"/>
@@ -5588,7 +5639,7 @@
                       </a:endParaRPr>
                     </a:p>
                   </a:txBody>
-                  <a:tcPr marL="91440" marR="91440" marT="45720" marB="45720" anchor="ctr">
+                  <a:tcPr anchor="ctr">
                     <a:lnL w="6350" cap="flat" cmpd="sng" algn="ctr">
                       <a:solidFill>
                         <a:srgbClr val="D7DCE8"/>
@@ -5630,6 +5681,11 @@
                     </a:solidFill>
                   </a:tcPr>
                 </a:tc>
+                <a:extLst>
+                  <a:ext uri="{0D108BD9-81ED-4DB2-BD59-A6C34878D82A}">
+                    <a16:rowId xmlns:a16="http://schemas.microsoft.com/office/drawing/2014/main" val="10004"/>
+                  </a:ext>
+                </a:extLst>
               </a:tr>
               <a:tr h="518160">
                 <a:tc>
@@ -5637,7 +5693,7 @@
                     <a:bodyPr/>
                     <a:lstStyle/>
                     <a:p>
-                      <a:pPr indent="0" marL="0">
+                      <a:pPr marL="0" indent="0">
                         <a:buNone/>
                       </a:pPr>
                       <a:r>
@@ -5658,7 +5714,7 @@
                       </a:endParaRPr>
                     </a:p>
                   </a:txBody>
-                  <a:tcPr marL="91440" marR="91440" marT="45720" marB="45720" anchor="ctr">
+                  <a:tcPr anchor="ctr">
                     <a:lnL w="6350" cap="flat" cmpd="sng" algn="ctr">
                       <a:solidFill>
                         <a:srgbClr val="D7DCE8"/>
@@ -5705,7 +5761,7 @@
                     <a:bodyPr/>
                     <a:lstStyle/>
                     <a:p>
-                      <a:pPr indent="0" marL="0">
+                      <a:pPr marL="0" indent="0">
                         <a:buNone/>
                       </a:pPr>
                       <a:r>
@@ -5726,7 +5782,7 @@
                       </a:endParaRPr>
                     </a:p>
                   </a:txBody>
-                  <a:tcPr marL="91440" marR="91440" marT="45720" marB="45720" anchor="ctr">
+                  <a:tcPr anchor="ctr">
                     <a:lnL w="6350" cap="flat" cmpd="sng" algn="ctr">
                       <a:solidFill>
                         <a:srgbClr val="D7DCE8"/>
@@ -5768,6 +5824,11 @@
                     </a:solidFill>
                   </a:tcPr>
                 </a:tc>
+                <a:extLst>
+                  <a:ext uri="{0D108BD9-81ED-4DB2-BD59-A6C34878D82A}">
+                    <a16:rowId xmlns:a16="http://schemas.microsoft.com/office/drawing/2014/main" val="10005"/>
+                  </a:ext>
+                </a:extLst>
               </a:tr>
             </a:tbl>
           </a:graphicData>
@@ -5794,9 +5855,6 @@
           <a:bodyPr wrap="square" rtlCol="0" anchor="ctr"/>
           <a:lstStyle/>
           <a:p>
-            <a:pPr indent="0" marL="0">
-              <a:buNone/>
-            </a:pPr>
             <a:r>
               <a:rPr lang="en-US" sz="1200" i="1" dirty="0">
                 <a:solidFill>
@@ -5806,7 +5864,447 @@
                 <a:ea typeface="Calibri" pitchFamily="34" charset="-122"/>
                 <a:cs typeface="Calibri" pitchFamily="34" charset="-120"/>
               </a:rPr>
-              <a:t>docs/metrics/trazabilidad.md, generado 2026-08-11 sobre 86 entradas / 49 tareas</a:t>
+              <a:t>docs/metrics/trazabilidad.md, </a:t>
+            </a:r>
+            <a:r>
+              <a:rPr lang="en-US" sz="1200" i="1" dirty="0" err="1">
+                <a:solidFill>
+                  <a:srgbClr val="3A4059"/>
+                </a:solidFill>
+                <a:latin typeface="Calibri" pitchFamily="34" charset="0"/>
+                <a:ea typeface="Calibri" pitchFamily="34" charset="-122"/>
+                <a:cs typeface="Calibri" pitchFamily="34" charset="-120"/>
+              </a:rPr>
+              <a:t>generado</a:t>
+            </a:r>
+            <a:r>
+              <a:rPr lang="en-US" sz="1200" i="1" dirty="0">
+                <a:solidFill>
+                  <a:srgbClr val="3A4059"/>
+                </a:solidFill>
+                <a:latin typeface="Calibri" pitchFamily="34" charset="0"/>
+                <a:ea typeface="Calibri" pitchFamily="34" charset="-122"/>
+                <a:cs typeface="Calibri" pitchFamily="34" charset="-120"/>
+              </a:rPr>
+              <a:t> </a:t>
+            </a:r>
+            <a:r>
+              <a:rPr lang="es-ES" sz="1200" i="1" dirty="0">
+                <a:solidFill>
+                  <a:srgbClr val="3A4059"/>
+                </a:solidFill>
+                <a:latin typeface="Calibri" pitchFamily="34" charset="0"/>
+                <a:ea typeface="Calibri" pitchFamily="34" charset="-122"/>
+                <a:cs typeface="Calibri" pitchFamily="34" charset="-120"/>
+              </a:rPr>
+              <a:t>2026-08-22</a:t>
+            </a:r>
+            <a:r>
+              <a:rPr lang="en-US" sz="1200" i="1" dirty="0">
+                <a:solidFill>
+                  <a:srgbClr val="3A4059"/>
+                </a:solidFill>
+                <a:latin typeface="Calibri" pitchFamily="34" charset="0"/>
+                <a:ea typeface="Calibri" pitchFamily="34" charset="-122"/>
+                <a:cs typeface="Calibri" pitchFamily="34" charset="-120"/>
+              </a:rPr>
+              <a:t> </a:t>
+            </a:r>
+            <a:r>
+              <a:rPr lang="en-US" sz="1200" i="1" dirty="0" err="1">
+                <a:solidFill>
+                  <a:srgbClr val="3A4059"/>
+                </a:solidFill>
+                <a:latin typeface="Calibri" pitchFamily="34" charset="0"/>
+                <a:ea typeface="Calibri" pitchFamily="34" charset="-122"/>
+                <a:cs typeface="Calibri" pitchFamily="34" charset="-120"/>
+              </a:rPr>
+              <a:t>sobre</a:t>
+            </a:r>
+            <a:r>
+              <a:rPr lang="en-US" sz="1200" i="1" dirty="0">
+                <a:solidFill>
+                  <a:srgbClr val="3A4059"/>
+                </a:solidFill>
+                <a:latin typeface="Calibri" pitchFamily="34" charset="0"/>
+                <a:ea typeface="Calibri" pitchFamily="34" charset="-122"/>
+                <a:cs typeface="Calibri" pitchFamily="34" charset="-120"/>
+              </a:rPr>
+              <a:t> 94 entradas / 52 </a:t>
+            </a:r>
+            <a:r>
+              <a:rPr lang="en-US" sz="1200" i="1" dirty="0" err="1">
+                <a:solidFill>
+                  <a:srgbClr val="3A4059"/>
+                </a:solidFill>
+                <a:latin typeface="Calibri" pitchFamily="34" charset="0"/>
+                <a:ea typeface="Calibri" pitchFamily="34" charset="-122"/>
+                <a:cs typeface="Calibri" pitchFamily="34" charset="-120"/>
+              </a:rPr>
+              <a:t>tareas</a:t>
+            </a:r>
+            <a:r>
+              <a:rPr lang="en-US" sz="1200" i="1" dirty="0">
+                <a:solidFill>
+                  <a:srgbClr val="3A4059"/>
+                </a:solidFill>
+                <a:latin typeface="Calibri" pitchFamily="34" charset="0"/>
+                <a:ea typeface="Calibri" pitchFamily="34" charset="-122"/>
+                <a:cs typeface="Calibri" pitchFamily="34" charset="-120"/>
+              </a:rPr>
+              <a:t>. Se </a:t>
+            </a:r>
+            <a:r>
+              <a:rPr lang="en-US" sz="1200" i="1" dirty="0" err="1">
+                <a:solidFill>
+                  <a:srgbClr val="3A4059"/>
+                </a:solidFill>
+                <a:latin typeface="Calibri" pitchFamily="34" charset="0"/>
+                <a:ea typeface="Calibri" pitchFamily="34" charset="-122"/>
+                <a:cs typeface="Calibri" pitchFamily="34" charset="-120"/>
+              </a:rPr>
+              <a:t>observa</a:t>
+            </a:r>
+            <a:r>
+              <a:rPr lang="en-US" sz="1200" i="1" dirty="0">
+                <a:solidFill>
+                  <a:srgbClr val="3A4059"/>
+                </a:solidFill>
+                <a:latin typeface="Calibri" pitchFamily="34" charset="0"/>
+                <a:ea typeface="Calibri" pitchFamily="34" charset="-122"/>
+                <a:cs typeface="Calibri" pitchFamily="34" charset="-120"/>
+              </a:rPr>
+              <a:t> </a:t>
+            </a:r>
+            <a:r>
+              <a:rPr lang="en-US" sz="1200" i="1" dirty="0" err="1">
+                <a:solidFill>
+                  <a:srgbClr val="3A4059"/>
+                </a:solidFill>
+                <a:latin typeface="Calibri" pitchFamily="34" charset="0"/>
+                <a:ea typeface="Calibri" pitchFamily="34" charset="-122"/>
+                <a:cs typeface="Calibri" pitchFamily="34" charset="-120"/>
+              </a:rPr>
+              <a:t>que</a:t>
+            </a:r>
+            <a:r>
+              <a:rPr lang="en-US" sz="1200" i="1" dirty="0">
+                <a:solidFill>
+                  <a:srgbClr val="3A4059"/>
+                </a:solidFill>
+                <a:latin typeface="Calibri" pitchFamily="34" charset="0"/>
+                <a:ea typeface="Calibri" pitchFamily="34" charset="-122"/>
+                <a:cs typeface="Calibri" pitchFamily="34" charset="-120"/>
+              </a:rPr>
+              <a:t> </a:t>
+            </a:r>
+            <a:r>
+              <a:rPr lang="en-US" sz="1200" i="1" dirty="0" err="1">
+                <a:solidFill>
+                  <a:srgbClr val="3A4059"/>
+                </a:solidFill>
+                <a:latin typeface="Calibri" pitchFamily="34" charset="0"/>
+                <a:ea typeface="Calibri" pitchFamily="34" charset="-122"/>
+                <a:cs typeface="Calibri" pitchFamily="34" charset="-120"/>
+              </a:rPr>
+              <a:t>falta</a:t>
+            </a:r>
+            <a:r>
+              <a:rPr lang="en-US" sz="1200" i="1" dirty="0">
+                <a:solidFill>
+                  <a:srgbClr val="3A4059"/>
+                </a:solidFill>
+                <a:latin typeface="Calibri" pitchFamily="34" charset="0"/>
+                <a:ea typeface="Calibri" pitchFamily="34" charset="-122"/>
+                <a:cs typeface="Calibri" pitchFamily="34" charset="-120"/>
+              </a:rPr>
+              <a:t> </a:t>
+            </a:r>
+            <a:r>
+              <a:rPr lang="en-US" sz="1200" i="1" dirty="0" err="1">
+                <a:solidFill>
+                  <a:srgbClr val="3A4059"/>
+                </a:solidFill>
+                <a:latin typeface="Calibri" pitchFamily="34" charset="0"/>
+                <a:ea typeface="Calibri" pitchFamily="34" charset="-122"/>
+                <a:cs typeface="Calibri" pitchFamily="34" charset="-120"/>
+              </a:rPr>
+              <a:t>ajustar</a:t>
+            </a:r>
+            <a:r>
+              <a:rPr lang="en-US" sz="1200" i="1" dirty="0">
+                <a:solidFill>
+                  <a:srgbClr val="3A4059"/>
+                </a:solidFill>
+                <a:latin typeface="Calibri" pitchFamily="34" charset="0"/>
+                <a:ea typeface="Calibri" pitchFamily="34" charset="-122"/>
+                <a:cs typeface="Calibri" pitchFamily="34" charset="-120"/>
+              </a:rPr>
+              <a:t> la norma, se </a:t>
+            </a:r>
+            <a:r>
+              <a:rPr lang="en-US" sz="1200" i="1" dirty="0" err="1">
+                <a:solidFill>
+                  <a:srgbClr val="3A4059"/>
+                </a:solidFill>
+                <a:latin typeface="Calibri" pitchFamily="34" charset="0"/>
+                <a:ea typeface="Calibri" pitchFamily="34" charset="-122"/>
+                <a:cs typeface="Calibri" pitchFamily="34" charset="-120"/>
+              </a:rPr>
+              <a:t>han</a:t>
+            </a:r>
+            <a:r>
+              <a:rPr lang="en-US" sz="1200" i="1" dirty="0">
+                <a:solidFill>
+                  <a:srgbClr val="3A4059"/>
+                </a:solidFill>
+                <a:latin typeface="Calibri" pitchFamily="34" charset="0"/>
+                <a:ea typeface="Calibri" pitchFamily="34" charset="-122"/>
+                <a:cs typeface="Calibri" pitchFamily="34" charset="-120"/>
+              </a:rPr>
+              <a:t> </a:t>
+            </a:r>
+            <a:r>
+              <a:rPr lang="en-US" sz="1200" i="1" dirty="0" err="1">
+                <a:solidFill>
+                  <a:srgbClr val="3A4059"/>
+                </a:solidFill>
+                <a:latin typeface="Calibri" pitchFamily="34" charset="0"/>
+                <a:ea typeface="Calibri" pitchFamily="34" charset="-122"/>
+                <a:cs typeface="Calibri" pitchFamily="34" charset="-120"/>
+              </a:rPr>
+              <a:t>detectado</a:t>
+            </a:r>
+            <a:r>
+              <a:rPr lang="en-US" sz="1200" i="1" dirty="0">
+                <a:solidFill>
+                  <a:srgbClr val="3A4059"/>
+                </a:solidFill>
+                <a:latin typeface="Calibri" pitchFamily="34" charset="0"/>
+                <a:ea typeface="Calibri" pitchFamily="34" charset="-122"/>
+                <a:cs typeface="Calibri" pitchFamily="34" charset="-120"/>
+              </a:rPr>
+              <a:t> </a:t>
+            </a:r>
+            <a:r>
+              <a:rPr lang="en-US" sz="1200" i="1" dirty="0" err="1">
+                <a:solidFill>
+                  <a:srgbClr val="3A4059"/>
+                </a:solidFill>
+                <a:latin typeface="Calibri" pitchFamily="34" charset="0"/>
+                <a:ea typeface="Calibri" pitchFamily="34" charset="-122"/>
+                <a:cs typeface="Calibri" pitchFamily="34" charset="-120"/>
+              </a:rPr>
+              <a:t>ocasiones</a:t>
+            </a:r>
+            <a:r>
+              <a:rPr lang="en-US" sz="1200" i="1" dirty="0">
+                <a:solidFill>
+                  <a:srgbClr val="3A4059"/>
+                </a:solidFill>
+                <a:latin typeface="Calibri" pitchFamily="34" charset="0"/>
+                <a:ea typeface="Calibri" pitchFamily="34" charset="-122"/>
+                <a:cs typeface="Calibri" pitchFamily="34" charset="-120"/>
+              </a:rPr>
+              <a:t> </a:t>
+            </a:r>
+            <a:r>
+              <a:rPr lang="en-US" sz="1200" i="1" dirty="0" err="1">
+                <a:solidFill>
+                  <a:srgbClr val="3A4059"/>
+                </a:solidFill>
+                <a:latin typeface="Calibri" pitchFamily="34" charset="0"/>
+                <a:ea typeface="Calibri" pitchFamily="34" charset="-122"/>
+                <a:cs typeface="Calibri" pitchFamily="34" charset="-120"/>
+              </a:rPr>
+              <a:t>en</a:t>
+            </a:r>
+            <a:r>
+              <a:rPr lang="en-US" sz="1200" i="1" dirty="0">
+                <a:solidFill>
+                  <a:srgbClr val="3A4059"/>
+                </a:solidFill>
+                <a:latin typeface="Calibri" pitchFamily="34" charset="0"/>
+                <a:ea typeface="Calibri" pitchFamily="34" charset="-122"/>
+                <a:cs typeface="Calibri" pitchFamily="34" charset="-120"/>
+              </a:rPr>
+              <a:t> las </a:t>
+            </a:r>
+            <a:r>
+              <a:rPr lang="en-US" sz="1200" i="1" dirty="0" err="1">
+                <a:solidFill>
+                  <a:srgbClr val="3A4059"/>
+                </a:solidFill>
+                <a:latin typeface="Calibri" pitchFamily="34" charset="0"/>
+                <a:ea typeface="Calibri" pitchFamily="34" charset="-122"/>
+                <a:cs typeface="Calibri" pitchFamily="34" charset="-120"/>
+              </a:rPr>
+              <a:t>que</a:t>
+            </a:r>
+            <a:r>
+              <a:rPr lang="en-US" sz="1200" i="1" dirty="0">
+                <a:solidFill>
+                  <a:srgbClr val="3A4059"/>
+                </a:solidFill>
+                <a:latin typeface="Calibri" pitchFamily="34" charset="0"/>
+                <a:ea typeface="Calibri" pitchFamily="34" charset="-122"/>
+                <a:cs typeface="Calibri" pitchFamily="34" charset="-120"/>
+              </a:rPr>
+              <a:t> el </a:t>
+            </a:r>
+            <a:r>
+              <a:rPr lang="en-US" sz="1200" i="1" dirty="0" err="1">
+                <a:solidFill>
+                  <a:srgbClr val="3A4059"/>
+                </a:solidFill>
+                <a:latin typeface="Calibri" pitchFamily="34" charset="0"/>
+                <a:ea typeface="Calibri" pitchFamily="34" charset="-122"/>
+                <a:cs typeface="Calibri" pitchFamily="34" charset="-120"/>
+              </a:rPr>
+              <a:t>Agente</a:t>
+            </a:r>
+            <a:r>
+              <a:rPr lang="en-US" sz="1200" i="1" dirty="0">
+                <a:solidFill>
+                  <a:srgbClr val="3A4059"/>
+                </a:solidFill>
+                <a:latin typeface="Calibri" pitchFamily="34" charset="0"/>
+                <a:ea typeface="Calibri" pitchFamily="34" charset="-122"/>
+                <a:cs typeface="Calibri" pitchFamily="34" charset="-120"/>
+              </a:rPr>
+              <a:t> no </a:t>
+            </a:r>
+            <a:r>
+              <a:rPr lang="en-US" sz="1200" i="1" dirty="0" err="1">
+                <a:solidFill>
+                  <a:srgbClr val="3A4059"/>
+                </a:solidFill>
+                <a:latin typeface="Calibri" pitchFamily="34" charset="0"/>
+                <a:ea typeface="Calibri" pitchFamily="34" charset="-122"/>
+                <a:cs typeface="Calibri" pitchFamily="34" charset="-120"/>
+              </a:rPr>
+              <a:t>mantenia</a:t>
+            </a:r>
+            <a:r>
+              <a:rPr lang="en-US" sz="1200" i="1" dirty="0">
+                <a:solidFill>
+                  <a:srgbClr val="3A4059"/>
+                </a:solidFill>
+                <a:latin typeface="Calibri" pitchFamily="34" charset="0"/>
+                <a:ea typeface="Calibri" pitchFamily="34" charset="-122"/>
+                <a:cs typeface="Calibri" pitchFamily="34" charset="-120"/>
+              </a:rPr>
+              <a:t> las </a:t>
+            </a:r>
+            <a:r>
+              <a:rPr lang="en-US" sz="1200" i="1" dirty="0" err="1">
+                <a:solidFill>
+                  <a:srgbClr val="3A4059"/>
+                </a:solidFill>
+                <a:latin typeface="Calibri" pitchFamily="34" charset="0"/>
+                <a:ea typeface="Calibri" pitchFamily="34" charset="-122"/>
+                <a:cs typeface="Calibri" pitchFamily="34" charset="-120"/>
+              </a:rPr>
+              <a:t>normas</a:t>
+            </a:r>
+            <a:r>
+              <a:rPr lang="en-US" sz="1200" i="1" dirty="0">
+                <a:solidFill>
+                  <a:srgbClr val="3A4059"/>
+                </a:solidFill>
+                <a:latin typeface="Calibri" pitchFamily="34" charset="0"/>
+                <a:ea typeface="Calibri" pitchFamily="34" charset="-122"/>
+                <a:cs typeface="Calibri" pitchFamily="34" charset="-120"/>
+              </a:rPr>
+              <a:t> </a:t>
+            </a:r>
+            <a:r>
+              <a:rPr lang="en-US" sz="1200" i="1" dirty="0" err="1">
+                <a:solidFill>
+                  <a:srgbClr val="3A4059"/>
+                </a:solidFill>
+                <a:latin typeface="Calibri" pitchFamily="34" charset="0"/>
+                <a:ea typeface="Calibri" pitchFamily="34" charset="-122"/>
+                <a:cs typeface="Calibri" pitchFamily="34" charset="-120"/>
+              </a:rPr>
+              <a:t>en</a:t>
+            </a:r>
+            <a:r>
+              <a:rPr lang="en-US" sz="1200" i="1" dirty="0">
+                <a:solidFill>
+                  <a:srgbClr val="3A4059"/>
+                </a:solidFill>
+                <a:latin typeface="Calibri" pitchFamily="34" charset="0"/>
+                <a:ea typeface="Calibri" pitchFamily="34" charset="-122"/>
+                <a:cs typeface="Calibri" pitchFamily="34" charset="-120"/>
+              </a:rPr>
+              <a:t> la </a:t>
+            </a:r>
+            <a:r>
+              <a:rPr lang="en-US" sz="1200" i="1" dirty="0" err="1">
+                <a:solidFill>
+                  <a:srgbClr val="3A4059"/>
+                </a:solidFill>
+                <a:latin typeface="Calibri" pitchFamily="34" charset="0"/>
+                <a:ea typeface="Calibri" pitchFamily="34" charset="-122"/>
+                <a:cs typeface="Calibri" pitchFamily="34" charset="-120"/>
+              </a:rPr>
+              <a:t>traza</a:t>
+            </a:r>
+            <a:r>
+              <a:rPr lang="en-US" sz="1200" i="1" dirty="0">
+                <a:solidFill>
+                  <a:srgbClr val="3A4059"/>
+                </a:solidFill>
+                <a:latin typeface="Calibri" pitchFamily="34" charset="0"/>
+                <a:ea typeface="Calibri" pitchFamily="34" charset="-122"/>
+                <a:cs typeface="Calibri" pitchFamily="34" charset="-120"/>
+              </a:rPr>
+              <a:t> del </a:t>
+            </a:r>
+            <a:r>
+              <a:rPr lang="en-US" sz="1200" i="1" dirty="0" err="1">
+                <a:solidFill>
+                  <a:srgbClr val="3A4059"/>
+                </a:solidFill>
+                <a:latin typeface="Calibri" pitchFamily="34" charset="0"/>
+                <a:ea typeface="Calibri" pitchFamily="34" charset="-122"/>
+                <a:cs typeface="Calibri" pitchFamily="34" charset="-120"/>
+              </a:rPr>
+              <a:t>flujo</a:t>
+            </a:r>
+            <a:r>
+              <a:rPr lang="en-US" sz="1200" i="1" dirty="0">
+                <a:solidFill>
+                  <a:srgbClr val="3A4059"/>
+                </a:solidFill>
+                <a:latin typeface="Calibri" pitchFamily="34" charset="0"/>
+                <a:ea typeface="Calibri" pitchFamily="34" charset="-122"/>
+                <a:cs typeface="Calibri" pitchFamily="34" charset="-120"/>
+              </a:rPr>
+              <a:t> de </a:t>
+            </a:r>
+            <a:r>
+              <a:rPr lang="en-US" sz="1200" i="1" dirty="0" err="1">
+                <a:solidFill>
+                  <a:srgbClr val="3A4059"/>
+                </a:solidFill>
+                <a:latin typeface="Calibri" pitchFamily="34" charset="0"/>
+                <a:ea typeface="Calibri" pitchFamily="34" charset="-122"/>
+                <a:cs typeface="Calibri" pitchFamily="34" charset="-120"/>
+              </a:rPr>
+              <a:t>tareas</a:t>
+            </a:r>
+            <a:r>
+              <a:rPr lang="en-US" sz="1200" i="1" dirty="0">
+                <a:solidFill>
+                  <a:srgbClr val="3A4059"/>
+                </a:solidFill>
+                <a:latin typeface="Calibri" pitchFamily="34" charset="0"/>
+                <a:ea typeface="Calibri" pitchFamily="34" charset="-122"/>
+                <a:cs typeface="Calibri" pitchFamily="34" charset="-120"/>
+              </a:rPr>
+              <a:t>.</a:t>
             </a:r>
             <a:endParaRPr lang="en-US" sz="1200" dirty="0"/>
           </a:p>
@@ -5833,7 +6331,7 @@
           <a:bodyPr wrap="square" rtlCol="0" anchor="ctr"/>
           <a:lstStyle/>
           <a:p>
-            <a:pPr indent="0" marL="0">
+            <a:pPr marL="0" indent="0">
               <a:buNone/>
             </a:pPr>
             <a:r>
@@ -5872,7 +6370,7 @@
           <a:bodyPr wrap="square" rtlCol="0" anchor="ctr"/>
           <a:lstStyle/>
           <a:p>
-            <a:pPr algn="r" indent="0" marL="0">
+            <a:pPr marL="0" indent="0" algn="r">
               <a:buNone/>
             </a:pPr>
             <a:r>
@@ -5906,6 +6404,7 @@
         <a:solidFill>
           <a:srgbClr val="F7F9FC"/>
         </a:solidFill>
+        <a:effectLst/>
       </p:bgPr>
     </p:bg>
     <p:spTree>
@@ -5941,6 +6440,13 @@
           </a:solidFill>
           <a:ln/>
         </p:spPr>
+        <p:txBody>
+          <a:bodyPr/>
+          <a:lstStyle/>
+          <a:p>
+            <a:endParaRPr lang="es-ES"/>
+          </a:p>
+        </p:txBody>
       </p:sp>
       <p:sp>
         <p:nvSpPr>
@@ -5963,11 +6469,11 @@
           <a:bodyPr wrap="square" rtlCol="0" anchor="ctr"/>
           <a:lstStyle/>
           <a:p>
-            <a:pPr indent="0" marL="0">
+            <a:pPr marL="0" indent="0">
               <a:buNone/>
             </a:pPr>
             <a:r>
-              <a:rPr lang="en-US" sz="1200" b="1" spc="200" kern="0" dirty="0">
+              <a:rPr lang="en-US" sz="1200" b="1" kern="0" spc="200" dirty="0">
                 <a:solidFill>
                   <a:srgbClr val="F72585"/>
                 </a:solidFill>
@@ -6002,7 +6508,7 @@
           <a:bodyPr wrap="square" rtlCol="0" anchor="ctr"/>
           <a:lstStyle/>
           <a:p>
-            <a:pPr indent="0" marL="0">
+            <a:pPr marL="0" indent="0">
               <a:buNone/>
             </a:pPr>
             <a:r>
@@ -6042,6 +6548,13 @@
             <a:prstDash val="solid"/>
           </a:ln>
         </p:spPr>
+        <p:txBody>
+          <a:bodyPr/>
+          <a:lstStyle/>
+          <a:p>
+            <a:endParaRPr lang="es-ES"/>
+          </a:p>
+        </p:txBody>
       </p:sp>
       <p:sp>
         <p:nvSpPr>
@@ -6063,6 +6576,297 @@
         <p:txBody>
           <a:bodyPr wrap="square" rtlCol="0" anchor="t"/>
           <a:lstStyle/>
+          <a:p>
+            <a:pPr>
+              <a:spcAft>
+                <a:spcPts val="1200"/>
+              </a:spcAft>
+              <a:buSzPct val="100000"/>
+            </a:pPr>
+            <a:r>
+              <a:rPr lang="en-US" dirty="0">
+                <a:solidFill>
+                  <a:srgbClr val="15192B"/>
+                </a:solidFill>
+                <a:latin typeface="Calibri" pitchFamily="34" charset="0"/>
+                <a:ea typeface="Calibri" pitchFamily="34" charset="-122"/>
+                <a:cs typeface="Calibri" pitchFamily="34" charset="-120"/>
+              </a:rPr>
+              <a:t>Durante la </a:t>
+            </a:r>
+            <a:r>
+              <a:rPr lang="en-US" dirty="0" err="1">
+                <a:solidFill>
+                  <a:srgbClr val="15192B"/>
+                </a:solidFill>
+                <a:latin typeface="Calibri" pitchFamily="34" charset="0"/>
+                <a:ea typeface="Calibri" pitchFamily="34" charset="-122"/>
+                <a:cs typeface="Calibri" pitchFamily="34" charset="-120"/>
+              </a:rPr>
+              <a:t>ejecución</a:t>
+            </a:r>
+            <a:r>
+              <a:rPr lang="en-US" dirty="0">
+                <a:solidFill>
+                  <a:srgbClr val="15192B"/>
+                </a:solidFill>
+                <a:latin typeface="Calibri" pitchFamily="34" charset="0"/>
+                <a:ea typeface="Calibri" pitchFamily="34" charset="-122"/>
+                <a:cs typeface="Calibri" pitchFamily="34" charset="-120"/>
+              </a:rPr>
+              <a:t> se </a:t>
+            </a:r>
+            <a:r>
+              <a:rPr lang="en-US" dirty="0" err="1">
+                <a:solidFill>
+                  <a:srgbClr val="15192B"/>
+                </a:solidFill>
+                <a:latin typeface="Calibri" pitchFamily="34" charset="0"/>
+                <a:ea typeface="Calibri" pitchFamily="34" charset="-122"/>
+                <a:cs typeface="Calibri" pitchFamily="34" charset="-120"/>
+              </a:rPr>
+              <a:t>han</a:t>
+            </a:r>
+            <a:r>
+              <a:rPr lang="en-US" dirty="0">
+                <a:solidFill>
+                  <a:srgbClr val="15192B"/>
+                </a:solidFill>
+                <a:latin typeface="Calibri" pitchFamily="34" charset="0"/>
+                <a:ea typeface="Calibri" pitchFamily="34" charset="-122"/>
+                <a:cs typeface="Calibri" pitchFamily="34" charset="-120"/>
+              </a:rPr>
+              <a:t> </a:t>
+            </a:r>
+            <a:r>
+              <a:rPr lang="en-US" dirty="0" err="1">
+                <a:solidFill>
+                  <a:srgbClr val="15192B"/>
+                </a:solidFill>
+                <a:latin typeface="Calibri" pitchFamily="34" charset="0"/>
+                <a:ea typeface="Calibri" pitchFamily="34" charset="-122"/>
+                <a:cs typeface="Calibri" pitchFamily="34" charset="-120"/>
+              </a:rPr>
+              <a:t>observado</a:t>
+            </a:r>
+            <a:r>
+              <a:rPr lang="en-US" dirty="0">
+                <a:solidFill>
+                  <a:srgbClr val="15192B"/>
+                </a:solidFill>
+                <a:latin typeface="Calibri" pitchFamily="34" charset="0"/>
+                <a:ea typeface="Calibri" pitchFamily="34" charset="-122"/>
+                <a:cs typeface="Calibri" pitchFamily="34" charset="-120"/>
+              </a:rPr>
+              <a:t> </a:t>
+            </a:r>
+            <a:r>
+              <a:rPr lang="en-US" dirty="0" err="1">
+                <a:solidFill>
+                  <a:srgbClr val="15192B"/>
+                </a:solidFill>
+                <a:latin typeface="Calibri" pitchFamily="34" charset="0"/>
+                <a:ea typeface="Calibri" pitchFamily="34" charset="-122"/>
+                <a:cs typeface="Calibri" pitchFamily="34" charset="-120"/>
+              </a:rPr>
+              <a:t>errores</a:t>
+            </a:r>
+            <a:r>
+              <a:rPr lang="en-US" dirty="0">
+                <a:solidFill>
+                  <a:srgbClr val="15192B"/>
+                </a:solidFill>
+                <a:latin typeface="Calibri" pitchFamily="34" charset="0"/>
+                <a:ea typeface="Calibri" pitchFamily="34" charset="-122"/>
+                <a:cs typeface="Calibri" pitchFamily="34" charset="-120"/>
+              </a:rPr>
+              <a:t> de </a:t>
+            </a:r>
+            <a:r>
+              <a:rPr lang="en-US" dirty="0" err="1">
+                <a:solidFill>
+                  <a:srgbClr val="15192B"/>
+                </a:solidFill>
+                <a:latin typeface="Calibri" pitchFamily="34" charset="0"/>
+                <a:ea typeface="Calibri" pitchFamily="34" charset="-122"/>
+                <a:cs typeface="Calibri" pitchFamily="34" charset="-120"/>
+              </a:rPr>
+              <a:t>implementación</a:t>
+            </a:r>
+            <a:r>
+              <a:rPr lang="en-US" dirty="0">
+                <a:solidFill>
+                  <a:srgbClr val="15192B"/>
+                </a:solidFill>
+                <a:latin typeface="Calibri" pitchFamily="34" charset="0"/>
+                <a:ea typeface="Calibri" pitchFamily="34" charset="-122"/>
+                <a:cs typeface="Calibri" pitchFamily="34" charset="-120"/>
+              </a:rPr>
+              <a:t>, no solo de Código, </a:t>
+            </a:r>
+            <a:r>
+              <a:rPr lang="en-US" dirty="0" err="1">
+                <a:solidFill>
+                  <a:srgbClr val="15192B"/>
+                </a:solidFill>
+                <a:latin typeface="Calibri" pitchFamily="34" charset="0"/>
+                <a:ea typeface="Calibri" pitchFamily="34" charset="-122"/>
+                <a:cs typeface="Calibri" pitchFamily="34" charset="-120"/>
+              </a:rPr>
+              <a:t>si</a:t>
+            </a:r>
+            <a:r>
+              <a:rPr lang="en-US" dirty="0">
+                <a:solidFill>
+                  <a:srgbClr val="15192B"/>
+                </a:solidFill>
+                <a:latin typeface="Calibri" pitchFamily="34" charset="0"/>
+                <a:ea typeface="Calibri" pitchFamily="34" charset="-122"/>
+                <a:cs typeface="Calibri" pitchFamily="34" charset="-120"/>
+              </a:rPr>
+              <a:t> no </a:t>
+            </a:r>
+            <a:r>
+              <a:rPr lang="en-US" dirty="0" err="1">
+                <a:solidFill>
+                  <a:srgbClr val="15192B"/>
+                </a:solidFill>
+                <a:latin typeface="Calibri" pitchFamily="34" charset="0"/>
+                <a:ea typeface="Calibri" pitchFamily="34" charset="-122"/>
+                <a:cs typeface="Calibri" pitchFamily="34" charset="-120"/>
+              </a:rPr>
+              <a:t>sobre</a:t>
+            </a:r>
+            <a:r>
+              <a:rPr lang="en-US" dirty="0">
+                <a:solidFill>
+                  <a:srgbClr val="15192B"/>
+                </a:solidFill>
+                <a:latin typeface="Calibri" pitchFamily="34" charset="0"/>
+                <a:ea typeface="Calibri" pitchFamily="34" charset="-122"/>
+                <a:cs typeface="Calibri" pitchFamily="34" charset="-120"/>
+              </a:rPr>
+              <a:t> </a:t>
+            </a:r>
+            <a:r>
+              <a:rPr lang="en-US" dirty="0" err="1">
+                <a:solidFill>
+                  <a:srgbClr val="15192B"/>
+                </a:solidFill>
+                <a:latin typeface="Calibri" pitchFamily="34" charset="0"/>
+                <a:ea typeface="Calibri" pitchFamily="34" charset="-122"/>
+                <a:cs typeface="Calibri" pitchFamily="34" charset="-120"/>
+              </a:rPr>
+              <a:t>todo</a:t>
+            </a:r>
+            <a:r>
+              <a:rPr lang="en-US" dirty="0">
+                <a:solidFill>
+                  <a:srgbClr val="15192B"/>
+                </a:solidFill>
+                <a:latin typeface="Calibri" pitchFamily="34" charset="0"/>
+                <a:ea typeface="Calibri" pitchFamily="34" charset="-122"/>
+                <a:cs typeface="Calibri" pitchFamily="34" charset="-120"/>
+              </a:rPr>
+              <a:t> de </a:t>
+            </a:r>
+            <a:r>
+              <a:rPr lang="en-US" dirty="0" err="1">
+                <a:solidFill>
+                  <a:srgbClr val="15192B"/>
+                </a:solidFill>
+                <a:latin typeface="Calibri" pitchFamily="34" charset="0"/>
+                <a:ea typeface="Calibri" pitchFamily="34" charset="-122"/>
+                <a:cs typeface="Calibri" pitchFamily="34" charset="-120"/>
+              </a:rPr>
+              <a:t>falta</a:t>
+            </a:r>
+            <a:r>
+              <a:rPr lang="en-US" dirty="0">
+                <a:solidFill>
+                  <a:srgbClr val="15192B"/>
+                </a:solidFill>
+                <a:latin typeface="Calibri" pitchFamily="34" charset="0"/>
+                <a:ea typeface="Calibri" pitchFamily="34" charset="-122"/>
+                <a:cs typeface="Calibri" pitchFamily="34" charset="-120"/>
+              </a:rPr>
+              <a:t> de </a:t>
+            </a:r>
+            <a:r>
+              <a:rPr lang="en-US" dirty="0" err="1">
+                <a:solidFill>
+                  <a:srgbClr val="15192B"/>
+                </a:solidFill>
+                <a:latin typeface="Calibri" pitchFamily="34" charset="0"/>
+                <a:ea typeface="Calibri" pitchFamily="34" charset="-122"/>
+                <a:cs typeface="Calibri" pitchFamily="34" charset="-120"/>
+              </a:rPr>
+              <a:t>expecificación</a:t>
+            </a:r>
+            <a:r>
+              <a:rPr lang="en-US" dirty="0">
+                <a:solidFill>
+                  <a:srgbClr val="15192B"/>
+                </a:solidFill>
+                <a:latin typeface="Calibri" pitchFamily="34" charset="0"/>
+                <a:ea typeface="Calibri" pitchFamily="34" charset="-122"/>
+                <a:cs typeface="Calibri" pitchFamily="34" charset="-120"/>
+              </a:rPr>
+              <a:t> </a:t>
+            </a:r>
+            <a:r>
+              <a:rPr lang="en-US" dirty="0" err="1">
+                <a:solidFill>
+                  <a:srgbClr val="15192B"/>
+                </a:solidFill>
+                <a:latin typeface="Calibri" pitchFamily="34" charset="0"/>
+                <a:ea typeface="Calibri" pitchFamily="34" charset="-122"/>
+                <a:cs typeface="Calibri" pitchFamily="34" charset="-120"/>
+              </a:rPr>
+              <a:t>en</a:t>
+            </a:r>
+            <a:r>
+              <a:rPr lang="en-US" dirty="0">
+                <a:solidFill>
+                  <a:srgbClr val="15192B"/>
+                </a:solidFill>
+                <a:latin typeface="Calibri" pitchFamily="34" charset="0"/>
+                <a:ea typeface="Calibri" pitchFamily="34" charset="-122"/>
+                <a:cs typeface="Calibri" pitchFamily="34" charset="-120"/>
+              </a:rPr>
+              <a:t> </a:t>
+            </a:r>
+            <a:r>
+              <a:rPr lang="en-US" dirty="0" err="1">
+                <a:solidFill>
+                  <a:srgbClr val="15192B"/>
+                </a:solidFill>
+                <a:latin typeface="Calibri" pitchFamily="34" charset="0"/>
+                <a:ea typeface="Calibri" pitchFamily="34" charset="-122"/>
+                <a:cs typeface="Calibri" pitchFamily="34" charset="-120"/>
+              </a:rPr>
+              <a:t>detalles</a:t>
+            </a:r>
+            <a:r>
+              <a:rPr lang="en-US" dirty="0">
+                <a:solidFill>
+                  <a:srgbClr val="15192B"/>
+                </a:solidFill>
+                <a:latin typeface="Calibri" pitchFamily="34" charset="0"/>
+                <a:ea typeface="Calibri" pitchFamily="34" charset="-122"/>
+                <a:cs typeface="Calibri" pitchFamily="34" charset="-120"/>
+              </a:rPr>
+              <a:t>.</a:t>
+            </a:r>
+            <a:endParaRPr lang="en-US" sz="1800" dirty="0">
+              <a:solidFill>
+                <a:srgbClr val="15192B"/>
+              </a:solidFill>
+              <a:latin typeface="Calibri" pitchFamily="34" charset="0"/>
+              <a:ea typeface="Calibri" pitchFamily="34" charset="-122"/>
+              <a:cs typeface="Calibri" pitchFamily="34" charset="-120"/>
+            </a:endParaRPr>
+          </a:p>
           <a:p>
             <a:pPr marL="228600" indent="-228600">
               <a:spcAft>
@@ -6170,7 +6974,7 @@
           <a:bodyPr wrap="square" rtlCol="0" anchor="ctr"/>
           <a:lstStyle/>
           <a:p>
-            <a:pPr indent="0" marL="0">
+            <a:pPr marL="0" indent="0">
               <a:buNone/>
             </a:pPr>
             <a:r>
@@ -6209,7 +7013,7 @@
           <a:bodyPr wrap="square" rtlCol="0" anchor="ctr"/>
           <a:lstStyle/>
           <a:p>
-            <a:pPr algn="r" indent="0" marL="0">
+            <a:pPr marL="0" indent="0" algn="r">
               <a:buNone/>
             </a:pPr>
             <a:r>
@@ -6243,6 +7047,7 @@
         <a:solidFill>
           <a:srgbClr val="F7F9FC"/>
         </a:solidFill>
+        <a:effectLst/>
       </p:bgPr>
     </p:bg>
     <p:spTree>
@@ -6278,6 +7083,13 @@
           </a:solidFill>
           <a:ln/>
         </p:spPr>
+        <p:txBody>
+          <a:bodyPr/>
+          <a:lstStyle/>
+          <a:p>
+            <a:endParaRPr lang="es-ES"/>
+          </a:p>
+        </p:txBody>
       </p:sp>
       <p:sp>
         <p:nvSpPr>
@@ -6300,11 +7112,11 @@
           <a:bodyPr wrap="square" rtlCol="0" anchor="ctr"/>
           <a:lstStyle/>
           <a:p>
-            <a:pPr indent="0" marL="0">
+            <a:pPr marL="0" indent="0">
               <a:buNone/>
             </a:pPr>
             <a:r>
-              <a:rPr lang="en-US" sz="1200" b="1" spc="200" kern="0" dirty="0">
+              <a:rPr lang="en-US" sz="1200" b="1" kern="0" spc="200" dirty="0">
                 <a:solidFill>
                   <a:srgbClr val="F72585"/>
                 </a:solidFill>
@@ -6339,7 +7151,7 @@
           <a:bodyPr wrap="square" rtlCol="0" anchor="ctr"/>
           <a:lstStyle/>
           <a:p>
-            <a:pPr indent="0" marL="0">
+            <a:pPr marL="0" indent="0">
               <a:buNone/>
             </a:pPr>
             <a:r>
@@ -6379,6 +7191,13 @@
             <a:prstDash val="solid"/>
           </a:ln>
         </p:spPr>
+        <p:txBody>
+          <a:bodyPr/>
+          <a:lstStyle/>
+          <a:p>
+            <a:endParaRPr lang="es-ES"/>
+          </a:p>
+        </p:txBody>
       </p:sp>
       <p:sp>
         <p:nvSpPr>
@@ -6528,7 +7347,7 @@
           <a:bodyPr wrap="square" rtlCol="0" anchor="ctr"/>
           <a:lstStyle/>
           <a:p>
-            <a:pPr indent="0" marL="0">
+            <a:pPr marL="0" indent="0">
               <a:buNone/>
             </a:pPr>
             <a:r>
@@ -6567,7 +7386,7 @@
           <a:bodyPr wrap="square" rtlCol="0" anchor="ctr"/>
           <a:lstStyle/>
           <a:p>
-            <a:pPr algn="r" indent="0" marL="0">
+            <a:pPr marL="0" indent="0" algn="r">
               <a:buNone/>
             </a:pPr>
             <a:r>
@@ -6601,6 +7420,7 @@
         <a:solidFill>
           <a:srgbClr val="F7F9FC"/>
         </a:solidFill>
+        <a:effectLst/>
       </p:bgPr>
     </p:bg>
     <p:spTree>
@@ -6636,6 +7456,13 @@
           </a:solidFill>
           <a:ln/>
         </p:spPr>
+        <p:txBody>
+          <a:bodyPr/>
+          <a:lstStyle/>
+          <a:p>
+            <a:endParaRPr lang="es-ES"/>
+          </a:p>
+        </p:txBody>
       </p:sp>
       <p:sp>
         <p:nvSpPr>
@@ -6658,11 +7485,11 @@
           <a:bodyPr wrap="square" rtlCol="0" anchor="ctr"/>
           <a:lstStyle/>
           <a:p>
-            <a:pPr indent="0" marL="0">
+            <a:pPr marL="0" indent="0">
               <a:buNone/>
             </a:pPr>
             <a:r>
-              <a:rPr lang="en-US" sz="1200" b="1" spc="200" kern="0" dirty="0">
+              <a:rPr lang="en-US" sz="1200" b="1" kern="0" spc="200" dirty="0">
                 <a:solidFill>
                   <a:srgbClr val="F72585"/>
                 </a:solidFill>
@@ -6697,7 +7524,7 @@
           <a:bodyPr wrap="square" rtlCol="0" anchor="ctr"/>
           <a:lstStyle/>
           <a:p>
-            <a:pPr indent="0" marL="0">
+            <a:pPr marL="0" indent="0">
               <a:buNone/>
             </a:pPr>
             <a:r>
@@ -6737,6 +7564,13 @@
             <a:prstDash val="solid"/>
           </a:ln>
         </p:spPr>
+        <p:txBody>
+          <a:bodyPr/>
+          <a:lstStyle/>
+          <a:p>
+            <a:endParaRPr lang="es-ES"/>
+          </a:p>
+        </p:txBody>
       </p:sp>
       <p:sp>
         <p:nvSpPr>
@@ -6843,7 +7677,7 @@
             <a:endParaRPr lang="en-US" sz="1800" dirty="0"/>
           </a:p>
           <a:p>
-            <a:pPr indent="0" marL="0">
+            <a:pPr marL="0" indent="0">
               <a:spcAft>
                 <a:spcPts val="1000"/>
               </a:spcAft>
@@ -6885,7 +7719,7 @@
           <a:bodyPr wrap="square" rtlCol="0" anchor="ctr"/>
           <a:lstStyle/>
           <a:p>
-            <a:pPr indent="0" marL="0">
+            <a:pPr marL="0" indent="0">
               <a:buNone/>
             </a:pPr>
             <a:r>
@@ -6924,7 +7758,7 @@
           <a:bodyPr wrap="square" rtlCol="0" anchor="ctr"/>
           <a:lstStyle/>
           <a:p>
-            <a:pPr algn="r" indent="0" marL="0">
+            <a:pPr marL="0" indent="0" algn="r">
               <a:buNone/>
             </a:pPr>
             <a:r>
@@ -6958,6 +7792,7 @@
         <a:solidFill>
           <a:srgbClr val="F7F9FC"/>
         </a:solidFill>
+        <a:effectLst/>
       </p:bgPr>
     </p:bg>
     <p:spTree>
@@ -6993,6 +7828,13 @@
           </a:solidFill>
           <a:ln/>
         </p:spPr>
+        <p:txBody>
+          <a:bodyPr/>
+          <a:lstStyle/>
+          <a:p>
+            <a:endParaRPr lang="es-ES"/>
+          </a:p>
+        </p:txBody>
       </p:sp>
       <p:sp>
         <p:nvSpPr>
@@ -7015,11 +7857,11 @@
           <a:bodyPr wrap="square" rtlCol="0" anchor="ctr"/>
           <a:lstStyle/>
           <a:p>
-            <a:pPr indent="0" marL="0">
+            <a:pPr marL="0" indent="0">
               <a:buNone/>
             </a:pPr>
             <a:r>
-              <a:rPr lang="en-US" sz="1200" b="1" spc="200" kern="0" dirty="0">
+              <a:rPr lang="en-US" sz="1200" b="1" kern="0" spc="200" dirty="0">
                 <a:solidFill>
                   <a:srgbClr val="4CC9F0"/>
                 </a:solidFill>
@@ -7054,7 +7896,7 @@
           <a:bodyPr wrap="square" rtlCol="0" anchor="ctr"/>
           <a:lstStyle/>
           <a:p>
-            <a:pPr indent="0" marL="0">
+            <a:pPr marL="0" indent="0">
               <a:buNone/>
             </a:pPr>
             <a:r>
@@ -7094,6 +7936,13 @@
             <a:prstDash val="solid"/>
           </a:ln>
         </p:spPr>
+        <p:txBody>
+          <a:bodyPr/>
+          <a:lstStyle/>
+          <a:p>
+            <a:endParaRPr lang="es-ES"/>
+          </a:p>
+        </p:txBody>
       </p:sp>
       <p:sp>
         <p:nvSpPr>
@@ -7137,7 +7986,7 @@
             <a:endParaRPr lang="en-US" sz="1800" dirty="0"/>
           </a:p>
           <a:p>
-            <a:pPr lvl="1" marL="685800" indent="-342900">
+            <a:pPr marL="685800" lvl="1" indent="-342900">
               <a:spcAft>
                 <a:spcPts val="1200"/>
               </a:spcAft>
@@ -7158,7 +8007,7 @@
             <a:endParaRPr lang="en-US" sz="1800" dirty="0"/>
           </a:p>
           <a:p>
-            <a:pPr lvl="1" marL="685800" indent="-342900">
+            <a:pPr marL="685800" lvl="1" indent="-342900">
               <a:spcAft>
                 <a:spcPts val="1200"/>
               </a:spcAft>
@@ -7179,7 +8028,7 @@
             <a:endParaRPr lang="en-US" sz="1800" dirty="0"/>
           </a:p>
           <a:p>
-            <a:pPr indent="0" marL="0">
+            <a:pPr marL="0" indent="0">
               <a:spcAft>
                 <a:spcPts val="1000"/>
               </a:spcAft>
@@ -7221,7 +8070,7 @@
           <a:bodyPr wrap="square" rtlCol="0" anchor="ctr"/>
           <a:lstStyle/>
           <a:p>
-            <a:pPr indent="0" marL="0">
+            <a:pPr marL="0" indent="0">
               <a:buNone/>
             </a:pPr>
             <a:r>
@@ -7260,7 +8109,7 @@
           <a:bodyPr wrap="square" rtlCol="0" anchor="ctr"/>
           <a:lstStyle/>
           <a:p>
-            <a:pPr algn="r" indent="0" marL="0">
+            <a:pPr marL="0" indent="0" algn="r">
               <a:buNone/>
             </a:pPr>
             <a:r>
@@ -7294,6 +8143,7 @@
         <a:solidFill>
           <a:srgbClr val="0A0E17"/>
         </a:solidFill>
+        <a:effectLst/>
       </p:bgPr>
     </p:bg>
     <p:spTree>
@@ -7329,6 +8179,13 @@
           </a:solidFill>
           <a:ln/>
         </p:spPr>
+        <p:txBody>
+          <a:bodyPr/>
+          <a:lstStyle/>
+          <a:p>
+            <a:endParaRPr lang="es-ES"/>
+          </a:p>
+        </p:txBody>
       </p:sp>
       <p:sp>
         <p:nvSpPr>
@@ -7351,7 +8208,7 @@
           <a:bodyPr wrap="square" rtlCol="0" anchor="ctr"/>
           <a:lstStyle/>
           <a:p>
-            <a:pPr indent="0" marL="0">
+            <a:pPr marL="0" indent="0">
               <a:buNone/>
             </a:pPr>
             <a:r>
@@ -7496,7 +8353,7 @@
           <a:bodyPr wrap="square" rtlCol="0" anchor="ctr"/>
           <a:lstStyle/>
           <a:p>
-            <a:pPr indent="0" marL="0">
+            <a:pPr marL="0" indent="0">
               <a:buNone/>
             </a:pPr>
             <a:r>
@@ -7508,7 +8365,7 @@
                 <a:ea typeface="Calibri" pitchFamily="34" charset="-122"/>
                 <a:cs typeface="Calibri" pitchFamily="34" charset="-120"/>
               </a:rPr>
-              <a:t>Gracias — turno de preguntas</a:t>
+              <a:t>Gracias</a:t>
             </a:r>
             <a:endParaRPr lang="en-US" sz="2000" dirty="0"/>
           </a:p>
@@ -7535,7 +8392,7 @@
           <a:bodyPr wrap="square" rtlCol="0" anchor="ctr"/>
           <a:lstStyle/>
           <a:p>
-            <a:pPr indent="0" marL="0">
+            <a:pPr marL="0" indent="0">
               <a:buNone/>
             </a:pPr>
             <a:r>
@@ -7574,7 +8431,7 @@
           <a:bodyPr wrap="square" rtlCol="0" anchor="ctr"/>
           <a:lstStyle/>
           <a:p>
-            <a:pPr algn="r" indent="0" marL="0">
+            <a:pPr marL="0" indent="0" algn="r">
               <a:buNone/>
             </a:pPr>
             <a:r>
@@ -7608,6 +8465,7 @@
         <a:solidFill>
           <a:srgbClr val="F7F9FC"/>
         </a:solidFill>
+        <a:effectLst/>
       </p:bgPr>
     </p:bg>
     <p:spTree>
@@ -7643,6 +8501,13 @@
           </a:solidFill>
           <a:ln/>
         </p:spPr>
+        <p:txBody>
+          <a:bodyPr/>
+          <a:lstStyle/>
+          <a:p>
+            <a:endParaRPr lang="es-ES"/>
+          </a:p>
+        </p:txBody>
       </p:sp>
       <p:sp>
         <p:nvSpPr>
@@ -7665,11 +8530,11 @@
           <a:bodyPr wrap="square" rtlCol="0" anchor="ctr"/>
           <a:lstStyle/>
           <a:p>
-            <a:pPr indent="0" marL="0">
+            <a:pPr marL="0" indent="0">
               <a:buNone/>
             </a:pPr>
             <a:r>
-              <a:rPr lang="en-US" sz="1200" b="1" spc="200" kern="0" dirty="0">
+              <a:rPr lang="en-US" sz="1200" b="1" kern="0" spc="200" dirty="0">
                 <a:solidFill>
                   <a:srgbClr val="4CC9F0"/>
                 </a:solidFill>
@@ -7704,7 +8569,7 @@
           <a:bodyPr wrap="square" rtlCol="0" anchor="ctr"/>
           <a:lstStyle/>
           <a:p>
-            <a:pPr indent="0" marL="0">
+            <a:pPr marL="0" indent="0">
               <a:buNone/>
             </a:pPr>
             <a:r>
@@ -7744,6 +8609,13 @@
             <a:prstDash val="solid"/>
           </a:ln>
         </p:spPr>
+        <p:txBody>
+          <a:bodyPr/>
+          <a:lstStyle/>
+          <a:p>
+            <a:endParaRPr lang="es-ES"/>
+          </a:p>
+        </p:txBody>
       </p:sp>
       <p:sp>
         <p:nvSpPr>
@@ -7771,24 +8643,31 @@
             <a:prstDash val="solid"/>
           </a:ln>
           <a:effectLst>
-            <a:outerShdw sx="100000" sy="100000" kx="0" ky="0" algn="bl" rotWithShape="0" blurRad="101600" dist="38100" dir="5400000">
+            <a:outerShdw blurRad="101600" dist="38100" dir="5400000" algn="bl" rotWithShape="0">
               <a:srgbClr val="000000">
                 <a:alpha val="25000"/>
               </a:srgbClr>
             </a:outerShdw>
           </a:effectLst>
         </p:spPr>
+        <p:txBody>
+          <a:bodyPr/>
+          <a:lstStyle/>
+          <a:p>
+            <a:endParaRPr lang="es-ES"/>
+          </a:p>
+        </p:txBody>
       </p:sp>
       <p:pic>
         <p:nvPicPr>
-          <p:cNvPr id="7" name="Image 0" descr="C:\Users\ruben.abad\AppData\Local\Temp\claude\c--Users-ruben-abad-Documents-CUrsoIA-PFM-mathMindIA-mathMindIA\76132eb8-9725-46ba-b08d-38440d8187a1\scratchpad\screenshots\01-login.png">    </p:cNvPr>
+          <p:cNvPr id="7" name="Image 0" descr="C:\Users\ruben.abad\AppData\Local\Temp\claude\c--Users-ruben-abad-Documents-CUrsoIA-PFM-mathMindIA-mathMindIA\76132eb8-9725-46ba-b08d-38440d8187a1\scratchpad\screenshots\01-login.png"/>
           <p:cNvPicPr>
             <a:picLocks noChangeAspect="1"/>
           </p:cNvPicPr>
           <p:nvPr/>
         </p:nvPicPr>
         <p:blipFill>
-          <a:blip r:embed="rId1"/>
+          <a:blip r:embed="rId3"/>
           <a:stretch>
             <a:fillRect/>
           </a:stretch>
@@ -7824,7 +8703,7 @@
           <a:bodyPr wrap="square" rtlCol="0" anchor="ctr"/>
           <a:lstStyle/>
           <a:p>
-            <a:pPr algn="ctr" indent="0" marL="0">
+            <a:pPr marL="0" indent="0" algn="ctr">
               <a:buNone/>
             </a:pPr>
             <a:r>
@@ -7969,7 +8848,7 @@
           <a:bodyPr wrap="square" rtlCol="0" anchor="ctr"/>
           <a:lstStyle/>
           <a:p>
-            <a:pPr indent="0" marL="0">
+            <a:pPr marL="0" indent="0">
               <a:buNone/>
             </a:pPr>
             <a:r>
@@ -8008,7 +8887,7 @@
           <a:bodyPr wrap="square" rtlCol="0" anchor="ctr"/>
           <a:lstStyle/>
           <a:p>
-            <a:pPr algn="r" indent="0" marL="0">
+            <a:pPr marL="0" indent="0" algn="r">
               <a:buNone/>
             </a:pPr>
             <a:r>
@@ -8042,6 +8921,7 @@
         <a:solidFill>
           <a:srgbClr val="F7F9FC"/>
         </a:solidFill>
+        <a:effectLst/>
       </p:bgPr>
     </p:bg>
     <p:spTree>
@@ -8077,6 +8957,13 @@
           </a:solidFill>
           <a:ln/>
         </p:spPr>
+        <p:txBody>
+          <a:bodyPr/>
+          <a:lstStyle/>
+          <a:p>
+            <a:endParaRPr lang="es-ES"/>
+          </a:p>
+        </p:txBody>
       </p:sp>
       <p:sp>
         <p:nvSpPr>
@@ -8099,11 +8986,11 @@
           <a:bodyPr wrap="square" rtlCol="0" anchor="ctr"/>
           <a:lstStyle/>
           <a:p>
-            <a:pPr indent="0" marL="0">
+            <a:pPr marL="0" indent="0">
               <a:buNone/>
             </a:pPr>
             <a:r>
-              <a:rPr lang="en-US" sz="1200" b="1" spc="200" kern="0" dirty="0">
+              <a:rPr lang="en-US" sz="1200" b="1" kern="0" spc="200" dirty="0">
                 <a:solidFill>
                   <a:srgbClr val="4CC9F0"/>
                 </a:solidFill>
@@ -8138,7 +9025,7 @@
           <a:bodyPr wrap="square" rtlCol="0" anchor="ctr"/>
           <a:lstStyle/>
           <a:p>
-            <a:pPr indent="0" marL="0">
+            <a:pPr marL="0" indent="0">
               <a:buNone/>
             </a:pPr>
             <a:r>
@@ -8178,6 +9065,13 @@
             <a:prstDash val="solid"/>
           </a:ln>
         </p:spPr>
+        <p:txBody>
+          <a:bodyPr/>
+          <a:lstStyle/>
+          <a:p>
+            <a:endParaRPr lang="es-ES"/>
+          </a:p>
+        </p:txBody>
       </p:sp>
       <p:sp>
         <p:nvSpPr>
@@ -8205,24 +9099,31 @@
             <a:prstDash val="solid"/>
           </a:ln>
           <a:effectLst>
-            <a:outerShdw sx="100000" sy="100000" kx="0" ky="0" algn="bl" rotWithShape="0" blurRad="101600" dist="38100" dir="5400000">
+            <a:outerShdw blurRad="101600" dist="38100" dir="5400000" algn="bl" rotWithShape="0">
               <a:srgbClr val="000000">
                 <a:alpha val="25000"/>
               </a:srgbClr>
             </a:outerShdw>
           </a:effectLst>
         </p:spPr>
+        <p:txBody>
+          <a:bodyPr/>
+          <a:lstStyle/>
+          <a:p>
+            <a:endParaRPr lang="es-ES"/>
+          </a:p>
+        </p:txBody>
       </p:sp>
       <p:pic>
         <p:nvPicPr>
-          <p:cNvPr id="7" name="Image 0" descr="C:\Users\ruben.abad\AppData\Local\Temp\claude\c--Users-ruben-abad-Documents-CUrsoIA-PFM-mathMindIA-mathMindIA\76132eb8-9725-46ba-b08d-38440d8187a1\scratchpad\screenshots\04-session-test.png">    </p:cNvPr>
+          <p:cNvPr id="7" name="Image 0" descr="C:\Users\ruben.abad\AppData\Local\Temp\claude\c--Users-ruben-abad-Documents-CUrsoIA-PFM-mathMindIA-mathMindIA\76132eb8-9725-46ba-b08d-38440d8187a1\scratchpad\screenshots\04-session-test.png"/>
           <p:cNvPicPr>
             <a:picLocks noChangeAspect="1"/>
           </p:cNvPicPr>
           <p:nvPr/>
         </p:nvPicPr>
         <p:blipFill>
-          <a:blip r:embed="rId1"/>
+          <a:blip r:embed="rId3"/>
           <a:stretch>
             <a:fillRect/>
           </a:stretch>
@@ -8258,7 +9159,7 @@
           <a:bodyPr wrap="square" rtlCol="0" anchor="ctr"/>
           <a:lstStyle/>
           <a:p>
-            <a:pPr algn="ctr" indent="0" marL="0">
+            <a:pPr marL="0" indent="0" algn="ctr">
               <a:buNone/>
             </a:pPr>
             <a:r>
@@ -8382,7 +9283,7 @@
           <a:bodyPr wrap="square" rtlCol="0" anchor="ctr"/>
           <a:lstStyle/>
           <a:p>
-            <a:pPr indent="0" marL="0">
+            <a:pPr marL="0" indent="0">
               <a:buNone/>
             </a:pPr>
             <a:r>
@@ -8421,7 +9322,7 @@
           <a:bodyPr wrap="square" rtlCol="0" anchor="ctr"/>
           <a:lstStyle/>
           <a:p>
-            <a:pPr algn="r" indent="0" marL="0">
+            <a:pPr marL="0" indent="0" algn="r">
               <a:buNone/>
             </a:pPr>
             <a:r>
@@ -8455,6 +9356,7 @@
         <a:solidFill>
           <a:srgbClr val="F7F9FC"/>
         </a:solidFill>
+        <a:effectLst/>
       </p:bgPr>
     </p:bg>
     <p:spTree>
@@ -8490,6 +9392,13 @@
           </a:solidFill>
           <a:ln/>
         </p:spPr>
+        <p:txBody>
+          <a:bodyPr/>
+          <a:lstStyle/>
+          <a:p>
+            <a:endParaRPr lang="es-ES"/>
+          </a:p>
+        </p:txBody>
       </p:sp>
       <p:sp>
         <p:nvSpPr>
@@ -8512,11 +9421,11 @@
           <a:bodyPr wrap="square" rtlCol="0" anchor="ctr"/>
           <a:lstStyle/>
           <a:p>
-            <a:pPr indent="0" marL="0">
+            <a:pPr marL="0" indent="0">
               <a:buNone/>
             </a:pPr>
             <a:r>
-              <a:rPr lang="en-US" sz="1200" b="1" spc="200" kern="0" dirty="0">
+              <a:rPr lang="en-US" sz="1200" b="1" kern="0" spc="200" dirty="0">
                 <a:solidFill>
                   <a:srgbClr val="4CC9F0"/>
                 </a:solidFill>
@@ -8551,7 +9460,7 @@
           <a:bodyPr wrap="square" rtlCol="0" anchor="ctr"/>
           <a:lstStyle/>
           <a:p>
-            <a:pPr indent="0" marL="0">
+            <a:pPr marL="0" indent="0">
               <a:buNone/>
             </a:pPr>
             <a:r>
@@ -8591,6 +9500,13 @@
             <a:prstDash val="solid"/>
           </a:ln>
         </p:spPr>
+        <p:txBody>
+          <a:bodyPr/>
+          <a:lstStyle/>
+          <a:p>
+            <a:endParaRPr lang="es-ES"/>
+          </a:p>
+        </p:txBody>
       </p:sp>
       <p:sp>
         <p:nvSpPr>
@@ -8618,24 +9534,31 @@
             <a:prstDash val="solid"/>
           </a:ln>
           <a:effectLst>
-            <a:outerShdw sx="100000" sy="100000" kx="0" ky="0" algn="bl" rotWithShape="0" blurRad="101600" dist="38100" dir="5400000">
+            <a:outerShdw blurRad="101600" dist="38100" dir="5400000" algn="bl" rotWithShape="0">
               <a:srgbClr val="000000">
                 <a:alpha val="25000"/>
               </a:srgbClr>
             </a:outerShdw>
           </a:effectLst>
         </p:spPr>
+        <p:txBody>
+          <a:bodyPr/>
+          <a:lstStyle/>
+          <a:p>
+            <a:endParaRPr lang="es-ES"/>
+          </a:p>
+        </p:txBody>
       </p:sp>
       <p:pic>
         <p:nvPicPr>
-          <p:cNvPr id="7" name="Image 0" descr="C:\Users\ruben.abad\AppData\Local\Temp\claude\c--Users-ruben-abad-Documents-CUrsoIA-PFM-mathMindIA-mathMindIA\76132eb8-9725-46ba-b08d-38440d8187a1\scratchpad\screenshots\03b-home-relleno.png">    </p:cNvPr>
+          <p:cNvPr id="7" name="Image 0" descr="C:\Users\ruben.abad\AppData\Local\Temp\claude\c--Users-ruben-abad-Documents-CUrsoIA-PFM-mathMindIA-mathMindIA\76132eb8-9725-46ba-b08d-38440d8187a1\scratchpad\screenshots\03b-home-relleno.png"/>
           <p:cNvPicPr>
             <a:picLocks noChangeAspect="1"/>
           </p:cNvPicPr>
           <p:nvPr/>
         </p:nvPicPr>
         <p:blipFill>
-          <a:blip r:embed="rId1"/>
+          <a:blip r:embed="rId3"/>
           <a:stretch>
             <a:fillRect/>
           </a:stretch>
@@ -8671,7 +9594,7 @@
           <a:bodyPr wrap="square" rtlCol="0" anchor="ctr"/>
           <a:lstStyle/>
           <a:p>
-            <a:pPr algn="ctr" indent="0" marL="0">
+            <a:pPr marL="0" indent="0" algn="ctr">
               <a:buNone/>
             </a:pPr>
             <a:r>
@@ -8715,24 +9638,31 @@
             <a:prstDash val="solid"/>
           </a:ln>
           <a:effectLst>
-            <a:outerShdw sx="100000" sy="100000" kx="0" ky="0" algn="bl" rotWithShape="0" blurRad="101600" dist="38100" dir="5400000">
+            <a:outerShdw blurRad="101600" dist="38100" dir="5400000" algn="bl" rotWithShape="0">
               <a:srgbClr val="000000">
                 <a:alpha val="25000"/>
               </a:srgbClr>
             </a:outerShdw>
           </a:effectLst>
         </p:spPr>
+        <p:txBody>
+          <a:bodyPr/>
+          <a:lstStyle/>
+          <a:p>
+            <a:endParaRPr lang="es-ES"/>
+          </a:p>
+        </p:txBody>
       </p:sp>
       <p:pic>
         <p:nvPicPr>
-          <p:cNvPr id="10" name="Image 1" descr="C:\Users\ruben.abad\AppData\Local\Temp\claude\c--Users-ruben-abad-Documents-CUrsoIA-PFM-mathMindIA-mathMindIA\76132eb8-9725-46ba-b08d-38440d8187a1\scratchpad\screenshots\06-resumen.png">    </p:cNvPr>
+          <p:cNvPr id="10" name="Image 1" descr="C:\Users\ruben.abad\AppData\Local\Temp\claude\c--Users-ruben-abad-Documents-CUrsoIA-PFM-mathMindIA-mathMindIA\76132eb8-9725-46ba-b08d-38440d8187a1\scratchpad\screenshots\06-resumen.png"/>
           <p:cNvPicPr>
             <a:picLocks noChangeAspect="1"/>
           </p:cNvPicPr>
           <p:nvPr/>
         </p:nvPicPr>
         <p:blipFill>
-          <a:blip r:embed="rId2"/>
+          <a:blip r:embed="rId4"/>
           <a:stretch>
             <a:fillRect/>
           </a:stretch>
@@ -8768,7 +9698,7 @@
           <a:bodyPr wrap="square" rtlCol="0" anchor="ctr"/>
           <a:lstStyle/>
           <a:p>
-            <a:pPr algn="ctr" indent="0" marL="0">
+            <a:pPr marL="0" indent="0" algn="ctr">
               <a:buNone/>
             </a:pPr>
             <a:r>
@@ -8812,24 +9742,31 @@
             <a:prstDash val="solid"/>
           </a:ln>
           <a:effectLst>
-            <a:outerShdw sx="100000" sy="100000" kx="0" ky="0" algn="bl" rotWithShape="0" blurRad="101600" dist="38100" dir="5400000">
+            <a:outerShdw blurRad="101600" dist="38100" dir="5400000" algn="bl" rotWithShape="0">
               <a:srgbClr val="000000">
                 <a:alpha val="25000"/>
               </a:srgbClr>
             </a:outerShdw>
           </a:effectLst>
         </p:spPr>
+        <p:txBody>
+          <a:bodyPr/>
+          <a:lstStyle/>
+          <a:p>
+            <a:endParaRPr lang="es-ES"/>
+          </a:p>
+        </p:txBody>
       </p:sp>
       <p:pic>
         <p:nvPicPr>
-          <p:cNvPr id="13" name="Image 2" descr="C:\Users\ruben.abad\AppData\Local\Temp\claude\c--Users-ruben-abad-Documents-CUrsoIA-PFM-mathMindIA-mathMindIA\76132eb8-9725-46ba-b08d-38440d8187a1\scratchpad\screenshots\05b-statistics-con-datos.png">    </p:cNvPr>
+          <p:cNvPr id="13" name="Image 2" descr="C:\Users\ruben.abad\AppData\Local\Temp\claude\c--Users-ruben-abad-Documents-CUrsoIA-PFM-mathMindIA-mathMindIA\76132eb8-9725-46ba-b08d-38440d8187a1\scratchpad\screenshots\05b-statistics-con-datos.png"/>
           <p:cNvPicPr>
             <a:picLocks noChangeAspect="1"/>
           </p:cNvPicPr>
           <p:nvPr/>
         </p:nvPicPr>
         <p:blipFill>
-          <a:blip r:embed="rId3"/>
+          <a:blip r:embed="rId5"/>
           <a:stretch>
             <a:fillRect/>
           </a:stretch>
@@ -8865,7 +9802,7 @@
           <a:bodyPr wrap="square" rtlCol="0" anchor="ctr"/>
           <a:lstStyle/>
           <a:p>
-            <a:pPr algn="ctr" indent="0" marL="0">
+            <a:pPr marL="0" indent="0" algn="ctr">
               <a:buNone/>
             </a:pPr>
             <a:r>
@@ -8904,7 +9841,7 @@
           <a:bodyPr wrap="square" rtlCol="0" anchor="ctr"/>
           <a:lstStyle/>
           <a:p>
-            <a:pPr indent="0" marL="0">
+            <a:pPr marL="0" indent="0">
               <a:buNone/>
             </a:pPr>
             <a:r>
@@ -8943,7 +9880,7 @@
           <a:bodyPr wrap="square" rtlCol="0" anchor="ctr"/>
           <a:lstStyle/>
           <a:p>
-            <a:pPr algn="r" indent="0" marL="0">
+            <a:pPr marL="0" indent="0" algn="r">
               <a:buNone/>
             </a:pPr>
             <a:r>
@@ -8977,6 +9914,7 @@
         <a:solidFill>
           <a:srgbClr val="F7F9FC"/>
         </a:solidFill>
+        <a:effectLst/>
       </p:bgPr>
     </p:bg>
     <p:spTree>
@@ -9012,6 +9950,13 @@
           </a:solidFill>
           <a:ln/>
         </p:spPr>
+        <p:txBody>
+          <a:bodyPr/>
+          <a:lstStyle/>
+          <a:p>
+            <a:endParaRPr lang="es-ES"/>
+          </a:p>
+        </p:txBody>
       </p:sp>
       <p:sp>
         <p:nvSpPr>
@@ -9034,11 +9979,11 @@
           <a:bodyPr wrap="square" rtlCol="0" anchor="ctr"/>
           <a:lstStyle/>
           <a:p>
-            <a:pPr indent="0" marL="0">
+            <a:pPr marL="0" indent="0">
               <a:buNone/>
             </a:pPr>
             <a:r>
-              <a:rPr lang="en-US" sz="1200" b="1" spc="200" kern="0" dirty="0">
+              <a:rPr lang="en-US" sz="1200" b="1" kern="0" spc="200" dirty="0">
                 <a:solidFill>
                   <a:srgbClr val="4CC9F0"/>
                 </a:solidFill>
@@ -9073,7 +10018,7 @@
           <a:bodyPr wrap="square" rtlCol="0" anchor="ctr"/>
           <a:lstStyle/>
           <a:p>
-            <a:pPr indent="0" marL="0">
+            <a:pPr marL="0" indent="0">
               <a:buNone/>
             </a:pPr>
             <a:r>
@@ -9113,6 +10058,13 @@
             <a:prstDash val="solid"/>
           </a:ln>
         </p:spPr>
+        <p:txBody>
+          <a:bodyPr/>
+          <a:lstStyle/>
+          <a:p>
+            <a:endParaRPr lang="es-ES"/>
+          </a:p>
+        </p:txBody>
       </p:sp>
       <p:sp>
         <p:nvSpPr>
@@ -9241,7 +10193,7 @@
           <a:bodyPr wrap="square" rtlCol="0" anchor="ctr"/>
           <a:lstStyle/>
           <a:p>
-            <a:pPr indent="0" marL="0">
+            <a:pPr marL="0" indent="0">
               <a:buNone/>
             </a:pPr>
             <a:r>
@@ -9280,7 +10232,7 @@
           <a:bodyPr wrap="square" rtlCol="0" anchor="ctr"/>
           <a:lstStyle/>
           <a:p>
-            <a:pPr algn="r" indent="0" marL="0">
+            <a:pPr marL="0" indent="0" algn="r">
               <a:buNone/>
             </a:pPr>
             <a:r>
@@ -9314,6 +10266,7 @@
         <a:solidFill>
           <a:srgbClr val="F7F9FC"/>
         </a:solidFill>
+        <a:effectLst/>
       </p:bgPr>
     </p:bg>
     <p:spTree>
@@ -9349,6 +10302,13 @@
           </a:solidFill>
           <a:ln/>
         </p:spPr>
+        <p:txBody>
+          <a:bodyPr/>
+          <a:lstStyle/>
+          <a:p>
+            <a:endParaRPr lang="es-ES"/>
+          </a:p>
+        </p:txBody>
       </p:sp>
       <p:sp>
         <p:nvSpPr>
@@ -9371,11 +10331,11 @@
           <a:bodyPr wrap="square" rtlCol="0" anchor="ctr"/>
           <a:lstStyle/>
           <a:p>
-            <a:pPr indent="0" marL="0">
+            <a:pPr marL="0" indent="0">
               <a:buNone/>
             </a:pPr>
             <a:r>
-              <a:rPr lang="en-US" sz="1200" b="1" spc="200" kern="0" dirty="0">
+              <a:rPr lang="en-US" sz="1200" b="1" kern="0" spc="200" dirty="0">
                 <a:solidFill>
                   <a:srgbClr val="4CC9F0"/>
                 </a:solidFill>
@@ -9410,7 +10370,7 @@
           <a:bodyPr wrap="square" rtlCol="0" anchor="ctr"/>
           <a:lstStyle/>
           <a:p>
-            <a:pPr indent="0" marL="0">
+            <a:pPr marL="0" indent="0">
               <a:buNone/>
             </a:pPr>
             <a:r>
@@ -9450,6 +10410,13 @@
             <a:prstDash val="solid"/>
           </a:ln>
         </p:spPr>
+        <p:txBody>
+          <a:bodyPr/>
+          <a:lstStyle/>
+          <a:p>
+            <a:endParaRPr lang="es-ES"/>
+          </a:p>
+        </p:txBody>
       </p:sp>
       <p:sp>
         <p:nvSpPr>
@@ -9578,7 +10545,7 @@
           <a:bodyPr wrap="square" rtlCol="0" anchor="ctr"/>
           <a:lstStyle/>
           <a:p>
-            <a:pPr indent="0" marL="0">
+            <a:pPr marL="0" indent="0">
               <a:buNone/>
             </a:pPr>
             <a:r>
@@ -9617,7 +10584,7 @@
           <a:bodyPr wrap="square" rtlCol="0" anchor="ctr"/>
           <a:lstStyle/>
           <a:p>
-            <a:pPr algn="r" indent="0" marL="0">
+            <a:pPr marL="0" indent="0" algn="r">
               <a:buNone/>
             </a:pPr>
             <a:r>
@@ -9651,6 +10618,7 @@
         <a:solidFill>
           <a:srgbClr val="F7F9FC"/>
         </a:solidFill>
+        <a:effectLst/>
       </p:bgPr>
     </p:bg>
     <p:spTree>
@@ -9686,6 +10654,13 @@
           </a:solidFill>
           <a:ln/>
         </p:spPr>
+        <p:txBody>
+          <a:bodyPr/>
+          <a:lstStyle/>
+          <a:p>
+            <a:endParaRPr lang="es-ES"/>
+          </a:p>
+        </p:txBody>
       </p:sp>
       <p:sp>
         <p:nvSpPr>
@@ -9708,11 +10683,11 @@
           <a:bodyPr wrap="square" rtlCol="0" anchor="ctr"/>
           <a:lstStyle/>
           <a:p>
-            <a:pPr indent="0" marL="0">
+            <a:pPr marL="0" indent="0">
               <a:buNone/>
             </a:pPr>
             <a:r>
-              <a:rPr lang="en-US" sz="1200" b="1" spc="200" kern="0" dirty="0">
+              <a:rPr lang="en-US" sz="1200" b="1" kern="0" spc="200" dirty="0">
                 <a:solidFill>
                   <a:srgbClr val="4CC9F0"/>
                 </a:solidFill>
@@ -9747,7 +10722,7 @@
           <a:bodyPr wrap="square" rtlCol="0" anchor="ctr"/>
           <a:lstStyle/>
           <a:p>
-            <a:pPr indent="0" marL="0">
+            <a:pPr marL="0" indent="0">
               <a:buNone/>
             </a:pPr>
             <a:r>
@@ -9787,6 +10762,13 @@
             <a:prstDash val="solid"/>
           </a:ln>
         </p:spPr>
+        <p:txBody>
+          <a:bodyPr/>
+          <a:lstStyle/>
+          <a:p>
+            <a:endParaRPr lang="es-ES"/>
+          </a:p>
+        </p:txBody>
       </p:sp>
       <p:sp>
         <p:nvSpPr>
@@ -9915,7 +10897,7 @@
           <a:bodyPr wrap="square" rtlCol="0" anchor="ctr"/>
           <a:lstStyle/>
           <a:p>
-            <a:pPr indent="0" marL="0">
+            <a:pPr marL="0" indent="0">
               <a:buNone/>
             </a:pPr>
             <a:r>
@@ -9954,7 +10936,7 @@
           <a:bodyPr wrap="square" rtlCol="0" anchor="ctr"/>
           <a:lstStyle/>
           <a:p>
-            <a:pPr algn="r" indent="0" marL="0">
+            <a:pPr marL="0" indent="0" algn="r">
               <a:buNone/>
             </a:pPr>
             <a:r>
@@ -9988,6 +10970,7 @@
         <a:solidFill>
           <a:srgbClr val="F7F9FC"/>
         </a:solidFill>
+        <a:effectLst/>
       </p:bgPr>
     </p:bg>
     <p:spTree>
@@ -10023,6 +11006,13 @@
           </a:solidFill>
           <a:ln/>
         </p:spPr>
+        <p:txBody>
+          <a:bodyPr/>
+          <a:lstStyle/>
+          <a:p>
+            <a:endParaRPr lang="es-ES"/>
+          </a:p>
+        </p:txBody>
       </p:sp>
       <p:sp>
         <p:nvSpPr>
@@ -10045,11 +11035,11 @@
           <a:bodyPr wrap="square" rtlCol="0" anchor="ctr"/>
           <a:lstStyle/>
           <a:p>
-            <a:pPr indent="0" marL="0">
+            <a:pPr marL="0" indent="0">
               <a:buNone/>
             </a:pPr>
             <a:r>
-              <a:rPr lang="en-US" sz="1200" b="1" spc="200" kern="0" dirty="0">
+              <a:rPr lang="en-US" sz="1200" b="1" kern="0" spc="200" dirty="0">
                 <a:solidFill>
                   <a:srgbClr val="A855F7"/>
                 </a:solidFill>
@@ -10084,7 +11074,7 @@
           <a:bodyPr wrap="square" rtlCol="0" anchor="ctr"/>
           <a:lstStyle/>
           <a:p>
-            <a:pPr indent="0" marL="0">
+            <a:pPr marL="0" indent="0">
               <a:buNone/>
             </a:pPr>
             <a:r>
@@ -10124,6 +11114,13 @@
             <a:prstDash val="solid"/>
           </a:ln>
         </p:spPr>
+        <p:txBody>
+          <a:bodyPr/>
+          <a:lstStyle/>
+          <a:p>
+            <a:endParaRPr lang="es-ES"/>
+          </a:p>
+        </p:txBody>
       </p:sp>
       <p:sp>
         <p:nvSpPr>
@@ -10252,7 +11249,7 @@
           <a:bodyPr wrap="square" rtlCol="0" anchor="ctr"/>
           <a:lstStyle/>
           <a:p>
-            <a:pPr indent="0" marL="0">
+            <a:pPr marL="0" indent="0">
               <a:buNone/>
             </a:pPr>
             <a:r>
@@ -10291,7 +11288,7 @@
           <a:bodyPr wrap="square" rtlCol="0" anchor="ctr"/>
           <a:lstStyle/>
           <a:p>
-            <a:pPr algn="r" indent="0" marL="0">
+            <a:pPr marL="0" indent="0" algn="r">
               <a:buNone/>
             </a:pPr>
             <a:r>
@@ -10610,4 +11607,319 @@
     </a:ext>
   </a:extLst>
 </a:theme>
+</file>
+
+<file path=ppt/theme/theme2.xml><?xml version="1.0" encoding="utf-8"?>
+<a:theme xmlns:a="http://schemas.openxmlformats.org/drawingml/2006/main" name="Tema de Office">
+  <a:themeElements>
+    <a:clrScheme name="Office">
+      <a:dk1>
+        <a:sysClr val="windowText" lastClr="000000"/>
+      </a:dk1>
+      <a:lt1>
+        <a:sysClr val="window" lastClr="FFFFFF"/>
+      </a:lt1>
+      <a:dk2>
+        <a:srgbClr val="0E2841"/>
+      </a:dk2>
+      <a:lt2>
+        <a:srgbClr val="E8E8E8"/>
+      </a:lt2>
+      <a:accent1>
+        <a:srgbClr val="156082"/>
+      </a:accent1>
+      <a:accent2>
+        <a:srgbClr val="E97132"/>
+      </a:accent2>
+      <a:accent3>
+        <a:srgbClr val="196B24"/>
+      </a:accent3>
+      <a:accent4>
+        <a:srgbClr val="0F9ED5"/>
+      </a:accent4>
+      <a:accent5>
+        <a:srgbClr val="A02B93"/>
+      </a:accent5>
+      <a:accent6>
+        <a:srgbClr val="4EA72E"/>
+      </a:accent6>
+      <a:hlink>
+        <a:srgbClr val="467886"/>
+      </a:hlink>
+      <a:folHlink>
+        <a:srgbClr val="96607D"/>
+      </a:folHlink>
+    </a:clrScheme>
+    <a:fontScheme name="Office">
+      <a:majorFont>
+        <a:latin typeface="Aptos Display" panose="02110004020202020204"/>
+        <a:ea typeface=""/>
+        <a:cs typeface=""/>
+        <a:font script="Jpan" typeface="游ゴシック Light"/>
+        <a:font script="Hang" typeface="맑은 고딕"/>
+        <a:font script="Hans" typeface="等线 Light"/>
+        <a:font script="Hant" typeface="新細明體"/>
+        <a:font script="Arab" typeface="Times New Roman"/>
+        <a:font script="Hebr" typeface="Times New Roman"/>
+        <a:font script="Thai" typeface="Angsana New"/>
+        <a:font script="Ethi" typeface="Nyala"/>
+        <a:font script="Beng" typeface="Vrinda"/>
+        <a:font script="Gujr" typeface="Shruti"/>
+        <a:font script="Khmr" typeface="MoolBoran"/>
+        <a:font script="Knda" typeface="Tunga"/>
+        <a:font script="Guru" typeface="Raavi"/>
+        <a:font script="Cans" typeface="Euphemia"/>
+        <a:font script="Cher" typeface="Plantagenet Cherokee"/>
+        <a:font script="Yiii" typeface="Microsoft Yi Baiti"/>
+        <a:font script="Tibt" typeface="Microsoft Himalaya"/>
+        <a:font script="Thaa" typeface="MV Boli"/>
+        <a:font script="Deva" typeface="Mangal"/>
+        <a:font script="Telu" typeface="Gautami"/>
+        <a:font script="Taml" typeface="Latha"/>
+        <a:font script="Syrc" typeface="Estrangelo Edessa"/>
+        <a:font script="Orya" typeface="Kalinga"/>
+        <a:font script="Mlym" typeface="Kartika"/>
+        <a:font script="Laoo" typeface="DokChampa"/>
+        <a:font script="Sinh" typeface="Iskoola Pota"/>
+        <a:font script="Mong" typeface="Mongolian Baiti"/>
+        <a:font script="Viet" typeface="Times New Roman"/>
+        <a:font script="Uigh" typeface="Microsoft Uighur"/>
+        <a:font script="Geor" typeface="Sylfaen"/>
+        <a:font script="Armn" typeface="Arial"/>
+        <a:font script="Bugi" typeface="Leelawadee UI"/>
+        <a:font script="Bopo" typeface="Microsoft JhengHei"/>
+        <a:font script="Java" typeface="Javanese Text"/>
+        <a:font script="Lisu" typeface="Segoe UI"/>
+        <a:font script="Mymr" typeface="Myanmar Text"/>
+        <a:font script="Nkoo" typeface="Ebrima"/>
+        <a:font script="Olck" typeface="Nirmala UI"/>
+        <a:font script="Osma" typeface="Ebrima"/>
+        <a:font script="Phag" typeface="Phagspa"/>
+        <a:font script="Syrn" typeface="Estrangelo Edessa"/>
+        <a:font script="Syrj" typeface="Estrangelo Edessa"/>
+        <a:font script="Syre" typeface="Estrangelo Edessa"/>
+        <a:font script="Sora" typeface="Nirmala UI"/>
+        <a:font script="Tale" typeface="Microsoft Tai Le"/>
+        <a:font script="Talu" typeface="Microsoft New Tai Lue"/>
+        <a:font script="Tfng" typeface="Ebrima"/>
+      </a:majorFont>
+      <a:minorFont>
+        <a:latin typeface="Aptos" panose="02110004020202020204"/>
+        <a:ea typeface=""/>
+        <a:cs typeface=""/>
+        <a:font script="Jpan" typeface="游ゴシック"/>
+        <a:font script="Hang" typeface="맑은 고딕"/>
+        <a:font script="Hans" typeface="等线"/>
+        <a:font script="Hant" typeface="新細明體"/>
+        <a:font script="Arab" typeface="Arial"/>
+        <a:font script="Hebr" typeface="Arial"/>
+        <a:font script="Thai" typeface="Cordia New"/>
+        <a:font script="Ethi" typeface="Nyala"/>
+        <a:font script="Beng" typeface="Vrinda"/>
+        <a:font script="Gujr" typeface="Shruti"/>
+        <a:font script="Khmr" typeface="DaunPenh"/>
+        <a:font script="Knda" typeface="Tunga"/>
+        <a:font script="Guru" typeface="Raavi"/>
+        <a:font script="Cans" typeface="Euphemia"/>
+        <a:font script="Cher" typeface="Plantagenet Cherokee"/>
+        <a:font script="Yiii" typeface="Microsoft Yi Baiti"/>
+        <a:font script="Tibt" typeface="Microsoft Himalaya"/>
+        <a:font script="Thaa" typeface="MV Boli"/>
+        <a:font script="Deva" typeface="Mangal"/>
+        <a:font script="Telu" typeface="Gautami"/>
+        <a:font script="Taml" typeface="Latha"/>
+        <a:font script="Syrc" typeface="Estrangelo Edessa"/>
+        <a:font script="Orya" typeface="Kalinga"/>
+        <a:font script="Mlym" typeface="Kartika"/>
+        <a:font script="Laoo" typeface="DokChampa"/>
+        <a:font script="Sinh" typeface="Iskoola Pota"/>
+        <a:font script="Mong" typeface="Mongolian Baiti"/>
+        <a:font script="Viet" typeface="Arial"/>
+        <a:font script="Uigh" typeface="Microsoft Uighur"/>
+        <a:font script="Geor" typeface="Sylfaen"/>
+        <a:font script="Armn" typeface="Arial"/>
+        <a:font script="Bugi" typeface="Leelawadee UI"/>
+        <a:font script="Bopo" typeface="Microsoft JhengHei"/>
+        <a:font script="Java" typeface="Javanese Text"/>
+        <a:font script="Lisu" typeface="Segoe UI"/>
+        <a:font script="Mymr" typeface="Myanmar Text"/>
+        <a:font script="Nkoo" typeface="Ebrima"/>
+        <a:font script="Olck" typeface="Nirmala UI"/>
+        <a:font script="Osma" typeface="Ebrima"/>
+        <a:font script="Phag" typeface="Phagspa"/>
+        <a:font script="Syrn" typeface="Estrangelo Edessa"/>
+        <a:font script="Syrj" typeface="Estrangelo Edessa"/>
+        <a:font script="Syre" typeface="Estrangelo Edessa"/>
+        <a:font script="Sora" typeface="Nirmala UI"/>
+        <a:font script="Tale" typeface="Microsoft Tai Le"/>
+        <a:font script="Talu" typeface="Microsoft New Tai Lue"/>
+        <a:font script="Tfng" typeface="Ebrima"/>
+      </a:minorFont>
+    </a:fontScheme>
+    <a:fmtScheme name="Office">
+      <a:fillStyleLst>
+        <a:solidFill>
+          <a:schemeClr val="phClr"/>
+        </a:solidFill>
+        <a:gradFill rotWithShape="1">
+          <a:gsLst>
+            <a:gs pos="0">
+              <a:schemeClr val="phClr">
+                <a:lumMod val="110000"/>
+                <a:satMod val="105000"/>
+                <a:tint val="67000"/>
+              </a:schemeClr>
+            </a:gs>
+            <a:gs pos="50000">
+              <a:schemeClr val="phClr">
+                <a:lumMod val="105000"/>
+                <a:satMod val="103000"/>
+                <a:tint val="73000"/>
+              </a:schemeClr>
+            </a:gs>
+            <a:gs pos="100000">
+              <a:schemeClr val="phClr">
+                <a:lumMod val="105000"/>
+                <a:satMod val="109000"/>
+                <a:tint val="81000"/>
+              </a:schemeClr>
+            </a:gs>
+          </a:gsLst>
+          <a:lin ang="5400000" scaled="0"/>
+        </a:gradFill>
+        <a:gradFill rotWithShape="1">
+          <a:gsLst>
+            <a:gs pos="0">
+              <a:schemeClr val="phClr">
+                <a:satMod val="103000"/>
+                <a:lumMod val="102000"/>
+                <a:tint val="94000"/>
+              </a:schemeClr>
+            </a:gs>
+            <a:gs pos="50000">
+              <a:schemeClr val="phClr">
+                <a:satMod val="110000"/>
+                <a:lumMod val="100000"/>
+                <a:shade val="100000"/>
+              </a:schemeClr>
+            </a:gs>
+            <a:gs pos="100000">
+              <a:schemeClr val="phClr">
+                <a:lumMod val="99000"/>
+                <a:satMod val="120000"/>
+                <a:shade val="78000"/>
+              </a:schemeClr>
+            </a:gs>
+          </a:gsLst>
+          <a:lin ang="5400000" scaled="0"/>
+        </a:gradFill>
+      </a:fillStyleLst>
+      <a:lnStyleLst>
+        <a:ln w="12700" cap="flat" cmpd="sng" algn="ctr">
+          <a:solidFill>
+            <a:schemeClr val="phClr"/>
+          </a:solidFill>
+          <a:prstDash val="solid"/>
+          <a:miter lim="800000"/>
+        </a:ln>
+        <a:ln w="19050" cap="flat" cmpd="sng" algn="ctr">
+          <a:solidFill>
+            <a:schemeClr val="phClr"/>
+          </a:solidFill>
+          <a:prstDash val="solid"/>
+          <a:miter lim="800000"/>
+        </a:ln>
+        <a:ln w="25400" cap="flat" cmpd="sng" algn="ctr">
+          <a:solidFill>
+            <a:schemeClr val="phClr"/>
+          </a:solidFill>
+          <a:prstDash val="solid"/>
+          <a:miter lim="800000"/>
+        </a:ln>
+      </a:lnStyleLst>
+      <a:effectStyleLst>
+        <a:effectStyle>
+          <a:effectLst/>
+        </a:effectStyle>
+        <a:effectStyle>
+          <a:effectLst/>
+        </a:effectStyle>
+        <a:effectStyle>
+          <a:effectLst>
+            <a:outerShdw blurRad="57150" dist="19050" dir="5400000" algn="ctr" rotWithShape="0">
+              <a:srgbClr val="000000">
+                <a:alpha val="63000"/>
+              </a:srgbClr>
+            </a:outerShdw>
+          </a:effectLst>
+        </a:effectStyle>
+      </a:effectStyleLst>
+      <a:bgFillStyleLst>
+        <a:solidFill>
+          <a:schemeClr val="phClr"/>
+        </a:solidFill>
+        <a:solidFill>
+          <a:schemeClr val="phClr">
+            <a:tint val="95000"/>
+            <a:satMod val="170000"/>
+          </a:schemeClr>
+        </a:solidFill>
+        <a:gradFill rotWithShape="1">
+          <a:gsLst>
+            <a:gs pos="0">
+              <a:schemeClr val="phClr">
+                <a:tint val="93000"/>
+                <a:satMod val="150000"/>
+                <a:shade val="98000"/>
+                <a:lumMod val="102000"/>
+              </a:schemeClr>
+            </a:gs>
+            <a:gs pos="50000">
+              <a:schemeClr val="phClr">
+                <a:tint val="98000"/>
+                <a:satMod val="130000"/>
+                <a:shade val="90000"/>
+                <a:lumMod val="103000"/>
+              </a:schemeClr>
+            </a:gs>
+            <a:gs pos="100000">
+              <a:schemeClr val="phClr">
+                <a:shade val="63000"/>
+                <a:satMod val="120000"/>
+              </a:schemeClr>
+            </a:gs>
+          </a:gsLst>
+          <a:lin ang="5400000" scaled="0"/>
+        </a:gradFill>
+      </a:bgFillStyleLst>
+    </a:fmtScheme>
+  </a:themeElements>
+  <a:objectDefaults>
+    <a:lnDef>
+      <a:spPr/>
+      <a:bodyPr/>
+      <a:lstStyle/>
+      <a:style>
+        <a:lnRef idx="2">
+          <a:schemeClr val="accent1"/>
+        </a:lnRef>
+        <a:fillRef idx="0">
+          <a:schemeClr val="accent1"/>
+        </a:fillRef>
+        <a:effectRef idx="1">
+          <a:schemeClr val="accent1"/>
+        </a:effectRef>
+        <a:fontRef idx="minor">
+          <a:schemeClr val="tx1"/>
+        </a:fontRef>
+      </a:style>
+    </a:lnDef>
+  </a:objectDefaults>
+  <a:extraClrSchemeLst/>
+  <a:extLst>
+    <a:ext uri="{05A4C25C-085E-4340-85A3-A5531E510DB2}">
+      <thm15:themeFamily xmlns:thm15="http://schemas.microsoft.com/office/thememl/2012/main" name="Office Theme" id="{2E142A2C-CD16-42D6-873A-C26D2A0506FA}" vid="{1BDDFF52-6CD6-40A5-AB3C-68EB2F1E4D0A}"/>
+    </a:ext>
+  </a:extLst>
+</a:theme>
 </file>
</xml_diff>